<commit_message>
title slide: replace version chip with date, add author Zaihua Ji
</commit_message>
<xml_diff>
--- a/docs/slides/dsupdt_guide.pptx
+++ b/docs/slides/dsupdt_guide.pptx
@@ -3305,7 +3305,7 @@
         <p:spPr>
           <a:xfrm>
             <a:off x="4762195" y="4892040"/>
-            <a:ext cx="2406701" cy="457200"/>
+            <a:ext cx="1600200" cy="457200"/>
           </a:xfrm>
           <a:prstGeom prst="roundRect">
             <a:avLst>
@@ -3332,7 +3332,7 @@
         <p:spPr>
           <a:xfrm>
             <a:off x="4762195" y="4892040"/>
-            <a:ext cx="2406701" cy="457200"/>
+            <a:ext cx="1600200" cy="457200"/>
           </a:xfrm>
           <a:prstGeom prst="rect">
             <a:avLst/>
@@ -3356,7 +3356,7 @@
                 <a:ea typeface="Calibri" pitchFamily="34" charset="-122"/>
                 <a:cs typeface="Calibri" pitchFamily="34" charset="-120"/>
               </a:rPr>
-              <a:t>rda_python_dsupdt v3.0.9</a:t>
+              <a:t>Updated 2026-07</a:t>
             </a:r>
             <a:endParaRPr lang="en-US" sz="1200" dirty="0"/>
           </a:p>
@@ -3365,6 +3365,59 @@
       <p:sp>
         <p:nvSpPr>
           <p:cNvPr id="16" name="Text 14"/>
+          <p:cNvSpPr/>
+          <p:nvPr/>
+        </p:nvSpPr>
+        <p:spPr>
+          <a:xfrm>
+            <a:off x="658368" y="5532120"/>
+            <a:ext cx="10058400" cy="365760"/>
+          </a:xfrm>
+          <a:prstGeom prst="rect">
+            <a:avLst/>
+          </a:prstGeom>
+          <a:noFill/>
+          <a:ln/>
+        </p:spPr>
+        <p:txBody>
+          <a:bodyPr wrap="square" lIns="0" tIns="0" rIns="0" bIns="0" rtlCol="0" anchor="ctr"/>
+          <a:lstStyle/>
+          <a:p>
+            <a:pPr indent="0" marL="0">
+              <a:buNone/>
+            </a:pPr>
+            <a:r>
+              <a:rPr lang="en-US" sz="1300" b="1" dirty="0">
+                <a:solidFill>
+                  <a:srgbClr val="8FB0C9"/>
+                </a:solidFill>
+                <a:latin typeface="Calibri" pitchFamily="34" charset="0"/>
+                <a:ea typeface="Calibri" pitchFamily="34" charset="-122"/>
+                <a:cs typeface="Calibri" pitchFamily="34" charset="-120"/>
+              </a:rPr>
+              <a:t>Zaihua Ji</a:t>
+            </a:r>
+            <a:pPr indent="0" marL="0">
+              <a:buNone/>
+            </a:pPr>
+            <a:r>
+              <a:rPr lang="en-US" sz="1300" dirty="0">
+                <a:solidFill>
+                  <a:srgbClr val="8FB0C9"/>
+                </a:solidFill>
+                <a:latin typeface="Calibri" pitchFamily="34" charset="0"/>
+                <a:ea typeface="Calibri" pitchFamily="34" charset="-122"/>
+                <a:cs typeface="Calibri" pitchFamily="34" charset="-120"/>
+              </a:rPr>
+              <a:t>   zji@ucar.edu</a:t>
+            </a:r>
+            <a:endParaRPr lang="en-US" sz="1300" dirty="0"/>
+          </a:p>
+        </p:txBody>
+      </p:sp>
+      <p:sp>
+        <p:nvSpPr>
+          <p:cNvPr id="17" name="Text 15"/>
           <p:cNvSpPr/>
           <p:nvPr/>
         </p:nvSpPr>

</xml_diff>

<commit_message>
temporal slide: add ControlTime (-CT) card explaining scheduled run time
Documents -CT/-FQ/-CO/-RI job-scheduling semantics, distinct from the
data-period timeline; reverts the earlier End Date "update time" wording.

Co-Authored-By: Claude Opus 4.6 <noreply@anthropic.com>
</commit_message>
<xml_diff>
--- a/docs/slides/dsupdt_guide.pptx
+++ b/docs/slides/dsupdt_guide.pptx
@@ -21341,8 +21341,8 @@
         </p:nvSpPr>
         <p:spPr>
           <a:xfrm>
-            <a:off x="3383280" y="1993392"/>
-            <a:ext cx="1828800" cy="274320"/>
+            <a:off x="3474720" y="1993392"/>
+            <a:ext cx="1645920" cy="274320"/>
           </a:xfrm>
           <a:prstGeom prst="rect">
             <a:avLst/>
@@ -21746,7 +21746,7 @@
         </p:nvSpPr>
         <p:spPr>
           <a:xfrm>
-            <a:off x="640080" y="4937760"/>
+            <a:off x="640080" y="4434840"/>
             <a:ext cx="201168" cy="201168"/>
           </a:xfrm>
           <a:prstGeom prst="ellipse">
@@ -21766,7 +21766,7 @@
         </p:nvSpPr>
         <p:spPr>
           <a:xfrm>
-            <a:off x="914400" y="4882896"/>
+            <a:off x="914400" y="4379976"/>
             <a:ext cx="2651760" cy="310896"/>
           </a:xfrm>
           <a:prstGeom prst="rect">
@@ -21805,7 +21805,7 @@
         </p:nvSpPr>
         <p:spPr>
           <a:xfrm>
-            <a:off x="3429000" y="4937760"/>
+            <a:off x="3429000" y="4434840"/>
             <a:ext cx="201168" cy="201168"/>
           </a:xfrm>
           <a:prstGeom prst="ellipse">
@@ -21825,7 +21825,7 @@
         </p:nvSpPr>
         <p:spPr>
           <a:xfrm>
-            <a:off x="3703320" y="4882896"/>
+            <a:off x="3703320" y="4379976"/>
             <a:ext cx="2651760" cy="310896"/>
           </a:xfrm>
           <a:prstGeom prst="rect">
@@ -21864,7 +21864,7 @@
         </p:nvSpPr>
         <p:spPr>
           <a:xfrm>
-            <a:off x="6217920" y="4937760"/>
+            <a:off x="6217920" y="4434840"/>
             <a:ext cx="201168" cy="201168"/>
           </a:xfrm>
           <a:prstGeom prst="ellipse">
@@ -21884,7 +21884,7 @@
         </p:nvSpPr>
         <p:spPr>
           <a:xfrm>
-            <a:off x="6492240" y="4882896"/>
+            <a:off x="6492240" y="4379976"/>
             <a:ext cx="2651760" cy="310896"/>
           </a:xfrm>
           <a:prstGeom prst="rect">
@@ -21923,7 +21923,7 @@
         </p:nvSpPr>
         <p:spPr>
           <a:xfrm>
-            <a:off x="9006840" y="4937760"/>
+            <a:off x="9006840" y="4434840"/>
             <a:ext cx="201168" cy="201168"/>
           </a:xfrm>
           <a:prstGeom prst="ellipse">
@@ -21948,7 +21948,7 @@
         </p:nvSpPr>
         <p:spPr>
           <a:xfrm>
-            <a:off x="9281160" y="4882896"/>
+            <a:off x="9281160" y="4379976"/>
             <a:ext cx="2651760" cy="310896"/>
           </a:xfrm>
           <a:prstGeom prst="rect">
@@ -21987,12 +21987,229 @@
         </p:nvSpPr>
         <p:spPr>
           <a:xfrm>
-            <a:off x="457200" y="5532120"/>
-            <a:ext cx="11274552" cy="640080"/>
+            <a:off x="457200" y="4846320"/>
+            <a:ext cx="11274552" cy="749808"/>
           </a:xfrm>
           <a:prstGeom prst="roundRect">
             <a:avLst>
-              <a:gd name="adj" fmla="val 11429"/>
+              <a:gd name="adj" fmla="val 9756"/>
+            </a:avLst>
+          </a:prstGeom>
+          <a:solidFill>
+            <a:srgbClr val="EEF4F8"/>
+          </a:solidFill>
+          <a:ln w="12700">
+            <a:solidFill>
+              <a:srgbClr val="065A82"/>
+            </a:solidFill>
+            <a:prstDash val="solid"/>
+          </a:ln>
+        </p:spPr>
+      </p:sp>
+      <p:sp>
+        <p:nvSpPr>
+          <p:cNvPr id="41" name="Text 39"/>
+          <p:cNvSpPr/>
+          <p:nvPr/>
+        </p:nvSpPr>
+        <p:spPr>
+          <a:xfrm>
+            <a:off x="658368" y="4910328"/>
+            <a:ext cx="10789920" cy="274320"/>
+          </a:xfrm>
+          <a:prstGeom prst="rect">
+            <a:avLst/>
+          </a:prstGeom>
+          <a:noFill/>
+          <a:ln/>
+        </p:spPr>
+        <p:txBody>
+          <a:bodyPr wrap="square" lIns="0" tIns="0" rIns="0" bIns="0" rtlCol="0" anchor="ctr"/>
+          <a:lstStyle/>
+          <a:p>
+            <a:pPr indent="0" marL="0">
+              <a:buNone/>
+            </a:pPr>
+            <a:r>
+              <a:rPr lang="en-US" sz="1250" b="1" dirty="0">
+                <a:solidFill>
+                  <a:srgbClr val="065A82"/>
+                </a:solidFill>
+                <a:latin typeface="Calibri" pitchFamily="34" charset="0"/>
+                <a:ea typeface="Calibri" pitchFamily="34" charset="-122"/>
+                <a:cs typeface="Calibri" pitchFamily="34" charset="-120"/>
+              </a:rPr>
+              <a:t>ControlTime  —  when the job itself runs</a:t>
+            </a:r>
+            <a:endParaRPr lang="en-US" sz="1250" dirty="0"/>
+          </a:p>
+        </p:txBody>
+      </p:sp>
+      <p:sp>
+        <p:nvSpPr>
+          <p:cNvPr id="42" name="Text 40"/>
+          <p:cNvSpPr/>
+          <p:nvPr/>
+        </p:nvSpPr>
+        <p:spPr>
+          <a:xfrm>
+            <a:off x="658368" y="5193792"/>
+            <a:ext cx="10881360" cy="365760"/>
+          </a:xfrm>
+          <a:prstGeom prst="rect">
+            <a:avLst/>
+          </a:prstGeom>
+          <a:noFill/>
+          <a:ln/>
+        </p:spPr>
+        <p:txBody>
+          <a:bodyPr wrap="square" lIns="0" tIns="0" rIns="0" bIns="0" rtlCol="0" anchor="ctr"/>
+          <a:lstStyle/>
+          <a:p>
+            <a:pPr indent="0" marL="0">
+              <a:buNone/>
+            </a:pPr>
+            <a:r>
+              <a:rPr lang="en-US" sz="1150" b="1" dirty="0">
+                <a:solidFill>
+                  <a:srgbClr val="065A82"/>
+                </a:solidFill>
+                <a:latin typeface="Courier New" pitchFamily="34" charset="0"/>
+                <a:ea typeface="Courier New" pitchFamily="34" charset="-122"/>
+                <a:cs typeface="Courier New" pitchFamily="34" charset="-120"/>
+              </a:rPr>
+              <a:t>-CT</a:t>
+            </a:r>
+            <a:pPr indent="0" marL="0">
+              <a:buNone/>
+            </a:pPr>
+            <a:r>
+              <a:rPr lang="en-US" sz="1150" dirty="0">
+                <a:solidFill>
+                  <a:srgbClr val="12212E"/>
+                </a:solidFill>
+                <a:latin typeface="Calibri" pitchFamily="34" charset="0"/>
+                <a:ea typeface="Calibri" pitchFamily="34" charset="-122"/>
+                <a:cs typeface="Calibri" pitchFamily="34" charset="-120"/>
+              </a:rPr>
+              <a:t> sets the scheduled run time (YYYY-MM-DD HH:NN:SS). After a success it advances by control </a:t>
+            </a:r>
+            <a:pPr indent="0" marL="0">
+              <a:buNone/>
+            </a:pPr>
+            <a:r>
+              <a:rPr lang="en-US" sz="1150" b="1" dirty="0">
+                <a:solidFill>
+                  <a:srgbClr val="065A82"/>
+                </a:solidFill>
+                <a:latin typeface="Courier New" pitchFamily="34" charset="0"/>
+                <a:ea typeface="Courier New" pitchFamily="34" charset="-122"/>
+                <a:cs typeface="Courier New" pitchFamily="34" charset="-120"/>
+              </a:rPr>
+              <a:t>-FQ</a:t>
+            </a:r>
+            <a:pPr indent="0" marL="0">
+              <a:buNone/>
+            </a:pPr>
+            <a:r>
+              <a:rPr lang="en-US" sz="1150" dirty="0">
+                <a:solidFill>
+                  <a:srgbClr val="12212E"/>
+                </a:solidFill>
+                <a:latin typeface="Calibri" pitchFamily="34" charset="0"/>
+                <a:ea typeface="Calibri" pitchFamily="34" charset="-122"/>
+                <a:cs typeface="Calibri" pitchFamily="34" charset="-120"/>
+              </a:rPr>
+              <a:t> + </a:t>
+            </a:r>
+            <a:pPr indent="0" marL="0">
+              <a:buNone/>
+            </a:pPr>
+            <a:r>
+              <a:rPr lang="en-US" sz="1150" b="1" dirty="0">
+                <a:solidFill>
+                  <a:srgbClr val="065A82"/>
+                </a:solidFill>
+                <a:latin typeface="Courier New" pitchFamily="34" charset="0"/>
+                <a:ea typeface="Courier New" pitchFamily="34" charset="-122"/>
+                <a:cs typeface="Courier New" pitchFamily="34" charset="-120"/>
+              </a:rPr>
+              <a:t>-CO</a:t>
+            </a:r>
+            <a:pPr indent="0" marL="0">
+              <a:buNone/>
+            </a:pPr>
+            <a:r>
+              <a:rPr lang="en-US" sz="1150" dirty="0">
+                <a:solidFill>
+                  <a:srgbClr val="12212E"/>
+                </a:solidFill>
+                <a:latin typeface="Calibri" pitchFamily="34" charset="0"/>
+                <a:ea typeface="Calibri" pitchFamily="34" charset="-122"/>
+                <a:cs typeface="Calibri" pitchFamily="34" charset="-120"/>
+              </a:rPr>
+              <a:t> offset; a failure retries after </a:t>
+            </a:r>
+            <a:pPr indent="0" marL="0">
+              <a:buNone/>
+            </a:pPr>
+            <a:r>
+              <a:rPr lang="en-US" sz="1150" b="1" dirty="0">
+                <a:solidFill>
+                  <a:srgbClr val="065A82"/>
+                </a:solidFill>
+                <a:latin typeface="Courier New" pitchFamily="34" charset="0"/>
+                <a:ea typeface="Courier New" pitchFamily="34" charset="-122"/>
+                <a:cs typeface="Courier New" pitchFamily="34" charset="-120"/>
+              </a:rPr>
+              <a:t>-RI</a:t>
+            </a:r>
+            <a:pPr indent="0" marL="0">
+              <a:buNone/>
+            </a:pPr>
+            <a:r>
+              <a:rPr lang="en-US" sz="1150" dirty="0">
+                <a:solidFill>
+                  <a:srgbClr val="12212E"/>
+                </a:solidFill>
+                <a:latin typeface="Calibri" pitchFamily="34" charset="0"/>
+                <a:ea typeface="Calibri" pitchFamily="34" charset="-122"/>
+                <a:cs typeface="Calibri" pitchFamily="34" charset="-120"/>
+              </a:rPr>
+              <a:t>.    e.g.  </a:t>
+            </a:r>
+            <a:pPr indent="0" marL="0">
+              <a:buNone/>
+            </a:pPr>
+            <a:r>
+              <a:rPr lang="en-US" sz="1150" dirty="0">
+                <a:solidFill>
+                  <a:srgbClr val="1C7293"/>
+                </a:solidFill>
+                <a:latin typeface="Courier New" pitchFamily="34" charset="0"/>
+                <a:ea typeface="Courier New" pitchFamily="34" charset="-122"/>
+                <a:cs typeface="Courier New" pitchFamily="34" charset="-120"/>
+              </a:rPr>
+              <a:t>dsupdt d609000 -SU -CT "2026-07-11 09:00:00" -FQ 1D -CO 9H</a:t>
+            </a:r>
+            <a:endParaRPr lang="en-US" sz="1150" dirty="0"/>
+          </a:p>
+        </p:txBody>
+      </p:sp>
+      <p:sp>
+        <p:nvSpPr>
+          <p:cNvPr id="43" name="Shape 41"/>
+          <p:cNvSpPr/>
+          <p:nvPr/>
+        </p:nvSpPr>
+        <p:spPr>
+          <a:xfrm>
+            <a:off x="457200" y="5705856"/>
+            <a:ext cx="11274552" cy="548640"/>
+          </a:xfrm>
+          <a:prstGeom prst="roundRect">
+            <a:avLst>
+              <a:gd name="adj" fmla="val 13333"/>
             </a:avLst>
           </a:prstGeom>
           <a:solidFill>
@@ -22008,14 +22225,14 @@
       </p:sp>
       <p:sp>
         <p:nvSpPr>
-          <p:cNvPr id="41" name="Text 39"/>
-          <p:cNvSpPr/>
-          <p:nvPr/>
-        </p:nvSpPr>
-        <p:spPr>
-          <a:xfrm>
-            <a:off x="685800" y="5532120"/>
-            <a:ext cx="10835640" cy="640080"/>
+          <p:cNvPr id="44" name="Text 42"/>
+          <p:cNvSpPr/>
+          <p:nvPr/>
+        </p:nvSpPr>
+        <p:spPr>
+          <a:xfrm>
+            <a:off x="685800" y="5705856"/>
+            <a:ext cx="10835640" cy="548640"/>
           </a:xfrm>
           <a:prstGeom prst="rect">
             <a:avLst/>
@@ -22034,7 +22251,7 @@
               <a:buNone/>
             </a:pPr>
             <a:r>
-              <a:rPr lang="en-US" sz="1200" b="1" dirty="0">
+              <a:rPr lang="en-US" sz="1150" b="1" dirty="0">
                 <a:solidFill>
                   <a:srgbClr val="065A82"/>
                 </a:solidFill>
@@ -22051,7 +22268,7 @@
               <a:buNone/>
             </a:pPr>
             <a:r>
-              <a:rPr lang="en-US" sz="1200" dirty="0">
+              <a:rPr lang="en-US" sz="1150" dirty="0">
                 <a:solidFill>
                   <a:srgbClr val="12212E"/>
                 </a:solidFill>
@@ -22068,7 +22285,7 @@
               <a:buNone/>
             </a:pPr>
             <a:r>
-              <a:rPr lang="en-US" sz="1200" i="1" dirty="0">
+              <a:rPr lang="en-US" sz="1150" i="1" dirty="0">
                 <a:solidFill>
                   <a:srgbClr val="5C6E7C"/>
                 </a:solidFill>
@@ -22078,13 +22295,13 @@
               </a:rPr>
               <a:t>VI = 0 → only the most recent period.</a:t>
             </a:r>
-            <a:endParaRPr lang="en-US" sz="1200" dirty="0"/>
-          </a:p>
-        </p:txBody>
-      </p:sp>
-      <p:sp>
-        <p:nvSpPr>
-          <p:cNvPr id="42" name="Text 40"/>
+            <a:endParaRPr lang="en-US" sz="1150" dirty="0"/>
+          </a:p>
+        </p:txBody>
+      </p:sp>
+      <p:sp>
+        <p:nvSpPr>
+          <p:cNvPr id="45" name="Text 43"/>
           <p:cNvSpPr/>
           <p:nvPr/>
         </p:nvSpPr>
@@ -22123,7 +22340,7 @@
       </p:sp>
       <p:sp>
         <p:nvSpPr>
-          <p:cNvPr id="43" name="Text 41"/>
+          <p:cNvPr id="46" name="Text 44"/>
           <p:cNvSpPr/>
           <p:nvPr/>
         </p:nvSpPr>

</xml_diff>

<commit_message>
temporal slide: plot ControlTime (-CT) marker on the timeline
Adds a square CT marker under 'now' with a dashed +FQ+CO advance arrow
to the next scheduled run, visualizing job scheduling on the axis.

Co-Authored-By: Claude Opus 4.6 <noreply@anthropic.com>
</commit_message>
<xml_diff>
--- a/docs/slides/dsupdt_guide.pptx
+++ b/docs/slides/dsupdt_guide.pptx
@@ -21746,6 +21746,192 @@
         </p:nvSpPr>
         <p:spPr>
           <a:xfrm>
+            <a:off x="10424160" y="3950208"/>
+            <a:ext cx="182880" cy="182880"/>
+          </a:xfrm>
+          <a:prstGeom prst="rect">
+            <a:avLst/>
+          </a:prstGeom>
+          <a:solidFill>
+            <a:srgbClr val="065A82"/>
+          </a:solidFill>
+          <a:ln/>
+        </p:spPr>
+      </p:sp>
+      <p:sp>
+        <p:nvSpPr>
+          <p:cNvPr id="33" name="Text 31"/>
+          <p:cNvSpPr/>
+          <p:nvPr/>
+        </p:nvSpPr>
+        <p:spPr>
+          <a:xfrm>
+            <a:off x="8458200" y="3922776"/>
+            <a:ext cx="1828800" cy="237744"/>
+          </a:xfrm>
+          <a:prstGeom prst="rect">
+            <a:avLst/>
+          </a:prstGeom>
+          <a:noFill/>
+          <a:ln/>
+        </p:spPr>
+        <p:txBody>
+          <a:bodyPr wrap="square" lIns="0" tIns="0" rIns="0" bIns="0" rtlCol="0" anchor="ctr"/>
+          <a:lstStyle/>
+          <a:p>
+            <a:pPr algn="r" indent="0" marL="0">
+              <a:buNone/>
+            </a:pPr>
+            <a:r>
+              <a:rPr lang="en-US" sz="1100" b="1" dirty="0">
+                <a:solidFill>
+                  <a:srgbClr val="065A82"/>
+                </a:solidFill>
+                <a:latin typeface="Calibri" pitchFamily="34" charset="0"/>
+                <a:ea typeface="Calibri" pitchFamily="34" charset="-122"/>
+                <a:cs typeface="Calibri" pitchFamily="34" charset="-120"/>
+              </a:rPr>
+              <a:t>CT — job runs</a:t>
+            </a:r>
+            <a:endParaRPr lang="en-US" sz="1100" dirty="0"/>
+          </a:p>
+        </p:txBody>
+      </p:sp>
+      <p:sp>
+        <p:nvSpPr>
+          <p:cNvPr id="34" name="Shape 32"/>
+          <p:cNvSpPr/>
+          <p:nvPr/>
+        </p:nvSpPr>
+        <p:spPr>
+          <a:xfrm>
+            <a:off x="10643616" y="4041648"/>
+            <a:ext cx="1133856" cy="0"/>
+          </a:xfrm>
+          <a:prstGeom prst="line">
+            <a:avLst/>
+          </a:prstGeom>
+          <a:noFill/>
+          <a:ln w="19050">
+            <a:solidFill>
+              <a:srgbClr val="065A82"/>
+            </a:solidFill>
+            <a:prstDash val="dash"/>
+            <a:tailEnd type="triangle"/>
+          </a:ln>
+        </p:spPr>
+      </p:sp>
+      <p:sp>
+        <p:nvSpPr>
+          <p:cNvPr id="35" name="Shape 33"/>
+          <p:cNvSpPr/>
+          <p:nvPr/>
+        </p:nvSpPr>
+        <p:spPr>
+          <a:xfrm>
+            <a:off x="11804904" y="3959352"/>
+            <a:ext cx="164592" cy="164592"/>
+          </a:xfrm>
+          <a:prstGeom prst="rect">
+            <a:avLst/>
+          </a:prstGeom>
+          <a:solidFill>
+            <a:srgbClr val="FFFFFF"/>
+          </a:solidFill>
+          <a:ln w="25400">
+            <a:solidFill>
+              <a:srgbClr val="065A82"/>
+            </a:solidFill>
+            <a:prstDash val="solid"/>
+          </a:ln>
+        </p:spPr>
+      </p:sp>
+      <p:sp>
+        <p:nvSpPr>
+          <p:cNvPr id="36" name="Text 34"/>
+          <p:cNvSpPr/>
+          <p:nvPr/>
+        </p:nvSpPr>
+        <p:spPr>
+          <a:xfrm>
+            <a:off x="10607040" y="3749040"/>
+            <a:ext cx="1463040" cy="219456"/>
+          </a:xfrm>
+          <a:prstGeom prst="rect">
+            <a:avLst/>
+          </a:prstGeom>
+          <a:noFill/>
+          <a:ln/>
+        </p:spPr>
+        <p:txBody>
+          <a:bodyPr wrap="square" lIns="0" tIns="0" rIns="0" bIns="0" rtlCol="0" anchor="ctr"/>
+          <a:lstStyle/>
+          <a:p>
+            <a:pPr algn="ctr" indent="0" marL="0">
+              <a:buNone/>
+            </a:pPr>
+            <a:r>
+              <a:rPr lang="en-US" sz="1000" dirty="0">
+                <a:solidFill>
+                  <a:srgbClr val="065A82"/>
+                </a:solidFill>
+                <a:latin typeface="Calibri" pitchFamily="34" charset="0"/>
+                <a:ea typeface="Calibri" pitchFamily="34" charset="-122"/>
+                <a:cs typeface="Calibri" pitchFamily="34" charset="-120"/>
+              </a:rPr>
+              <a:t>+ FQ + CO</a:t>
+            </a:r>
+            <a:endParaRPr lang="en-US" sz="1000" dirty="0"/>
+          </a:p>
+        </p:txBody>
+      </p:sp>
+      <p:sp>
+        <p:nvSpPr>
+          <p:cNvPr id="37" name="Text 35"/>
+          <p:cNvSpPr/>
+          <p:nvPr/>
+        </p:nvSpPr>
+        <p:spPr>
+          <a:xfrm>
+            <a:off x="11201400" y="4133088"/>
+            <a:ext cx="1371600" cy="219456"/>
+          </a:xfrm>
+          <a:prstGeom prst="rect">
+            <a:avLst/>
+          </a:prstGeom>
+          <a:noFill/>
+          <a:ln/>
+        </p:spPr>
+        <p:txBody>
+          <a:bodyPr wrap="square" lIns="0" tIns="0" rIns="0" bIns="0" rtlCol="0" anchor="ctr"/>
+          <a:lstStyle/>
+          <a:p>
+            <a:pPr algn="ctr" indent="0" marL="0">
+              <a:buNone/>
+            </a:pPr>
+            <a:r>
+              <a:rPr lang="en-US" sz="950" i="1" dirty="0">
+                <a:solidFill>
+                  <a:srgbClr val="5C6E7C"/>
+                </a:solidFill>
+                <a:latin typeface="Calibri" pitchFamily="34" charset="0"/>
+                <a:ea typeface="Calibri" pitchFamily="34" charset="-122"/>
+                <a:cs typeface="Calibri" pitchFamily="34" charset="-120"/>
+              </a:rPr>
+              <a:t>next CT</a:t>
+            </a:r>
+            <a:endParaRPr lang="en-US" sz="950" dirty="0"/>
+          </a:p>
+        </p:txBody>
+      </p:sp>
+      <p:sp>
+        <p:nvSpPr>
+          <p:cNvPr id="38" name="Shape 36"/>
+          <p:cNvSpPr/>
+          <p:nvPr/>
+        </p:nvSpPr>
+        <p:spPr>
+          <a:xfrm>
             <a:off x="640080" y="4434840"/>
             <a:ext cx="201168" cy="201168"/>
           </a:xfrm>
@@ -21760,7 +21946,7 @@
       </p:sp>
       <p:sp>
         <p:nvSpPr>
-          <p:cNvPr id="33" name="Text 31"/>
+          <p:cNvPr id="39" name="Text 37"/>
           <p:cNvSpPr/>
           <p:nvPr/>
         </p:nvSpPr>
@@ -21799,7 +21985,7 @@
       </p:sp>
       <p:sp>
         <p:nvSpPr>
-          <p:cNvPr id="34" name="Shape 32"/>
+          <p:cNvPr id="40" name="Shape 38"/>
           <p:cNvSpPr/>
           <p:nvPr/>
         </p:nvSpPr>
@@ -21819,7 +22005,7 @@
       </p:sp>
       <p:sp>
         <p:nvSpPr>
-          <p:cNvPr id="35" name="Text 33"/>
+          <p:cNvPr id="41" name="Text 39"/>
           <p:cNvSpPr/>
           <p:nvPr/>
         </p:nvSpPr>
@@ -21858,7 +22044,7 @@
       </p:sp>
       <p:sp>
         <p:nvSpPr>
-          <p:cNvPr id="36" name="Shape 34"/>
+          <p:cNvPr id="42" name="Shape 40"/>
           <p:cNvSpPr/>
           <p:nvPr/>
         </p:nvSpPr>
@@ -21878,7 +22064,7 @@
       </p:sp>
       <p:sp>
         <p:nvSpPr>
-          <p:cNvPr id="37" name="Text 35"/>
+          <p:cNvPr id="43" name="Text 41"/>
           <p:cNvSpPr/>
           <p:nvPr/>
         </p:nvSpPr>
@@ -21917,7 +22103,7 @@
       </p:sp>
       <p:sp>
         <p:nvSpPr>
-          <p:cNvPr id="38" name="Shape 36"/>
+          <p:cNvPr id="44" name="Shape 42"/>
           <p:cNvSpPr/>
           <p:nvPr/>
         </p:nvSpPr>
@@ -21942,7 +22128,7 @@
       </p:sp>
       <p:sp>
         <p:nvSpPr>
-          <p:cNvPr id="39" name="Text 37"/>
+          <p:cNvPr id="45" name="Text 43"/>
           <p:cNvSpPr/>
           <p:nvPr/>
         </p:nvSpPr>
@@ -21981,7 +22167,7 @@
       </p:sp>
       <p:sp>
         <p:nvSpPr>
-          <p:cNvPr id="40" name="Shape 38"/>
+          <p:cNvPr id="46" name="Shape 44"/>
           <p:cNvSpPr/>
           <p:nvPr/>
         </p:nvSpPr>
@@ -22008,7 +22194,7 @@
       </p:sp>
       <p:sp>
         <p:nvSpPr>
-          <p:cNvPr id="41" name="Text 39"/>
+          <p:cNvPr id="47" name="Text 45"/>
           <p:cNvSpPr/>
           <p:nvPr/>
         </p:nvSpPr>
@@ -22047,7 +22233,7 @@
       </p:sp>
       <p:sp>
         <p:nvSpPr>
-          <p:cNvPr id="42" name="Text 40"/>
+          <p:cNvPr id="48" name="Text 46"/>
           <p:cNvSpPr/>
           <p:nvPr/>
         </p:nvSpPr>
@@ -22198,7 +22384,7 @@
       </p:sp>
       <p:sp>
         <p:nvSpPr>
-          <p:cNvPr id="43" name="Shape 41"/>
+          <p:cNvPr id="49" name="Shape 47"/>
           <p:cNvSpPr/>
           <p:nvPr/>
         </p:nvSpPr>
@@ -22225,7 +22411,7 @@
       </p:sp>
       <p:sp>
         <p:nvSpPr>
-          <p:cNvPr id="44" name="Text 42"/>
+          <p:cNvPr id="50" name="Text 48"/>
           <p:cNvSpPr/>
           <p:nvPr/>
         </p:nvSpPr>
@@ -22301,7 +22487,7 @@
       </p:sp>
       <p:sp>
         <p:nvSpPr>
-          <p:cNvPr id="45" name="Text 43"/>
+          <p:cNvPr id="51" name="Text 49"/>
           <p:cNvSpPr/>
           <p:nvPr/>
         </p:nvSpPr>
@@ -22340,7 +22526,7 @@
       </p:sp>
       <p:sp>
         <p:nvSpPr>
-          <p:cNvPr id="46" name="Text 44"/>
+          <p:cNvPr id="52" name="Text 50"/>
           <p:cNvSpPr/>
           <p:nvPr/>
         </p:nvSpPr>

</xml_diff>

<commit_message>
temporal slide: correct due-interval logic on the timeline
Periods within DI of now are not archivable yet (end + DI > now); mark
07-14/now as not-yet-due and add a 'due cutoff (now - DI)' line so the
archived-this-run boundary matches the Due Interval semantics.

Co-Authored-By: Claude Opus 4.6 <noreply@anthropic.com>
</commit_message>
<xml_diff>
--- a/docs/slides/dsupdt_guide.pptx
+++ b/docs/slides/dsupdt_guide.pptx
@@ -21505,9 +21505,14 @@
             <a:avLst/>
           </a:prstGeom>
           <a:solidFill>
-            <a:srgbClr val="E8963A"/>
+            <a:srgbClr val="FFFFFF"/>
           </a:solidFill>
-          <a:ln/>
+          <a:ln w="25400">
+            <a:solidFill>
+              <a:srgbClr val="5C6E7C"/>
+            </a:solidFill>
+            <a:prstDash val="solid"/>
+          </a:ln>
         </p:spPr>
       </p:sp>
       <p:sp>
@@ -21683,6 +21688,91 @@
         </p:nvSpPr>
         <p:spPr>
           <a:xfrm>
+            <a:off x="8339328" y="2286000"/>
+            <a:ext cx="0" cy="1508760"/>
+          </a:xfrm>
+          <a:prstGeom prst="line">
+            <a:avLst/>
+          </a:prstGeom>
+          <a:noFill/>
+          <a:ln w="15875">
+            <a:solidFill>
+              <a:srgbClr val="5C6E7C"/>
+            </a:solidFill>
+            <a:prstDash val="dash"/>
+          </a:ln>
+        </p:spPr>
+      </p:sp>
+      <p:sp>
+        <p:nvSpPr>
+          <p:cNvPr id="31" name="Text 29"/>
+          <p:cNvSpPr/>
+          <p:nvPr/>
+        </p:nvSpPr>
+        <p:spPr>
+          <a:xfrm>
+            <a:off x="7196328" y="1847088"/>
+            <a:ext cx="2286000" cy="420624"/>
+          </a:xfrm>
+          <a:prstGeom prst="rect">
+            <a:avLst/>
+          </a:prstGeom>
+          <a:noFill/>
+          <a:ln/>
+        </p:spPr>
+        <p:txBody>
+          <a:bodyPr wrap="square" lIns="0" tIns="0" rIns="0" bIns="0" rtlCol="0" anchor="ctr"/>
+          <a:lstStyle/>
+          <a:p>
+            <a:pPr algn="ctr" indent="0" marL="0">
+              <a:lnSpc>
+                <a:spcPct val="95000"/>
+              </a:lnSpc>
+              <a:buNone/>
+            </a:pPr>
+            <a:r>
+              <a:rPr lang="en-US" sz="1050" b="1" dirty="0">
+                <a:solidFill>
+                  <a:srgbClr val="5C6E7C"/>
+                </a:solidFill>
+                <a:latin typeface="Calibri" pitchFamily="34" charset="0"/>
+                <a:ea typeface="Calibri" pitchFamily="34" charset="-122"/>
+                <a:cs typeface="Calibri" pitchFamily="34" charset="-120"/>
+              </a:rPr>
+              <a:t>due cutoff</a:t>
+            </a:r>
+            <a:endParaRPr lang="en-US" sz="1050" dirty="0"/>
+          </a:p>
+          <a:p>
+            <a:pPr algn="ctr" indent="0" marL="0">
+              <a:lnSpc>
+                <a:spcPct val="95000"/>
+              </a:lnSpc>
+              <a:buNone/>
+            </a:pPr>
+            <a:r>
+              <a:rPr lang="en-US" sz="1050" b="1" dirty="0">
+                <a:solidFill>
+                  <a:srgbClr val="5C6E7C"/>
+                </a:solidFill>
+                <a:latin typeface="Calibri" pitchFamily="34" charset="0"/>
+                <a:ea typeface="Calibri" pitchFamily="34" charset="-122"/>
+                <a:cs typeface="Calibri" pitchFamily="34" charset="-120"/>
+              </a:rPr>
+              <a:t>(now − DI)</a:t>
+            </a:r>
+            <a:endParaRPr lang="en-US" sz="1050" dirty="0"/>
+          </a:p>
+        </p:txBody>
+      </p:sp>
+      <p:sp>
+        <p:nvSpPr>
+          <p:cNvPr id="32" name="Shape 30"/>
+          <p:cNvSpPr/>
+          <p:nvPr/>
+        </p:nvSpPr>
+        <p:spPr>
+          <a:xfrm>
             <a:off x="4297680" y="3813048"/>
             <a:ext cx="2176272" cy="0"/>
           </a:xfrm>
@@ -21701,7 +21791,7 @@
       </p:sp>
       <p:sp>
         <p:nvSpPr>
-          <p:cNvPr id="31" name="Text 29"/>
+          <p:cNvPr id="33" name="Text 31"/>
           <p:cNvSpPr/>
           <p:nvPr/>
         </p:nvSpPr>
@@ -21740,7 +21830,7 @@
       </p:sp>
       <p:sp>
         <p:nvSpPr>
-          <p:cNvPr id="32" name="Shape 30"/>
+          <p:cNvPr id="34" name="Shape 32"/>
           <p:cNvSpPr/>
           <p:nvPr/>
         </p:nvSpPr>
@@ -21760,7 +21850,7 @@
       </p:sp>
       <p:sp>
         <p:nvSpPr>
-          <p:cNvPr id="33" name="Text 31"/>
+          <p:cNvPr id="35" name="Text 33"/>
           <p:cNvSpPr/>
           <p:nvPr/>
         </p:nvSpPr>
@@ -21799,7 +21889,7 @@
       </p:sp>
       <p:sp>
         <p:nvSpPr>
-          <p:cNvPr id="34" name="Shape 32"/>
+          <p:cNvPr id="36" name="Shape 34"/>
           <p:cNvSpPr/>
           <p:nvPr/>
         </p:nvSpPr>
@@ -21823,7 +21913,7 @@
       </p:sp>
       <p:sp>
         <p:nvSpPr>
-          <p:cNvPr id="35" name="Shape 33"/>
+          <p:cNvPr id="37" name="Shape 35"/>
           <p:cNvSpPr/>
           <p:nvPr/>
         </p:nvSpPr>
@@ -21848,7 +21938,7 @@
       </p:sp>
       <p:sp>
         <p:nvSpPr>
-          <p:cNvPr id="36" name="Text 34"/>
+          <p:cNvPr id="38" name="Text 36"/>
           <p:cNvSpPr/>
           <p:nvPr/>
         </p:nvSpPr>
@@ -21887,7 +21977,7 @@
       </p:sp>
       <p:sp>
         <p:nvSpPr>
-          <p:cNvPr id="37" name="Text 35"/>
+          <p:cNvPr id="39" name="Text 37"/>
           <p:cNvSpPr/>
           <p:nvPr/>
         </p:nvSpPr>
@@ -21926,7 +22016,7 @@
       </p:sp>
       <p:sp>
         <p:nvSpPr>
-          <p:cNvPr id="38" name="Shape 36"/>
+          <p:cNvPr id="40" name="Shape 38"/>
           <p:cNvSpPr/>
           <p:nvPr/>
         </p:nvSpPr>
@@ -21946,7 +22036,7 @@
       </p:sp>
       <p:sp>
         <p:nvSpPr>
-          <p:cNvPr id="39" name="Text 37"/>
+          <p:cNvPr id="41" name="Text 39"/>
           <p:cNvSpPr/>
           <p:nvPr/>
         </p:nvSpPr>
@@ -21985,7 +22075,7 @@
       </p:sp>
       <p:sp>
         <p:nvSpPr>
-          <p:cNvPr id="40" name="Shape 38"/>
+          <p:cNvPr id="42" name="Shape 40"/>
           <p:cNvSpPr/>
           <p:nvPr/>
         </p:nvSpPr>
@@ -22005,7 +22095,7 @@
       </p:sp>
       <p:sp>
         <p:nvSpPr>
-          <p:cNvPr id="41" name="Text 39"/>
+          <p:cNvPr id="43" name="Text 41"/>
           <p:cNvSpPr/>
           <p:nvPr/>
         </p:nvSpPr>
@@ -22044,7 +22134,7 @@
       </p:sp>
       <p:sp>
         <p:nvSpPr>
-          <p:cNvPr id="42" name="Shape 40"/>
+          <p:cNvPr id="44" name="Shape 42"/>
           <p:cNvSpPr/>
           <p:nvPr/>
         </p:nvSpPr>
@@ -22064,7 +22154,7 @@
       </p:sp>
       <p:sp>
         <p:nvSpPr>
-          <p:cNvPr id="43" name="Text 41"/>
+          <p:cNvPr id="45" name="Text 43"/>
           <p:cNvSpPr/>
           <p:nvPr/>
         </p:nvSpPr>
@@ -22103,7 +22193,7 @@
       </p:sp>
       <p:sp>
         <p:nvSpPr>
-          <p:cNvPr id="44" name="Shape 42"/>
+          <p:cNvPr id="46" name="Shape 44"/>
           <p:cNvSpPr/>
           <p:nvPr/>
         </p:nvSpPr>
@@ -22128,7 +22218,7 @@
       </p:sp>
       <p:sp>
         <p:nvSpPr>
-          <p:cNvPr id="45" name="Text 43"/>
+          <p:cNvPr id="47" name="Text 45"/>
           <p:cNvSpPr/>
           <p:nvPr/>
         </p:nvSpPr>
@@ -22167,7 +22257,7 @@
       </p:sp>
       <p:sp>
         <p:nvSpPr>
-          <p:cNvPr id="46" name="Shape 44"/>
+          <p:cNvPr id="48" name="Shape 46"/>
           <p:cNvSpPr/>
           <p:nvPr/>
         </p:nvSpPr>
@@ -22194,7 +22284,7 @@
       </p:sp>
       <p:sp>
         <p:nvSpPr>
-          <p:cNvPr id="47" name="Text 45"/>
+          <p:cNvPr id="49" name="Text 47"/>
           <p:cNvSpPr/>
           <p:nvPr/>
         </p:nvSpPr>
@@ -22233,7 +22323,7 @@
       </p:sp>
       <p:sp>
         <p:nvSpPr>
-          <p:cNvPr id="48" name="Text 46"/>
+          <p:cNvPr id="50" name="Text 48"/>
           <p:cNvSpPr/>
           <p:nvPr/>
         </p:nvSpPr>
@@ -22384,7 +22474,7 @@
       </p:sp>
       <p:sp>
         <p:nvSpPr>
-          <p:cNvPr id="49" name="Shape 47"/>
+          <p:cNvPr id="51" name="Shape 49"/>
           <p:cNvSpPr/>
           <p:nvPr/>
         </p:nvSpPr>
@@ -22411,7 +22501,7 @@
       </p:sp>
       <p:sp>
         <p:nvSpPr>
-          <p:cNvPr id="50" name="Text 48"/>
+          <p:cNvPr id="52" name="Text 50"/>
           <p:cNvSpPr/>
           <p:nvPr/>
         </p:nvSpPr>
@@ -22487,7 +22577,7 @@
       </p:sp>
       <p:sp>
         <p:nvSpPr>
-          <p:cNvPr id="51" name="Text 49"/>
+          <p:cNvPr id="53" name="Text 51"/>
           <p:cNvSpPr/>
           <p:nvPr/>
         </p:nvSpPr>
@@ -22526,7 +22616,7 @@
       </p:sp>
       <p:sp>
         <p:nvSpPr>
-          <p:cNvPr id="52" name="Text 50"/>
+          <p:cNvPr id="54" name="Text 52"/>
           <p:cNvSpPr/>
           <p:nvPr/>
         </p:nvSpPr>

</xml_diff>

<commit_message>
temporal slide: correct ControlTime step to Next CT = CT + FQ
CO is a within-period offset (period start + CO, e.g. daily day start),
so it cancels in the step between runs; relabel the advance arrow +FQ
and note CT = period start + CO.

Co-Authored-By: Claude Opus 4.6 <noreply@anthropic.com>
</commit_message>
<xml_diff>
--- a/docs/slides/dsupdt_guide.pptx
+++ b/docs/slides/dsupdt_guide.pptx
@@ -21889,7 +21889,46 @@
       </p:sp>
       <p:sp>
         <p:nvSpPr>
-          <p:cNvPr id="36" name="Shape 34"/>
+          <p:cNvPr id="36" name="Text 34"/>
+          <p:cNvSpPr/>
+          <p:nvPr/>
+        </p:nvSpPr>
+        <p:spPr>
+          <a:xfrm>
+            <a:off x="8458200" y="4142232"/>
+            <a:ext cx="1828800" cy="201168"/>
+          </a:xfrm>
+          <a:prstGeom prst="rect">
+            <a:avLst/>
+          </a:prstGeom>
+          <a:noFill/>
+          <a:ln/>
+        </p:spPr>
+        <p:txBody>
+          <a:bodyPr wrap="square" lIns="0" tIns="0" rIns="0" bIns="0" rtlCol="0" anchor="ctr"/>
+          <a:lstStyle/>
+          <a:p>
+            <a:pPr algn="r" indent="0" marL="0">
+              <a:buNone/>
+            </a:pPr>
+            <a:r>
+              <a:rPr lang="en-US" sz="900" i="1" dirty="0">
+                <a:solidFill>
+                  <a:srgbClr val="5C6E7C"/>
+                </a:solidFill>
+                <a:latin typeface="Calibri" pitchFamily="34" charset="0"/>
+                <a:ea typeface="Calibri" pitchFamily="34" charset="-122"/>
+                <a:cs typeface="Calibri" pitchFamily="34" charset="-120"/>
+              </a:rPr>
+              <a:t>= period start + CO</a:t>
+            </a:r>
+            <a:endParaRPr lang="en-US" sz="900" dirty="0"/>
+          </a:p>
+        </p:txBody>
+      </p:sp>
+      <p:sp>
+        <p:nvSpPr>
+          <p:cNvPr id="37" name="Shape 35"/>
           <p:cNvSpPr/>
           <p:nvPr/>
         </p:nvSpPr>
@@ -21913,7 +21952,7 @@
       </p:sp>
       <p:sp>
         <p:nvSpPr>
-          <p:cNvPr id="37" name="Shape 35"/>
+          <p:cNvPr id="38" name="Shape 36"/>
           <p:cNvSpPr/>
           <p:nvPr/>
         </p:nvSpPr>
@@ -21938,7 +21977,7 @@
       </p:sp>
       <p:sp>
         <p:nvSpPr>
-          <p:cNvPr id="38" name="Text 36"/>
+          <p:cNvPr id="39" name="Text 37"/>
           <p:cNvSpPr/>
           <p:nvPr/>
         </p:nvSpPr>
@@ -21969,7 +22008,7 @@
                 <a:ea typeface="Calibri" pitchFamily="34" charset="-122"/>
                 <a:cs typeface="Calibri" pitchFamily="34" charset="-120"/>
               </a:rPr>
-              <a:t>+ FQ + CO</a:t>
+              <a:t>+ FQ</a:t>
             </a:r>
             <a:endParaRPr lang="en-US" sz="1000" dirty="0"/>
           </a:p>
@@ -21977,7 +22016,7 @@
       </p:sp>
       <p:sp>
         <p:nvSpPr>
-          <p:cNvPr id="39" name="Text 37"/>
+          <p:cNvPr id="40" name="Text 38"/>
           <p:cNvSpPr/>
           <p:nvPr/>
         </p:nvSpPr>
@@ -22016,7 +22055,7 @@
       </p:sp>
       <p:sp>
         <p:nvSpPr>
-          <p:cNvPr id="40" name="Shape 38"/>
+          <p:cNvPr id="41" name="Shape 39"/>
           <p:cNvSpPr/>
           <p:nvPr/>
         </p:nvSpPr>
@@ -22036,7 +22075,7 @@
       </p:sp>
       <p:sp>
         <p:nvSpPr>
-          <p:cNvPr id="41" name="Text 39"/>
+          <p:cNvPr id="42" name="Text 40"/>
           <p:cNvSpPr/>
           <p:nvPr/>
         </p:nvSpPr>
@@ -22075,7 +22114,7 @@
       </p:sp>
       <p:sp>
         <p:nvSpPr>
-          <p:cNvPr id="42" name="Shape 40"/>
+          <p:cNvPr id="43" name="Shape 41"/>
           <p:cNvSpPr/>
           <p:nvPr/>
         </p:nvSpPr>
@@ -22095,7 +22134,7 @@
       </p:sp>
       <p:sp>
         <p:nvSpPr>
-          <p:cNvPr id="43" name="Text 41"/>
+          <p:cNvPr id="44" name="Text 42"/>
           <p:cNvSpPr/>
           <p:nvPr/>
         </p:nvSpPr>
@@ -22134,7 +22173,7 @@
       </p:sp>
       <p:sp>
         <p:nvSpPr>
-          <p:cNvPr id="44" name="Shape 42"/>
+          <p:cNvPr id="45" name="Shape 43"/>
           <p:cNvSpPr/>
           <p:nvPr/>
         </p:nvSpPr>
@@ -22154,7 +22193,7 @@
       </p:sp>
       <p:sp>
         <p:nvSpPr>
-          <p:cNvPr id="45" name="Text 43"/>
+          <p:cNvPr id="46" name="Text 44"/>
           <p:cNvSpPr/>
           <p:nvPr/>
         </p:nvSpPr>
@@ -22193,7 +22232,7 @@
       </p:sp>
       <p:sp>
         <p:nvSpPr>
-          <p:cNvPr id="46" name="Shape 44"/>
+          <p:cNvPr id="47" name="Shape 45"/>
           <p:cNvSpPr/>
           <p:nvPr/>
         </p:nvSpPr>
@@ -22218,7 +22257,7 @@
       </p:sp>
       <p:sp>
         <p:nvSpPr>
-          <p:cNvPr id="47" name="Text 45"/>
+          <p:cNvPr id="48" name="Text 46"/>
           <p:cNvSpPr/>
           <p:nvPr/>
         </p:nvSpPr>
@@ -22257,7 +22296,7 @@
       </p:sp>
       <p:sp>
         <p:nvSpPr>
-          <p:cNvPr id="48" name="Shape 46"/>
+          <p:cNvPr id="49" name="Shape 47"/>
           <p:cNvSpPr/>
           <p:nvPr/>
         </p:nvSpPr>
@@ -22284,7 +22323,7 @@
       </p:sp>
       <p:sp>
         <p:nvSpPr>
-          <p:cNvPr id="49" name="Text 47"/>
+          <p:cNvPr id="50" name="Text 48"/>
           <p:cNvSpPr/>
           <p:nvPr/>
         </p:nvSpPr>
@@ -22323,7 +22362,7 @@
       </p:sp>
       <p:sp>
         <p:nvSpPr>
-          <p:cNvPr id="50" name="Text 48"/>
+          <p:cNvPr id="51" name="Text 49"/>
           <p:cNvSpPr/>
           <p:nvPr/>
         </p:nvSpPr>
@@ -22368,7 +22407,7 @@
                 <a:ea typeface="Calibri" pitchFamily="34" charset="-122"/>
                 <a:cs typeface="Calibri" pitchFamily="34" charset="-120"/>
               </a:rPr>
-              <a:t> sets the scheduled run time (YYYY-MM-DD HH:NN:SS). After a success it advances by control </a:t>
+              <a:t> sets the run time (YYYY-MM-DD HH:NN:SS). Each success steps it by one </a:t>
             </a:r>
             <a:pPr indent="0" marL="0">
               <a:buNone/>
@@ -22396,7 +22435,7 @@
                 <a:ea typeface="Calibri" pitchFamily="34" charset="-122"/>
                 <a:cs typeface="Calibri" pitchFamily="34" charset="-120"/>
               </a:rPr>
-              <a:t> + </a:t>
+              <a:t> (Next CT = CT + FQ); </a:t>
             </a:r>
             <a:pPr indent="0" marL="0">
               <a:buNone/>
@@ -22424,7 +22463,7 @@
                 <a:ea typeface="Calibri" pitchFamily="34" charset="-122"/>
                 <a:cs typeface="Calibri" pitchFamily="34" charset="-120"/>
               </a:rPr>
-              <a:t> offset; a failure retries after </a:t>
+              <a:t> only offsets the run from the period start (daily → day start + CO), so it cancels in the step. Failure retries after </a:t>
             </a:r>
             <a:pPr indent="0" marL="0">
               <a:buNone/>
@@ -22452,7 +22491,7 @@
                 <a:ea typeface="Calibri" pitchFamily="34" charset="-122"/>
                 <a:cs typeface="Calibri" pitchFamily="34" charset="-120"/>
               </a:rPr>
-              <a:t>.    e.g.  </a:t>
+              <a:t>.   e.g.  </a:t>
             </a:r>
             <a:pPr indent="0" marL="0">
               <a:buNone/>
@@ -22474,7 +22513,7 @@
       </p:sp>
       <p:sp>
         <p:nvSpPr>
-          <p:cNvPr id="51" name="Shape 49"/>
+          <p:cNvPr id="52" name="Shape 50"/>
           <p:cNvSpPr/>
           <p:nvPr/>
         </p:nvSpPr>
@@ -22501,7 +22540,7 @@
       </p:sp>
       <p:sp>
         <p:nvSpPr>
-          <p:cNvPr id="52" name="Text 50"/>
+          <p:cNvPr id="53" name="Text 51"/>
           <p:cNvSpPr/>
           <p:nvPr/>
         </p:nvSpPr>
@@ -22577,7 +22616,7 @@
       </p:sp>
       <p:sp>
         <p:nvSpPr>
-          <p:cNvPr id="53" name="Text 51"/>
+          <p:cNvPr id="54" name="Text 52"/>
           <p:cNvSpPr/>
           <p:nvPr/>
         </p:nvSpPr>
@@ -22616,7 +22655,7 @@
       </p:sp>
       <p:sp>
         <p:nvSpPr>
-          <p:cNvPr id="54" name="Text 52"/>
+          <p:cNvPr id="55" name="Text 53"/>
           <p:cNvSpPr/>
           <p:nvPr/>
         </p:nvSpPr>

</xml_diff>

<commit_message>
temporal slide: clarify data-end times are server (GMT) vs -CT local time
Adds a 'Time zones' note to the ControlTime card so users don't confuse
the server-time data end date/hour (-ED/-EH) with the local-time -CT.

Co-Authored-By: Claude Opus 4.6 <noreply@anthropic.com>
</commit_message>
<xml_diff>
--- a/docs/slides/dsupdt_guide.pptx
+++ b/docs/slides/dsupdt_guide.pptx
@@ -22302,12 +22302,12 @@
         </p:nvSpPr>
         <p:spPr>
           <a:xfrm>
-            <a:off x="457200" y="4846320"/>
-            <a:ext cx="11274552" cy="749808"/>
+            <a:off x="457200" y="4773168"/>
+            <a:ext cx="11274552" cy="932688"/>
           </a:xfrm>
           <a:prstGeom prst="roundRect">
             <a:avLst>
-              <a:gd name="adj" fmla="val 9756"/>
+              <a:gd name="adj" fmla="val 7843"/>
             </a:avLst>
           </a:prstGeom>
           <a:solidFill>
@@ -22329,7 +22329,7 @@
         </p:nvSpPr>
         <p:spPr>
           <a:xfrm>
-            <a:off x="658368" y="4910328"/>
+            <a:off x="658368" y="4828032"/>
             <a:ext cx="10789920" cy="274320"/>
           </a:xfrm>
           <a:prstGeom prst="rect">
@@ -22368,8 +22368,8 @@
         </p:nvSpPr>
         <p:spPr>
           <a:xfrm>
-            <a:off x="658368" y="5193792"/>
-            <a:ext cx="10881360" cy="365760"/>
+            <a:off x="658368" y="5102352"/>
+            <a:ext cx="10881360" cy="310896"/>
           </a:xfrm>
           <a:prstGeom prst="rect">
             <a:avLst/>
@@ -22513,18 +22513,155 @@
       </p:sp>
       <p:sp>
         <p:nvSpPr>
-          <p:cNvPr id="52" name="Shape 50"/>
-          <p:cNvSpPr/>
-          <p:nvPr/>
-        </p:nvSpPr>
-        <p:spPr>
-          <a:xfrm>
-            <a:off x="457200" y="5705856"/>
-            <a:ext cx="11274552" cy="548640"/>
+          <p:cNvPr id="52" name="Text 50"/>
+          <p:cNvSpPr/>
+          <p:nvPr/>
+        </p:nvSpPr>
+        <p:spPr>
+          <a:xfrm>
+            <a:off x="658368" y="5394960"/>
+            <a:ext cx="10881360" cy="274320"/>
+          </a:xfrm>
+          <a:prstGeom prst="rect">
+            <a:avLst/>
+          </a:prstGeom>
+          <a:noFill/>
+          <a:ln/>
+        </p:spPr>
+        <p:txBody>
+          <a:bodyPr wrap="square" lIns="0" tIns="0" rIns="0" bIns="0" rtlCol="0" anchor="ctr"/>
+          <a:lstStyle/>
+          <a:p>
+            <a:pPr indent="0" marL="0">
+              <a:buNone/>
+            </a:pPr>
+            <a:r>
+              <a:rPr lang="en-US" sz="1100" b="1" dirty="0">
+                <a:solidFill>
+                  <a:srgbClr val="B5701F"/>
+                </a:solidFill>
+                <a:latin typeface="Calibri" pitchFamily="34" charset="0"/>
+                <a:ea typeface="Calibri" pitchFamily="34" charset="-122"/>
+                <a:cs typeface="Calibri" pitchFamily="34" charset="-120"/>
+              </a:rPr>
+              <a:t>Time zones:  </a:t>
+            </a:r>
+            <a:pPr indent="0" marL="0">
+              <a:buNone/>
+            </a:pPr>
+            <a:r>
+              <a:rPr lang="en-US" sz="1100" dirty="0">
+                <a:solidFill>
+                  <a:srgbClr val="12212E"/>
+                </a:solidFill>
+                <a:latin typeface="Calibri" pitchFamily="34" charset="0"/>
+                <a:ea typeface="Calibri" pitchFamily="34" charset="-122"/>
+                <a:cs typeface="Calibri" pitchFamily="34" charset="-120"/>
+              </a:rPr>
+              <a:t>the data end date/hour (End Date, </a:t>
+            </a:r>
+            <a:pPr indent="0" marL="0">
+              <a:buNone/>
+            </a:pPr>
+            <a:r>
+              <a:rPr lang="en-US" sz="1100" b="1" dirty="0">
+                <a:solidFill>
+                  <a:srgbClr val="B5701F"/>
+                </a:solidFill>
+                <a:latin typeface="Courier New" pitchFamily="34" charset="0"/>
+                <a:ea typeface="Courier New" pitchFamily="34" charset="-122"/>
+                <a:cs typeface="Courier New" pitchFamily="34" charset="-120"/>
+              </a:rPr>
+              <a:t>-ED</a:t>
+            </a:r>
+            <a:pPr indent="0" marL="0">
+              <a:buNone/>
+            </a:pPr>
+            <a:r>
+              <a:rPr lang="en-US" sz="1100" dirty="0">
+                <a:solidFill>
+                  <a:srgbClr val="12212E"/>
+                </a:solidFill>
+                <a:latin typeface="Calibri" pitchFamily="34" charset="0"/>
+                <a:ea typeface="Calibri" pitchFamily="34" charset="-122"/>
+                <a:cs typeface="Calibri" pitchFamily="34" charset="-120"/>
+              </a:rPr>
+              <a:t> / </a:t>
+            </a:r>
+            <a:pPr indent="0" marL="0">
+              <a:buNone/>
+            </a:pPr>
+            <a:r>
+              <a:rPr lang="en-US" sz="1100" b="1" dirty="0">
+                <a:solidFill>
+                  <a:srgbClr val="B5701F"/>
+                </a:solidFill>
+                <a:latin typeface="Courier New" pitchFamily="34" charset="0"/>
+                <a:ea typeface="Courier New" pitchFamily="34" charset="-122"/>
+                <a:cs typeface="Courier New" pitchFamily="34" charset="-120"/>
+              </a:rPr>
+              <a:t>-EH</a:t>
+            </a:r>
+            <a:pPr indent="0" marL="0">
+              <a:buNone/>
+            </a:pPr>
+            <a:r>
+              <a:rPr lang="en-US" sz="1100" dirty="0">
+                <a:solidFill>
+                  <a:srgbClr val="12212E"/>
+                </a:solidFill>
+                <a:latin typeface="Calibri" pitchFamily="34" charset="0"/>
+                <a:ea typeface="Calibri" pitchFamily="34" charset="-122"/>
+                <a:cs typeface="Calibri" pitchFamily="34" charset="-120"/>
+              </a:rPr>
+              <a:t>) is server time (e.g. GMT), while </a:t>
+            </a:r>
+            <a:pPr indent="0" marL="0">
+              <a:buNone/>
+            </a:pPr>
+            <a:r>
+              <a:rPr lang="en-US" sz="1100" b="1" dirty="0">
+                <a:solidFill>
+                  <a:srgbClr val="B5701F"/>
+                </a:solidFill>
+                <a:latin typeface="Courier New" pitchFamily="34" charset="0"/>
+                <a:ea typeface="Courier New" pitchFamily="34" charset="-122"/>
+                <a:cs typeface="Courier New" pitchFamily="34" charset="-120"/>
+              </a:rPr>
+              <a:t>-CT</a:t>
+            </a:r>
+            <a:pPr indent="0" marL="0">
+              <a:buNone/>
+            </a:pPr>
+            <a:r>
+              <a:rPr lang="en-US" sz="1100" dirty="0">
+                <a:solidFill>
+                  <a:srgbClr val="12212E"/>
+                </a:solidFill>
+                <a:latin typeface="Calibri" pitchFamily="34" charset="0"/>
+                <a:ea typeface="Calibri" pitchFamily="34" charset="-122"/>
+                <a:cs typeface="Calibri" pitchFamily="34" charset="-120"/>
+              </a:rPr>
+              <a:t> is the local time the job runs — don’t mix the two.</a:t>
+            </a:r>
+            <a:endParaRPr lang="en-US" sz="1100" dirty="0"/>
+          </a:p>
+        </p:txBody>
+      </p:sp>
+      <p:sp>
+        <p:nvSpPr>
+          <p:cNvPr id="53" name="Shape 51"/>
+          <p:cNvSpPr/>
+          <p:nvPr/>
+        </p:nvSpPr>
+        <p:spPr>
+          <a:xfrm>
+            <a:off x="457200" y="5833872"/>
+            <a:ext cx="11274552" cy="502920"/>
           </a:xfrm>
           <a:prstGeom prst="roundRect">
             <a:avLst>
-              <a:gd name="adj" fmla="val 13333"/>
+              <a:gd name="adj" fmla="val 14545"/>
             </a:avLst>
           </a:prstGeom>
           <a:solidFill>
@@ -22540,14 +22677,14 @@
       </p:sp>
       <p:sp>
         <p:nvSpPr>
-          <p:cNvPr id="53" name="Text 51"/>
-          <p:cNvSpPr/>
-          <p:nvPr/>
-        </p:nvSpPr>
-        <p:spPr>
-          <a:xfrm>
-            <a:off x="685800" y="5705856"/>
-            <a:ext cx="10835640" cy="548640"/>
+          <p:cNvPr id="54" name="Text 52"/>
+          <p:cNvSpPr/>
+          <p:nvPr/>
+        </p:nvSpPr>
+        <p:spPr>
+          <a:xfrm>
+            <a:off x="685800" y="5833872"/>
+            <a:ext cx="10835640" cy="502920"/>
           </a:xfrm>
           <a:prstGeom prst="rect">
             <a:avLst/>
@@ -22616,7 +22753,7 @@
       </p:sp>
       <p:sp>
         <p:nvSpPr>
-          <p:cNvPr id="54" name="Text 52"/>
+          <p:cNvPr id="55" name="Text 53"/>
           <p:cNvSpPr/>
           <p:nvPr/>
         </p:nvSpPr>
@@ -22655,7 +22792,7 @@
       </p:sp>
       <p:sp>
         <p:nvSpPr>
-          <p:cNvPr id="55" name="Text 53"/>
+          <p:cNvPr id="56" name="Text 54"/>
           <p:cNvSpPr/>
           <p:nvPr/>
         </p:nvSpPr>

</xml_diff>

<commit_message>
temporal slide: show GMT->local shift of the data end date/hour
At End Date, a dashed circle marks the server-time (GMT) data end and a
solid circle its local-time equivalent, shifted earlier by the TZ offset
(e.g. -7h Mountain), clarifying why -CT (local) and -ED/-EH (GMT) differ.

Co-Authored-By: Claude Opus 4.6 <noreply@anthropic.com>
</commit_message>
<xml_diff>
--- a/docs/slides/dsupdt_guide.pptx
+++ b/docs/slides/dsupdt_guide.pptx
@@ -21253,27 +21253,7 @@
       </p:sp>
       <p:sp>
         <p:nvSpPr>
-          <p:cNvPr id="16" name="Shape 14"/>
-          <p:cNvSpPr/>
-          <p:nvPr/>
-        </p:nvSpPr>
-        <p:spPr>
-          <a:xfrm>
-            <a:off x="4178808" y="3127248"/>
-            <a:ext cx="237744" cy="237744"/>
-          </a:xfrm>
-          <a:prstGeom prst="ellipse">
-            <a:avLst/>
-          </a:prstGeom>
-          <a:solidFill>
-            <a:srgbClr val="1C7293"/>
-          </a:solidFill>
-          <a:ln/>
-        </p:spPr>
-      </p:sp>
-      <p:sp>
-        <p:nvSpPr>
-          <p:cNvPr id="17" name="Text 15"/>
+          <p:cNvPr id="16" name="Text 14"/>
           <p:cNvSpPr/>
           <p:nvPr/>
         </p:nvSpPr>
@@ -21312,7 +21292,7 @@
       </p:sp>
       <p:sp>
         <p:nvSpPr>
-          <p:cNvPr id="18" name="Shape 16"/>
+          <p:cNvPr id="17" name="Shape 15"/>
           <p:cNvSpPr/>
           <p:nvPr/>
         </p:nvSpPr>
@@ -21335,14 +21315,14 @@
       </p:sp>
       <p:sp>
         <p:nvSpPr>
-          <p:cNvPr id="19" name="Text 17"/>
-          <p:cNvSpPr/>
-          <p:nvPr/>
-        </p:nvSpPr>
-        <p:spPr>
-          <a:xfrm>
-            <a:off x="3474720" y="1993392"/>
-            <a:ext cx="1645920" cy="274320"/>
+          <p:cNvPr id="18" name="Text 16"/>
+          <p:cNvSpPr/>
+          <p:nvPr/>
+        </p:nvSpPr>
+        <p:spPr>
+          <a:xfrm>
+            <a:off x="3337560" y="1993392"/>
+            <a:ext cx="1920240" cy="274320"/>
           </a:xfrm>
           <a:prstGeom prst="rect">
             <a:avLst/>
@@ -21366,7 +21346,7 @@
                 <a:ea typeface="Calibri" pitchFamily="34" charset="-122"/>
                 <a:cs typeface="Calibri" pitchFamily="34" charset="-120"/>
               </a:rPr>
-              <a:t>End Date</a:t>
+              <a:t>End Date (GMT)</a:t>
             </a:r>
             <a:endParaRPr lang="en-US" sz="1100" dirty="0"/>
           </a:p>
@@ -21374,7 +21354,115 @@
       </p:sp>
       <p:sp>
         <p:nvSpPr>
+          <p:cNvPr id="19" name="Shape 17"/>
+          <p:cNvSpPr/>
+          <p:nvPr/>
+        </p:nvSpPr>
+        <p:spPr>
+          <a:xfrm>
+            <a:off x="4178808" y="3127248"/>
+            <a:ext cx="237744" cy="237744"/>
+          </a:xfrm>
+          <a:prstGeom prst="ellipse">
+            <a:avLst/>
+          </a:prstGeom>
+          <a:solidFill>
+            <a:srgbClr val="FFFFFF"/>
+          </a:solidFill>
+          <a:ln w="25400">
+            <a:solidFill>
+              <a:srgbClr val="1C7293"/>
+            </a:solidFill>
+            <a:prstDash val="dash"/>
+          </a:ln>
+        </p:spPr>
+      </p:sp>
+      <p:sp>
+        <p:nvSpPr>
           <p:cNvPr id="20" name="Shape 18"/>
+          <p:cNvSpPr/>
+          <p:nvPr/>
+        </p:nvSpPr>
+        <p:spPr>
+          <a:xfrm>
+            <a:off x="3538728" y="3127248"/>
+            <a:ext cx="237744" cy="237744"/>
+          </a:xfrm>
+          <a:prstGeom prst="ellipse">
+            <a:avLst/>
+          </a:prstGeom>
+          <a:solidFill>
+            <a:srgbClr val="1C7293"/>
+          </a:solidFill>
+          <a:ln/>
+        </p:spPr>
+      </p:sp>
+      <p:sp>
+        <p:nvSpPr>
+          <p:cNvPr id="21" name="Shape 19"/>
+          <p:cNvSpPr/>
+          <p:nvPr/>
+        </p:nvSpPr>
+        <p:spPr>
+          <a:xfrm>
+            <a:off x="3794760" y="3246120"/>
+            <a:ext cx="365760" cy="0"/>
+          </a:xfrm>
+          <a:prstGeom prst="line">
+            <a:avLst/>
+          </a:prstGeom>
+          <a:noFill/>
+          <a:ln w="19050">
+            <a:solidFill>
+              <a:srgbClr val="1C7293"/>
+            </a:solidFill>
+            <a:prstDash val="solid"/>
+            <a:headEnd type="triangle"/>
+          </a:ln>
+        </p:spPr>
+      </p:sp>
+      <p:sp>
+        <p:nvSpPr>
+          <p:cNvPr id="22" name="Text 20"/>
+          <p:cNvSpPr/>
+          <p:nvPr/>
+        </p:nvSpPr>
+        <p:spPr>
+          <a:xfrm>
+            <a:off x="3108960" y="2916936"/>
+            <a:ext cx="1737360" cy="237744"/>
+          </a:xfrm>
+          <a:prstGeom prst="rect">
+            <a:avLst/>
+          </a:prstGeom>
+          <a:noFill/>
+          <a:ln/>
+        </p:spPr>
+        <p:txBody>
+          <a:bodyPr wrap="square" lIns="0" tIns="0" rIns="0" bIns="0" rtlCol="0" anchor="ctr"/>
+          <a:lstStyle/>
+          <a:p>
+            <a:pPr algn="ctr" indent="0" marL="0">
+              <a:buNone/>
+            </a:pPr>
+            <a:r>
+              <a:rPr lang="en-US" sz="950" b="1" dirty="0">
+                <a:solidFill>
+                  <a:srgbClr val="1C7293"/>
+                </a:solidFill>
+                <a:latin typeface="Calibri" pitchFamily="34" charset="0"/>
+                <a:ea typeface="Calibri" pitchFamily="34" charset="-122"/>
+                <a:cs typeface="Calibri" pitchFamily="34" charset="-120"/>
+              </a:rPr>
+              <a:t>GMT → local (−7h)</a:t>
+            </a:r>
+            <a:endParaRPr lang="en-US" sz="950" dirty="0"/>
+          </a:p>
+        </p:txBody>
+      </p:sp>
+      <p:sp>
+        <p:nvSpPr>
+          <p:cNvPr id="23" name="Shape 21"/>
           <p:cNvSpPr/>
           <p:nvPr/>
         </p:nvSpPr>
@@ -21394,7 +21482,7 @@
       </p:sp>
       <p:sp>
         <p:nvSpPr>
-          <p:cNvPr id="21" name="Text 19"/>
+          <p:cNvPr id="24" name="Text 22"/>
           <p:cNvSpPr/>
           <p:nvPr/>
         </p:nvSpPr>
@@ -21433,7 +21521,7 @@
       </p:sp>
       <p:sp>
         <p:nvSpPr>
-          <p:cNvPr id="22" name="Shape 20"/>
+          <p:cNvPr id="25" name="Shape 23"/>
           <p:cNvSpPr/>
           <p:nvPr/>
         </p:nvSpPr>
@@ -21453,7 +21541,7 @@
       </p:sp>
       <p:sp>
         <p:nvSpPr>
-          <p:cNvPr id="23" name="Text 21"/>
+          <p:cNvPr id="26" name="Text 24"/>
           <p:cNvSpPr/>
           <p:nvPr/>
         </p:nvSpPr>
@@ -21492,7 +21580,7 @@
       </p:sp>
       <p:sp>
         <p:nvSpPr>
-          <p:cNvPr id="24" name="Shape 22"/>
+          <p:cNvPr id="27" name="Shape 25"/>
           <p:cNvSpPr/>
           <p:nvPr/>
         </p:nvSpPr>
@@ -21517,7 +21605,7 @@
       </p:sp>
       <p:sp>
         <p:nvSpPr>
-          <p:cNvPr id="25" name="Text 23"/>
+          <p:cNvPr id="28" name="Text 26"/>
           <p:cNvSpPr/>
           <p:nvPr/>
         </p:nvSpPr>
@@ -21556,7 +21644,7 @@
       </p:sp>
       <p:sp>
         <p:nvSpPr>
-          <p:cNvPr id="26" name="Shape 24"/>
+          <p:cNvPr id="29" name="Shape 27"/>
           <p:cNvSpPr/>
           <p:nvPr/>
         </p:nvSpPr>
@@ -21581,7 +21669,7 @@
       </p:sp>
       <p:sp>
         <p:nvSpPr>
-          <p:cNvPr id="27" name="Text 25"/>
+          <p:cNvPr id="30" name="Text 28"/>
           <p:cNvSpPr/>
           <p:nvPr/>
         </p:nvSpPr>
@@ -21620,7 +21708,7 @@
       </p:sp>
       <p:sp>
         <p:nvSpPr>
-          <p:cNvPr id="28" name="Shape 26"/>
+          <p:cNvPr id="31" name="Shape 29"/>
           <p:cNvSpPr/>
           <p:nvPr/>
         </p:nvSpPr>
@@ -21643,7 +21731,7 @@
       </p:sp>
       <p:sp>
         <p:nvSpPr>
-          <p:cNvPr id="29" name="Text 27"/>
+          <p:cNvPr id="32" name="Text 30"/>
           <p:cNvSpPr/>
           <p:nvPr/>
         </p:nvSpPr>
@@ -21682,7 +21770,7 @@
       </p:sp>
       <p:sp>
         <p:nvSpPr>
-          <p:cNvPr id="30" name="Shape 28"/>
+          <p:cNvPr id="33" name="Shape 31"/>
           <p:cNvSpPr/>
           <p:nvPr/>
         </p:nvSpPr>
@@ -21705,7 +21793,7 @@
       </p:sp>
       <p:sp>
         <p:nvSpPr>
-          <p:cNvPr id="31" name="Text 29"/>
+          <p:cNvPr id="34" name="Text 32"/>
           <p:cNvSpPr/>
           <p:nvPr/>
         </p:nvSpPr>
@@ -21767,7 +21855,7 @@
       </p:sp>
       <p:sp>
         <p:nvSpPr>
-          <p:cNvPr id="32" name="Shape 30"/>
+          <p:cNvPr id="35" name="Shape 33"/>
           <p:cNvSpPr/>
           <p:nvPr/>
         </p:nvSpPr>
@@ -21791,7 +21879,7 @@
       </p:sp>
       <p:sp>
         <p:nvSpPr>
-          <p:cNvPr id="33" name="Text 31"/>
+          <p:cNvPr id="36" name="Text 34"/>
           <p:cNvSpPr/>
           <p:nvPr/>
         </p:nvSpPr>
@@ -21830,7 +21918,7 @@
       </p:sp>
       <p:sp>
         <p:nvSpPr>
-          <p:cNvPr id="34" name="Shape 32"/>
+          <p:cNvPr id="37" name="Shape 35"/>
           <p:cNvSpPr/>
           <p:nvPr/>
         </p:nvSpPr>
@@ -21850,7 +21938,7 @@
       </p:sp>
       <p:sp>
         <p:nvSpPr>
-          <p:cNvPr id="35" name="Text 33"/>
+          <p:cNvPr id="38" name="Text 36"/>
           <p:cNvSpPr/>
           <p:nvPr/>
         </p:nvSpPr>
@@ -21889,7 +21977,7 @@
       </p:sp>
       <p:sp>
         <p:nvSpPr>
-          <p:cNvPr id="36" name="Text 34"/>
+          <p:cNvPr id="39" name="Text 37"/>
           <p:cNvSpPr/>
           <p:nvPr/>
         </p:nvSpPr>
@@ -21928,7 +22016,7 @@
       </p:sp>
       <p:sp>
         <p:nvSpPr>
-          <p:cNvPr id="37" name="Shape 35"/>
+          <p:cNvPr id="40" name="Shape 38"/>
           <p:cNvSpPr/>
           <p:nvPr/>
         </p:nvSpPr>
@@ -21952,7 +22040,7 @@
       </p:sp>
       <p:sp>
         <p:nvSpPr>
-          <p:cNvPr id="38" name="Shape 36"/>
+          <p:cNvPr id="41" name="Shape 39"/>
           <p:cNvSpPr/>
           <p:nvPr/>
         </p:nvSpPr>
@@ -21977,7 +22065,7 @@
       </p:sp>
       <p:sp>
         <p:nvSpPr>
-          <p:cNvPr id="39" name="Text 37"/>
+          <p:cNvPr id="42" name="Text 40"/>
           <p:cNvSpPr/>
           <p:nvPr/>
         </p:nvSpPr>
@@ -22016,7 +22104,7 @@
       </p:sp>
       <p:sp>
         <p:nvSpPr>
-          <p:cNvPr id="40" name="Text 38"/>
+          <p:cNvPr id="43" name="Text 41"/>
           <p:cNvSpPr/>
           <p:nvPr/>
         </p:nvSpPr>
@@ -22055,7 +22143,7 @@
       </p:sp>
       <p:sp>
         <p:nvSpPr>
-          <p:cNvPr id="41" name="Shape 39"/>
+          <p:cNvPr id="44" name="Shape 42"/>
           <p:cNvSpPr/>
           <p:nvPr/>
         </p:nvSpPr>
@@ -22075,7 +22163,7 @@
       </p:sp>
       <p:sp>
         <p:nvSpPr>
-          <p:cNvPr id="42" name="Text 40"/>
+          <p:cNvPr id="45" name="Text 43"/>
           <p:cNvSpPr/>
           <p:nvPr/>
         </p:nvSpPr>
@@ -22114,7 +22202,7 @@
       </p:sp>
       <p:sp>
         <p:nvSpPr>
-          <p:cNvPr id="43" name="Shape 41"/>
+          <p:cNvPr id="46" name="Shape 44"/>
           <p:cNvSpPr/>
           <p:nvPr/>
         </p:nvSpPr>
@@ -22134,7 +22222,7 @@
       </p:sp>
       <p:sp>
         <p:nvSpPr>
-          <p:cNvPr id="44" name="Text 42"/>
+          <p:cNvPr id="47" name="Text 45"/>
           <p:cNvSpPr/>
           <p:nvPr/>
         </p:nvSpPr>
@@ -22173,7 +22261,7 @@
       </p:sp>
       <p:sp>
         <p:nvSpPr>
-          <p:cNvPr id="45" name="Shape 43"/>
+          <p:cNvPr id="48" name="Shape 46"/>
           <p:cNvSpPr/>
           <p:nvPr/>
         </p:nvSpPr>
@@ -22193,7 +22281,7 @@
       </p:sp>
       <p:sp>
         <p:nvSpPr>
-          <p:cNvPr id="46" name="Text 44"/>
+          <p:cNvPr id="49" name="Text 47"/>
           <p:cNvSpPr/>
           <p:nvPr/>
         </p:nvSpPr>
@@ -22232,7 +22320,7 @@
       </p:sp>
       <p:sp>
         <p:nvSpPr>
-          <p:cNvPr id="47" name="Shape 45"/>
+          <p:cNvPr id="50" name="Shape 48"/>
           <p:cNvSpPr/>
           <p:nvPr/>
         </p:nvSpPr>
@@ -22257,7 +22345,7 @@
       </p:sp>
       <p:sp>
         <p:nvSpPr>
-          <p:cNvPr id="48" name="Text 46"/>
+          <p:cNvPr id="51" name="Text 49"/>
           <p:cNvSpPr/>
           <p:nvPr/>
         </p:nvSpPr>
@@ -22296,7 +22384,7 @@
       </p:sp>
       <p:sp>
         <p:nvSpPr>
-          <p:cNvPr id="49" name="Shape 47"/>
+          <p:cNvPr id="52" name="Shape 50"/>
           <p:cNvSpPr/>
           <p:nvPr/>
         </p:nvSpPr>
@@ -22323,7 +22411,7 @@
       </p:sp>
       <p:sp>
         <p:nvSpPr>
-          <p:cNvPr id="50" name="Text 48"/>
+          <p:cNvPr id="53" name="Text 51"/>
           <p:cNvSpPr/>
           <p:nvPr/>
         </p:nvSpPr>
@@ -22362,7 +22450,7 @@
       </p:sp>
       <p:sp>
         <p:nvSpPr>
-          <p:cNvPr id="51" name="Text 49"/>
+          <p:cNvPr id="54" name="Text 52"/>
           <p:cNvSpPr/>
           <p:nvPr/>
         </p:nvSpPr>
@@ -22513,7 +22601,7 @@
       </p:sp>
       <p:sp>
         <p:nvSpPr>
-          <p:cNvPr id="52" name="Text 50"/>
+          <p:cNvPr id="55" name="Text 53"/>
           <p:cNvSpPr/>
           <p:nvPr/>
         </p:nvSpPr>
@@ -22650,7 +22738,7 @@
       </p:sp>
       <p:sp>
         <p:nvSpPr>
-          <p:cNvPr id="53" name="Shape 51"/>
+          <p:cNvPr id="56" name="Shape 54"/>
           <p:cNvSpPr/>
           <p:nvPr/>
         </p:nvSpPr>
@@ -22677,7 +22765,7 @@
       </p:sp>
       <p:sp>
         <p:nvSpPr>
-          <p:cNvPr id="54" name="Text 52"/>
+          <p:cNvPr id="57" name="Text 55"/>
           <p:cNvSpPr/>
           <p:nvPr/>
         </p:nvSpPr>
@@ -22753,7 +22841,7 @@
       </p:sp>
       <p:sp>
         <p:nvSpPr>
-          <p:cNvPr id="55" name="Text 53"/>
+          <p:cNvPr id="58" name="Text 56"/>
           <p:cNvSpPr/>
           <p:nvPr/>
         </p:nvSpPr>
@@ -22792,7 +22880,7 @@
       </p:sp>
       <p:sp>
         <p:nvSpPr>
-          <p:cNvPr id="56" name="Text 54"/>
+          <p:cNvPr id="59" name="Text 57"/>
           <p:cNvSpPr/>
           <p:nvPr/>
         </p:nvSpPr>

</xml_diff>

<commit_message>
temporal slide: use current Denver time (MDT, GMT-6h) as local example
Co-Authored-By: Claude Opus 4.6 <noreply@anthropic.com>
</commit_message>
<xml_diff>
--- a/docs/slides/dsupdt_guide.pptx
+++ b/docs/slides/dsupdt_guide.pptx
@@ -21429,8 +21429,8 @@
         </p:nvSpPr>
         <p:spPr>
           <a:xfrm>
-            <a:off x="3108960" y="2916936"/>
-            <a:ext cx="1737360" cy="237744"/>
+            <a:off x="3063240" y="2916936"/>
+            <a:ext cx="1828800" cy="237744"/>
           </a:xfrm>
           <a:prstGeom prst="rect">
             <a:avLst/>
@@ -21454,7 +21454,7 @@
                 <a:ea typeface="Calibri" pitchFamily="34" charset="-122"/>
                 <a:cs typeface="Calibri" pitchFamily="34" charset="-120"/>
               </a:rPr>
-              <a:t>GMT → local (−7h)</a:t>
+              <a:t>GMT → Denver (−6h)</a:t>
             </a:r>
             <a:endParaRPr lang="en-US" sz="950" dirty="0"/>
           </a:p>
@@ -22702,7 +22702,7 @@
                 <a:ea typeface="Calibri" pitchFamily="34" charset="-122"/>
                 <a:cs typeface="Calibri" pitchFamily="34" charset="-120"/>
               </a:rPr>
-              <a:t>) is server time (e.g. GMT), while </a:t>
+              <a:t>) is server time (GMT), while </a:t>
             </a:r>
             <a:pPr indent="0" marL="0">
               <a:buNone/>
@@ -22730,7 +22730,7 @@
                 <a:ea typeface="Calibri" pitchFamily="34" charset="-122"/>
                 <a:cs typeface="Calibri" pitchFamily="34" charset="-120"/>
               </a:rPr>
-              <a:t> is the local time the job runs — don’t mix the two.</a:t>
+              <a:t> is local time the job runs (Denver, MDT = GMT−6h in summer) — don’t mix the two.</a:t>
             </a:r>
             <a:endParaRPr lang="en-US" sz="1100" dirty="0"/>
           </a:p>

</xml_diff>

<commit_message>
temporal slide: shift all solid markers to local time
Apply the GMT->local shift to every data-end marker (not just End Date):
each date tick shows a dashed GMT ghost and a solid circle shifted left
to its local (Denver) time; axis extended left to cover them.

Co-Authored-By: Claude Opus 4.6 <noreply@anthropic.com>
</commit_message>
<xml_diff>
--- a/docs/slides/dsupdt_guide.pptx
+++ b/docs/slides/dsupdt_guide.pptx
@@ -21010,8 +21010,8 @@
         </p:nvSpPr>
         <p:spPr>
           <a:xfrm>
-            <a:off x="1005840" y="3246120"/>
-            <a:ext cx="9692640" cy="0"/>
+            <a:off x="365760" y="3246120"/>
+            <a:ext cx="10332720" cy="0"/>
           </a:xfrm>
           <a:prstGeom prst="line">
             <a:avLst/>
@@ -21148,6 +21148,31 @@
             <a:avLst/>
           </a:prstGeom>
           <a:solidFill>
+            <a:srgbClr val="FFFFFF"/>
+          </a:solidFill>
+          <a:ln w="25400">
+            <a:solidFill>
+              <a:srgbClr val="2E8B7A"/>
+            </a:solidFill>
+            <a:prstDash val="dash"/>
+          </a:ln>
+        </p:spPr>
+      </p:sp>
+      <p:sp>
+        <p:nvSpPr>
+          <p:cNvPr id="13" name="Shape 11"/>
+          <p:cNvSpPr/>
+          <p:nvPr/>
+        </p:nvSpPr>
+        <p:spPr>
+          <a:xfrm>
+            <a:off x="429768" y="3127248"/>
+            <a:ext cx="237744" cy="237744"/>
+          </a:xfrm>
+          <a:prstGeom prst="ellipse">
+            <a:avLst/>
+          </a:prstGeom>
+          <a:solidFill>
             <a:srgbClr val="2E8B7A"/>
           </a:solidFill>
           <a:ln/>
@@ -21155,7 +21180,31 @@
       </p:sp>
       <p:sp>
         <p:nvSpPr>
-          <p:cNvPr id="13" name="Text 11"/>
+          <p:cNvPr id="14" name="Shape 12"/>
+          <p:cNvSpPr/>
+          <p:nvPr/>
+        </p:nvSpPr>
+        <p:spPr>
+          <a:xfrm>
+            <a:off x="685800" y="3246120"/>
+            <a:ext cx="365760" cy="0"/>
+          </a:xfrm>
+          <a:prstGeom prst="line">
+            <a:avLst/>
+          </a:prstGeom>
+          <a:noFill/>
+          <a:ln w="15875">
+            <a:solidFill>
+              <a:srgbClr val="2E8B7A"/>
+            </a:solidFill>
+            <a:prstDash val="solid"/>
+            <a:headEnd type="triangle"/>
+          </a:ln>
+        </p:spPr>
+      </p:sp>
+      <p:sp>
+        <p:nvSpPr>
+          <p:cNvPr id="15" name="Text 13"/>
           <p:cNvSpPr/>
           <p:nvPr/>
         </p:nvSpPr>
@@ -21194,13 +21243,38 @@
       </p:sp>
       <p:sp>
         <p:nvSpPr>
-          <p:cNvPr id="14" name="Shape 12"/>
+          <p:cNvPr id="16" name="Shape 14"/>
           <p:cNvSpPr/>
           <p:nvPr/>
         </p:nvSpPr>
         <p:spPr>
           <a:xfrm>
             <a:off x="2624328" y="3127248"/>
+            <a:ext cx="237744" cy="237744"/>
+          </a:xfrm>
+          <a:prstGeom prst="ellipse">
+            <a:avLst/>
+          </a:prstGeom>
+          <a:solidFill>
+            <a:srgbClr val="FFFFFF"/>
+          </a:solidFill>
+          <a:ln w="25400">
+            <a:solidFill>
+              <a:srgbClr val="2E8B7A"/>
+            </a:solidFill>
+            <a:prstDash val="dash"/>
+          </a:ln>
+        </p:spPr>
+      </p:sp>
+      <p:sp>
+        <p:nvSpPr>
+          <p:cNvPr id="17" name="Shape 15"/>
+          <p:cNvSpPr/>
+          <p:nvPr/>
+        </p:nvSpPr>
+        <p:spPr>
+          <a:xfrm>
+            <a:off x="1984248" y="3127248"/>
             <a:ext cx="237744" cy="237744"/>
           </a:xfrm>
           <a:prstGeom prst="ellipse">
@@ -21214,7 +21288,31 @@
       </p:sp>
       <p:sp>
         <p:nvSpPr>
-          <p:cNvPr id="15" name="Text 13"/>
+          <p:cNvPr id="18" name="Shape 16"/>
+          <p:cNvSpPr/>
+          <p:nvPr/>
+        </p:nvSpPr>
+        <p:spPr>
+          <a:xfrm>
+            <a:off x="2240280" y="3246120"/>
+            <a:ext cx="365760" cy="0"/>
+          </a:xfrm>
+          <a:prstGeom prst="line">
+            <a:avLst/>
+          </a:prstGeom>
+          <a:noFill/>
+          <a:ln w="15875">
+            <a:solidFill>
+              <a:srgbClr val="2E8B7A"/>
+            </a:solidFill>
+            <a:prstDash val="solid"/>
+            <a:headEnd type="triangle"/>
+          </a:ln>
+        </p:spPr>
+      </p:sp>
+      <p:sp>
+        <p:nvSpPr>
+          <p:cNvPr id="19" name="Text 17"/>
           <p:cNvSpPr/>
           <p:nvPr/>
         </p:nvSpPr>
@@ -21253,108 +21351,7 @@
       </p:sp>
       <p:sp>
         <p:nvSpPr>
-          <p:cNvPr id="16" name="Text 14"/>
-          <p:cNvSpPr/>
-          <p:nvPr/>
-        </p:nvSpPr>
-        <p:spPr>
-          <a:xfrm>
-            <a:off x="3749040" y="3447288"/>
-            <a:ext cx="1097280" cy="274320"/>
-          </a:xfrm>
-          <a:prstGeom prst="rect">
-            <a:avLst/>
-          </a:prstGeom>
-          <a:noFill/>
-          <a:ln/>
-        </p:spPr>
-        <p:txBody>
-          <a:bodyPr wrap="square" lIns="0" tIns="0" rIns="0" bIns="0" rtlCol="0" anchor="ctr"/>
-          <a:lstStyle/>
-          <a:p>
-            <a:pPr algn="ctr" indent="0" marL="0">
-              <a:buNone/>
-            </a:pPr>
-            <a:r>
-              <a:rPr lang="en-US" sz="1100" dirty="0">
-                <a:solidFill>
-                  <a:srgbClr val="5C6E7C"/>
-                </a:solidFill>
-                <a:latin typeface="Courier New" pitchFamily="34" charset="0"/>
-                <a:ea typeface="Courier New" pitchFamily="34" charset="-122"/>
-                <a:cs typeface="Courier New" pitchFamily="34" charset="-120"/>
-              </a:rPr>
-              <a:t>07-11</a:t>
-            </a:r>
-            <a:endParaRPr lang="en-US" sz="1100" dirty="0"/>
-          </a:p>
-        </p:txBody>
-      </p:sp>
-      <p:sp>
-        <p:nvSpPr>
-          <p:cNvPr id="17" name="Shape 15"/>
-          <p:cNvSpPr/>
-          <p:nvPr/>
-        </p:nvSpPr>
-        <p:spPr>
-          <a:xfrm>
-            <a:off x="4297680" y="2286000"/>
-            <a:ext cx="0" cy="1508760"/>
-          </a:xfrm>
-          <a:prstGeom prst="line">
-            <a:avLst/>
-          </a:prstGeom>
-          <a:noFill/>
-          <a:ln w="19050">
-            <a:solidFill>
-              <a:srgbClr val="1C7293"/>
-            </a:solidFill>
-            <a:prstDash val="dash"/>
-          </a:ln>
-        </p:spPr>
-      </p:sp>
-      <p:sp>
-        <p:nvSpPr>
-          <p:cNvPr id="18" name="Text 16"/>
-          <p:cNvSpPr/>
-          <p:nvPr/>
-        </p:nvSpPr>
-        <p:spPr>
-          <a:xfrm>
-            <a:off x="3337560" y="1993392"/>
-            <a:ext cx="1920240" cy="274320"/>
-          </a:xfrm>
-          <a:prstGeom prst="rect">
-            <a:avLst/>
-          </a:prstGeom>
-          <a:noFill/>
-          <a:ln/>
-        </p:spPr>
-        <p:txBody>
-          <a:bodyPr wrap="square" lIns="0" tIns="0" rIns="0" bIns="0" rtlCol="0" anchor="ctr"/>
-          <a:lstStyle/>
-          <a:p>
-            <a:pPr algn="ctr" indent="0" marL="0">
-              <a:buNone/>
-            </a:pPr>
-            <a:r>
-              <a:rPr lang="en-US" sz="1100" b="1" dirty="0">
-                <a:solidFill>
-                  <a:srgbClr val="1C7293"/>
-                </a:solidFill>
-                <a:latin typeface="Calibri" pitchFamily="34" charset="0"/>
-                <a:ea typeface="Calibri" pitchFamily="34" charset="-122"/>
-                <a:cs typeface="Calibri" pitchFamily="34" charset="-120"/>
-              </a:rPr>
-              <a:t>End Date (GMT)</a:t>
-            </a:r>
-            <a:endParaRPr lang="en-US" sz="1100" dirty="0"/>
-          </a:p>
-        </p:txBody>
-      </p:sp>
-      <p:sp>
-        <p:nvSpPr>
-          <p:cNvPr id="19" name="Shape 17"/>
+          <p:cNvPr id="20" name="Shape 18"/>
           <p:cNvSpPr/>
           <p:nvPr/>
         </p:nvSpPr>
@@ -21379,7 +21376,7 @@
       </p:sp>
       <p:sp>
         <p:nvSpPr>
-          <p:cNvPr id="20" name="Shape 18"/>
+          <p:cNvPr id="21" name="Shape 19"/>
           <p:cNvSpPr/>
           <p:nvPr/>
         </p:nvSpPr>
@@ -21399,7 +21396,7 @@
       </p:sp>
       <p:sp>
         <p:nvSpPr>
-          <p:cNvPr id="21" name="Shape 19"/>
+          <p:cNvPr id="22" name="Shape 20"/>
           <p:cNvSpPr/>
           <p:nvPr/>
         </p:nvSpPr>
@@ -21412,7 +21409,7 @@
             <a:avLst/>
           </a:prstGeom>
           <a:noFill/>
-          <a:ln w="19050">
+          <a:ln w="15875">
             <a:solidFill>
               <a:srgbClr val="1C7293"/>
             </a:solidFill>
@@ -21423,7 +21420,108 @@
       </p:sp>
       <p:sp>
         <p:nvSpPr>
-          <p:cNvPr id="22" name="Text 20"/>
+          <p:cNvPr id="23" name="Text 21"/>
+          <p:cNvSpPr/>
+          <p:nvPr/>
+        </p:nvSpPr>
+        <p:spPr>
+          <a:xfrm>
+            <a:off x="3749040" y="3447288"/>
+            <a:ext cx="1097280" cy="274320"/>
+          </a:xfrm>
+          <a:prstGeom prst="rect">
+            <a:avLst/>
+          </a:prstGeom>
+          <a:noFill/>
+          <a:ln/>
+        </p:spPr>
+        <p:txBody>
+          <a:bodyPr wrap="square" lIns="0" tIns="0" rIns="0" bIns="0" rtlCol="0" anchor="ctr"/>
+          <a:lstStyle/>
+          <a:p>
+            <a:pPr algn="ctr" indent="0" marL="0">
+              <a:buNone/>
+            </a:pPr>
+            <a:r>
+              <a:rPr lang="en-US" sz="1100" dirty="0">
+                <a:solidFill>
+                  <a:srgbClr val="5C6E7C"/>
+                </a:solidFill>
+                <a:latin typeface="Courier New" pitchFamily="34" charset="0"/>
+                <a:ea typeface="Courier New" pitchFamily="34" charset="-122"/>
+                <a:cs typeface="Courier New" pitchFamily="34" charset="-120"/>
+              </a:rPr>
+              <a:t>07-11</a:t>
+            </a:r>
+            <a:endParaRPr lang="en-US" sz="1100" dirty="0"/>
+          </a:p>
+        </p:txBody>
+      </p:sp>
+      <p:sp>
+        <p:nvSpPr>
+          <p:cNvPr id="24" name="Shape 22"/>
+          <p:cNvSpPr/>
+          <p:nvPr/>
+        </p:nvSpPr>
+        <p:spPr>
+          <a:xfrm>
+            <a:off x="4297680" y="2286000"/>
+            <a:ext cx="0" cy="1508760"/>
+          </a:xfrm>
+          <a:prstGeom prst="line">
+            <a:avLst/>
+          </a:prstGeom>
+          <a:noFill/>
+          <a:ln w="19050">
+            <a:solidFill>
+              <a:srgbClr val="1C7293"/>
+            </a:solidFill>
+            <a:prstDash val="dash"/>
+          </a:ln>
+        </p:spPr>
+      </p:sp>
+      <p:sp>
+        <p:nvSpPr>
+          <p:cNvPr id="25" name="Text 23"/>
+          <p:cNvSpPr/>
+          <p:nvPr/>
+        </p:nvSpPr>
+        <p:spPr>
+          <a:xfrm>
+            <a:off x="3337560" y="1993392"/>
+            <a:ext cx="1920240" cy="274320"/>
+          </a:xfrm>
+          <a:prstGeom prst="rect">
+            <a:avLst/>
+          </a:prstGeom>
+          <a:noFill/>
+          <a:ln/>
+        </p:spPr>
+        <p:txBody>
+          <a:bodyPr wrap="square" lIns="0" tIns="0" rIns="0" bIns="0" rtlCol="0" anchor="ctr"/>
+          <a:lstStyle/>
+          <a:p>
+            <a:pPr algn="ctr" indent="0" marL="0">
+              <a:buNone/>
+            </a:pPr>
+            <a:r>
+              <a:rPr lang="en-US" sz="1100" b="1" dirty="0">
+                <a:solidFill>
+                  <a:srgbClr val="1C7293"/>
+                </a:solidFill>
+                <a:latin typeface="Calibri" pitchFamily="34" charset="0"/>
+                <a:ea typeface="Calibri" pitchFamily="34" charset="-122"/>
+                <a:cs typeface="Calibri" pitchFamily="34" charset="-120"/>
+              </a:rPr>
+              <a:t>End Date (GMT)</a:t>
+            </a:r>
+            <a:endParaRPr lang="en-US" sz="1100" dirty="0"/>
+          </a:p>
+        </p:txBody>
+      </p:sp>
+      <p:sp>
+        <p:nvSpPr>
+          <p:cNvPr id="26" name="Text 24"/>
           <p:cNvSpPr/>
           <p:nvPr/>
         </p:nvSpPr>
@@ -21462,13 +21560,38 @@
       </p:sp>
       <p:sp>
         <p:nvSpPr>
-          <p:cNvPr id="23" name="Shape 21"/>
+          <p:cNvPr id="27" name="Shape 25"/>
           <p:cNvSpPr/>
           <p:nvPr/>
         </p:nvSpPr>
         <p:spPr>
           <a:xfrm>
             <a:off x="5733288" y="3127248"/>
+            <a:ext cx="237744" cy="237744"/>
+          </a:xfrm>
+          <a:prstGeom prst="ellipse">
+            <a:avLst/>
+          </a:prstGeom>
+          <a:solidFill>
+            <a:srgbClr val="FFFFFF"/>
+          </a:solidFill>
+          <a:ln w="25400">
+            <a:solidFill>
+              <a:srgbClr val="E8963A"/>
+            </a:solidFill>
+            <a:prstDash val="dash"/>
+          </a:ln>
+        </p:spPr>
+      </p:sp>
+      <p:sp>
+        <p:nvSpPr>
+          <p:cNvPr id="28" name="Shape 26"/>
+          <p:cNvSpPr/>
+          <p:nvPr/>
+        </p:nvSpPr>
+        <p:spPr>
+          <a:xfrm>
+            <a:off x="5093208" y="3127248"/>
             <a:ext cx="237744" cy="237744"/>
           </a:xfrm>
           <a:prstGeom prst="ellipse">
@@ -21482,7 +21605,31 @@
       </p:sp>
       <p:sp>
         <p:nvSpPr>
-          <p:cNvPr id="24" name="Text 22"/>
+          <p:cNvPr id="29" name="Shape 27"/>
+          <p:cNvSpPr/>
+          <p:nvPr/>
+        </p:nvSpPr>
+        <p:spPr>
+          <a:xfrm>
+            <a:off x="5349240" y="3246120"/>
+            <a:ext cx="365760" cy="0"/>
+          </a:xfrm>
+          <a:prstGeom prst="line">
+            <a:avLst/>
+          </a:prstGeom>
+          <a:noFill/>
+          <a:ln w="15875">
+            <a:solidFill>
+              <a:srgbClr val="E8963A"/>
+            </a:solidFill>
+            <a:prstDash val="solid"/>
+            <a:headEnd type="triangle"/>
+          </a:ln>
+        </p:spPr>
+      </p:sp>
+      <p:sp>
+        <p:nvSpPr>
+          <p:cNvPr id="30" name="Text 28"/>
           <p:cNvSpPr/>
           <p:nvPr/>
         </p:nvSpPr>
@@ -21521,13 +21668,38 @@
       </p:sp>
       <p:sp>
         <p:nvSpPr>
-          <p:cNvPr id="25" name="Shape 23"/>
+          <p:cNvPr id="31" name="Shape 29"/>
           <p:cNvSpPr/>
           <p:nvPr/>
         </p:nvSpPr>
         <p:spPr>
           <a:xfrm>
             <a:off x="7287768" y="3127248"/>
+            <a:ext cx="237744" cy="237744"/>
+          </a:xfrm>
+          <a:prstGeom prst="ellipse">
+            <a:avLst/>
+          </a:prstGeom>
+          <a:solidFill>
+            <a:srgbClr val="FFFFFF"/>
+          </a:solidFill>
+          <a:ln w="25400">
+            <a:solidFill>
+              <a:srgbClr val="E8963A"/>
+            </a:solidFill>
+            <a:prstDash val="dash"/>
+          </a:ln>
+        </p:spPr>
+      </p:sp>
+      <p:sp>
+        <p:nvSpPr>
+          <p:cNvPr id="32" name="Shape 30"/>
+          <p:cNvSpPr/>
+          <p:nvPr/>
+        </p:nvSpPr>
+        <p:spPr>
+          <a:xfrm>
+            <a:off x="6647688" y="3127248"/>
             <a:ext cx="237744" cy="237744"/>
           </a:xfrm>
           <a:prstGeom prst="ellipse">
@@ -21541,7 +21713,31 @@
       </p:sp>
       <p:sp>
         <p:nvSpPr>
-          <p:cNvPr id="26" name="Text 24"/>
+          <p:cNvPr id="33" name="Shape 31"/>
+          <p:cNvSpPr/>
+          <p:nvPr/>
+        </p:nvSpPr>
+        <p:spPr>
+          <a:xfrm>
+            <a:off x="6903720" y="3246120"/>
+            <a:ext cx="365760" cy="0"/>
+          </a:xfrm>
+          <a:prstGeom prst="line">
+            <a:avLst/>
+          </a:prstGeom>
+          <a:noFill/>
+          <a:ln w="15875">
+            <a:solidFill>
+              <a:srgbClr val="E8963A"/>
+            </a:solidFill>
+            <a:prstDash val="solid"/>
+            <a:headEnd type="triangle"/>
+          </a:ln>
+        </p:spPr>
+      </p:sp>
+      <p:sp>
+        <p:nvSpPr>
+          <p:cNvPr id="34" name="Text 32"/>
           <p:cNvSpPr/>
           <p:nvPr/>
         </p:nvSpPr>
@@ -21580,7 +21776,7 @@
       </p:sp>
       <p:sp>
         <p:nvSpPr>
-          <p:cNvPr id="27" name="Shape 25"/>
+          <p:cNvPr id="35" name="Shape 33"/>
           <p:cNvSpPr/>
           <p:nvPr/>
         </p:nvSpPr>
@@ -21605,7 +21801,7 @@
       </p:sp>
       <p:sp>
         <p:nvSpPr>
-          <p:cNvPr id="28" name="Text 26"/>
+          <p:cNvPr id="36" name="Text 34"/>
           <p:cNvSpPr/>
           <p:nvPr/>
         </p:nvSpPr>
@@ -21644,7 +21840,7 @@
       </p:sp>
       <p:sp>
         <p:nvSpPr>
-          <p:cNvPr id="29" name="Shape 27"/>
+          <p:cNvPr id="37" name="Shape 35"/>
           <p:cNvSpPr/>
           <p:nvPr/>
         </p:nvSpPr>
@@ -21669,7 +21865,7 @@
       </p:sp>
       <p:sp>
         <p:nvSpPr>
-          <p:cNvPr id="30" name="Text 28"/>
+          <p:cNvPr id="38" name="Text 36"/>
           <p:cNvSpPr/>
           <p:nvPr/>
         </p:nvSpPr>
@@ -21708,7 +21904,7 @@
       </p:sp>
       <p:sp>
         <p:nvSpPr>
-          <p:cNvPr id="31" name="Shape 29"/>
+          <p:cNvPr id="39" name="Shape 37"/>
           <p:cNvSpPr/>
           <p:nvPr/>
         </p:nvSpPr>
@@ -21731,7 +21927,7 @@
       </p:sp>
       <p:sp>
         <p:nvSpPr>
-          <p:cNvPr id="32" name="Text 30"/>
+          <p:cNvPr id="40" name="Text 38"/>
           <p:cNvSpPr/>
           <p:nvPr/>
         </p:nvSpPr>
@@ -21770,7 +21966,7 @@
       </p:sp>
       <p:sp>
         <p:nvSpPr>
-          <p:cNvPr id="33" name="Shape 31"/>
+          <p:cNvPr id="41" name="Shape 39"/>
           <p:cNvSpPr/>
           <p:nvPr/>
         </p:nvSpPr>
@@ -21793,7 +21989,7 @@
       </p:sp>
       <p:sp>
         <p:nvSpPr>
-          <p:cNvPr id="34" name="Text 32"/>
+          <p:cNvPr id="42" name="Text 40"/>
           <p:cNvSpPr/>
           <p:nvPr/>
         </p:nvSpPr>
@@ -21855,7 +22051,7 @@
       </p:sp>
       <p:sp>
         <p:nvSpPr>
-          <p:cNvPr id="35" name="Shape 33"/>
+          <p:cNvPr id="43" name="Shape 41"/>
           <p:cNvSpPr/>
           <p:nvPr/>
         </p:nvSpPr>
@@ -21879,7 +22075,7 @@
       </p:sp>
       <p:sp>
         <p:nvSpPr>
-          <p:cNvPr id="36" name="Text 34"/>
+          <p:cNvPr id="44" name="Text 42"/>
           <p:cNvSpPr/>
           <p:nvPr/>
         </p:nvSpPr>
@@ -21918,7 +22114,7 @@
       </p:sp>
       <p:sp>
         <p:nvSpPr>
-          <p:cNvPr id="37" name="Shape 35"/>
+          <p:cNvPr id="45" name="Shape 43"/>
           <p:cNvSpPr/>
           <p:nvPr/>
         </p:nvSpPr>
@@ -21938,7 +22134,7 @@
       </p:sp>
       <p:sp>
         <p:nvSpPr>
-          <p:cNvPr id="38" name="Text 36"/>
+          <p:cNvPr id="46" name="Text 44"/>
           <p:cNvSpPr/>
           <p:nvPr/>
         </p:nvSpPr>
@@ -21977,7 +22173,7 @@
       </p:sp>
       <p:sp>
         <p:nvSpPr>
-          <p:cNvPr id="39" name="Text 37"/>
+          <p:cNvPr id="47" name="Text 45"/>
           <p:cNvSpPr/>
           <p:nvPr/>
         </p:nvSpPr>
@@ -22016,7 +22212,7 @@
       </p:sp>
       <p:sp>
         <p:nvSpPr>
-          <p:cNvPr id="40" name="Shape 38"/>
+          <p:cNvPr id="48" name="Shape 46"/>
           <p:cNvSpPr/>
           <p:nvPr/>
         </p:nvSpPr>
@@ -22040,7 +22236,7 @@
       </p:sp>
       <p:sp>
         <p:nvSpPr>
-          <p:cNvPr id="41" name="Shape 39"/>
+          <p:cNvPr id="49" name="Shape 47"/>
           <p:cNvSpPr/>
           <p:nvPr/>
         </p:nvSpPr>
@@ -22065,7 +22261,7 @@
       </p:sp>
       <p:sp>
         <p:nvSpPr>
-          <p:cNvPr id="42" name="Text 40"/>
+          <p:cNvPr id="50" name="Text 48"/>
           <p:cNvSpPr/>
           <p:nvPr/>
         </p:nvSpPr>
@@ -22104,7 +22300,7 @@
       </p:sp>
       <p:sp>
         <p:nvSpPr>
-          <p:cNvPr id="43" name="Text 41"/>
+          <p:cNvPr id="51" name="Text 49"/>
           <p:cNvSpPr/>
           <p:nvPr/>
         </p:nvSpPr>
@@ -22143,7 +22339,7 @@
       </p:sp>
       <p:sp>
         <p:nvSpPr>
-          <p:cNvPr id="44" name="Shape 42"/>
+          <p:cNvPr id="52" name="Shape 50"/>
           <p:cNvSpPr/>
           <p:nvPr/>
         </p:nvSpPr>
@@ -22163,7 +22359,7 @@
       </p:sp>
       <p:sp>
         <p:nvSpPr>
-          <p:cNvPr id="45" name="Text 43"/>
+          <p:cNvPr id="53" name="Text 51"/>
           <p:cNvSpPr/>
           <p:nvPr/>
         </p:nvSpPr>
@@ -22202,7 +22398,7 @@
       </p:sp>
       <p:sp>
         <p:nvSpPr>
-          <p:cNvPr id="46" name="Shape 44"/>
+          <p:cNvPr id="54" name="Shape 52"/>
           <p:cNvSpPr/>
           <p:nvPr/>
         </p:nvSpPr>
@@ -22222,7 +22418,7 @@
       </p:sp>
       <p:sp>
         <p:nvSpPr>
-          <p:cNvPr id="47" name="Text 45"/>
+          <p:cNvPr id="55" name="Text 53"/>
           <p:cNvSpPr/>
           <p:nvPr/>
         </p:nvSpPr>
@@ -22261,7 +22457,7 @@
       </p:sp>
       <p:sp>
         <p:nvSpPr>
-          <p:cNvPr id="48" name="Shape 46"/>
+          <p:cNvPr id="56" name="Shape 54"/>
           <p:cNvSpPr/>
           <p:nvPr/>
         </p:nvSpPr>
@@ -22281,7 +22477,7 @@
       </p:sp>
       <p:sp>
         <p:nvSpPr>
-          <p:cNvPr id="49" name="Text 47"/>
+          <p:cNvPr id="57" name="Text 55"/>
           <p:cNvSpPr/>
           <p:nvPr/>
         </p:nvSpPr>
@@ -22320,7 +22516,7 @@
       </p:sp>
       <p:sp>
         <p:nvSpPr>
-          <p:cNvPr id="50" name="Shape 48"/>
+          <p:cNvPr id="58" name="Shape 56"/>
           <p:cNvSpPr/>
           <p:nvPr/>
         </p:nvSpPr>
@@ -22345,7 +22541,7 @@
       </p:sp>
       <p:sp>
         <p:nvSpPr>
-          <p:cNvPr id="51" name="Text 49"/>
+          <p:cNvPr id="59" name="Text 57"/>
           <p:cNvSpPr/>
           <p:nvPr/>
         </p:nvSpPr>
@@ -22384,7 +22580,7 @@
       </p:sp>
       <p:sp>
         <p:nvSpPr>
-          <p:cNvPr id="52" name="Shape 50"/>
+          <p:cNvPr id="60" name="Shape 58"/>
           <p:cNvSpPr/>
           <p:nvPr/>
         </p:nvSpPr>
@@ -22411,7 +22607,7 @@
       </p:sp>
       <p:sp>
         <p:nvSpPr>
-          <p:cNvPr id="53" name="Text 51"/>
+          <p:cNvPr id="61" name="Text 59"/>
           <p:cNvSpPr/>
           <p:nvPr/>
         </p:nvSpPr>
@@ -22450,7 +22646,7 @@
       </p:sp>
       <p:sp>
         <p:nvSpPr>
-          <p:cNvPr id="54" name="Text 52"/>
+          <p:cNvPr id="62" name="Text 60"/>
           <p:cNvSpPr/>
           <p:nvPr/>
         </p:nvSpPr>
@@ -22601,7 +22797,7 @@
       </p:sp>
       <p:sp>
         <p:nvSpPr>
-          <p:cNvPr id="55" name="Text 53"/>
+          <p:cNvPr id="63" name="Text 61"/>
           <p:cNvSpPr/>
           <p:nvPr/>
         </p:nvSpPr>
@@ -22738,7 +22934,7 @@
       </p:sp>
       <p:sp>
         <p:nvSpPr>
-          <p:cNvPr id="56" name="Shape 54"/>
+          <p:cNvPr id="64" name="Shape 62"/>
           <p:cNvSpPr/>
           <p:nvPr/>
         </p:nvSpPr>
@@ -22765,7 +22961,7 @@
       </p:sp>
       <p:sp>
         <p:nvSpPr>
-          <p:cNvPr id="57" name="Text 55"/>
+          <p:cNvPr id="65" name="Text 63"/>
           <p:cNvSpPr/>
           <p:nvPr/>
         </p:nvSpPr>
@@ -22841,7 +23037,7 @@
       </p:sp>
       <p:sp>
         <p:nvSpPr>
-          <p:cNvPr id="58" name="Text 56"/>
+          <p:cNvPr id="66" name="Text 64"/>
           <p:cNvSpPr/>
           <p:nvPr/>
         </p:nvSpPr>
@@ -22880,7 +23076,7 @@
       </p:sp>
       <p:sp>
         <p:nvSpPr>
-          <p:cNvPr id="59" name="Text 57"/>
+          <p:cNvPr id="67" name="Text 65"/>
           <p:cNvSpPr/>
           <p:nvPr/>
         </p:nvSpPr>

</xml_diff>

<commit_message>
apply GMT to local time shift to hollow not-yet-due markers on slide 18
Mirror the timezone shift used for solid data-end circles onto the hollow
not-yet-due/now markers (07-14 and now) so the whole timeline consistently
shows the GMT ghost tick and the local-shifted marker.

Co-Authored-By: Claude Opus 4.6 <noreply@anthropic.com>
</commit_message>
<xml_diff>
--- a/docs/slides/dsupdt_guide.pptx
+++ b/docs/slides/dsupdt_guide.pptx
@@ -21791,62 +21791,23 @@
           <a:solidFill>
             <a:srgbClr val="FFFFFF"/>
           </a:solidFill>
-          <a:ln w="25400">
+          <a:ln w="19050">
             <a:solidFill>
               <a:srgbClr val="5C6E7C"/>
             </a:solidFill>
-            <a:prstDash val="solid"/>
+            <a:prstDash val="dash"/>
           </a:ln>
         </p:spPr>
       </p:sp>
       <p:sp>
         <p:nvSpPr>
-          <p:cNvPr id="36" name="Text 34"/>
-          <p:cNvSpPr/>
-          <p:nvPr/>
-        </p:nvSpPr>
-        <p:spPr>
-          <a:xfrm>
-            <a:off x="8412480" y="3447288"/>
-            <a:ext cx="1097280" cy="274320"/>
-          </a:xfrm>
-          <a:prstGeom prst="rect">
-            <a:avLst/>
-          </a:prstGeom>
-          <a:noFill/>
-          <a:ln/>
-        </p:spPr>
-        <p:txBody>
-          <a:bodyPr wrap="square" lIns="0" tIns="0" rIns="0" bIns="0" rtlCol="0" anchor="ctr"/>
-          <a:lstStyle/>
-          <a:p>
-            <a:pPr algn="ctr" indent="0" marL="0">
-              <a:buNone/>
-            </a:pPr>
-            <a:r>
-              <a:rPr lang="en-US" sz="1100" dirty="0">
-                <a:solidFill>
-                  <a:srgbClr val="5C6E7C"/>
-                </a:solidFill>
-                <a:latin typeface="Courier New" pitchFamily="34" charset="0"/>
-                <a:ea typeface="Courier New" pitchFamily="34" charset="-122"/>
-                <a:cs typeface="Courier New" pitchFamily="34" charset="-120"/>
-              </a:rPr>
-              <a:t>07-14</a:t>
-            </a:r>
-            <a:endParaRPr lang="en-US" sz="1100" dirty="0"/>
-          </a:p>
-        </p:txBody>
-      </p:sp>
-      <p:sp>
-        <p:nvSpPr>
-          <p:cNvPr id="37" name="Shape 35"/>
-          <p:cNvSpPr/>
-          <p:nvPr/>
-        </p:nvSpPr>
-        <p:spPr>
-          <a:xfrm>
-            <a:off x="10396728" y="3127248"/>
+          <p:cNvPr id="36" name="Shape 34"/>
+          <p:cNvSpPr/>
+          <p:nvPr/>
+        </p:nvSpPr>
+        <p:spPr>
+          <a:xfrm>
+            <a:off x="8202168" y="3127248"/>
             <a:ext cx="237744" cy="237744"/>
           </a:xfrm>
           <a:prstGeom prst="ellipse">
@@ -21865,13 +21826,37 @@
       </p:sp>
       <p:sp>
         <p:nvSpPr>
+          <p:cNvPr id="37" name="Shape 35"/>
+          <p:cNvSpPr/>
+          <p:nvPr/>
+        </p:nvSpPr>
+        <p:spPr>
+          <a:xfrm>
+            <a:off x="8458200" y="3246120"/>
+            <a:ext cx="365760" cy="0"/>
+          </a:xfrm>
+          <a:prstGeom prst="line">
+            <a:avLst/>
+          </a:prstGeom>
+          <a:noFill/>
+          <a:ln w="15875">
+            <a:solidFill>
+              <a:srgbClr val="5C6E7C"/>
+            </a:solidFill>
+            <a:prstDash val="solid"/>
+            <a:headEnd type="triangle"/>
+          </a:ln>
+        </p:spPr>
+      </p:sp>
+      <p:sp>
+        <p:nvSpPr>
           <p:cNvPr id="38" name="Text 36"/>
           <p:cNvSpPr/>
           <p:nvPr/>
         </p:nvSpPr>
         <p:spPr>
           <a:xfrm>
-            <a:off x="9966960" y="3447288"/>
+            <a:off x="8412480" y="3447288"/>
             <a:ext cx="1097280" cy="274320"/>
           </a:xfrm>
           <a:prstGeom prst="rect">
@@ -21896,6 +21881,119 @@
                 <a:ea typeface="Courier New" pitchFamily="34" charset="-122"/>
                 <a:cs typeface="Courier New" pitchFamily="34" charset="-120"/>
               </a:rPr>
+              <a:t>07-14</a:t>
+            </a:r>
+            <a:endParaRPr lang="en-US" sz="1100" dirty="0"/>
+          </a:p>
+        </p:txBody>
+      </p:sp>
+      <p:sp>
+        <p:nvSpPr>
+          <p:cNvPr id="39" name="Shape 37"/>
+          <p:cNvSpPr/>
+          <p:nvPr/>
+        </p:nvSpPr>
+        <p:spPr>
+          <a:xfrm>
+            <a:off x="10396728" y="3127248"/>
+            <a:ext cx="237744" cy="237744"/>
+          </a:xfrm>
+          <a:prstGeom prst="ellipse">
+            <a:avLst/>
+          </a:prstGeom>
+          <a:solidFill>
+            <a:srgbClr val="FFFFFF"/>
+          </a:solidFill>
+          <a:ln w="19050">
+            <a:solidFill>
+              <a:srgbClr val="5C6E7C"/>
+            </a:solidFill>
+            <a:prstDash val="dash"/>
+          </a:ln>
+        </p:spPr>
+      </p:sp>
+      <p:sp>
+        <p:nvSpPr>
+          <p:cNvPr id="40" name="Shape 38"/>
+          <p:cNvSpPr/>
+          <p:nvPr/>
+        </p:nvSpPr>
+        <p:spPr>
+          <a:xfrm>
+            <a:off x="9756648" y="3127248"/>
+            <a:ext cx="237744" cy="237744"/>
+          </a:xfrm>
+          <a:prstGeom prst="ellipse">
+            <a:avLst/>
+          </a:prstGeom>
+          <a:solidFill>
+            <a:srgbClr val="FFFFFF"/>
+          </a:solidFill>
+          <a:ln w="25400">
+            <a:solidFill>
+              <a:srgbClr val="5C6E7C"/>
+            </a:solidFill>
+            <a:prstDash val="solid"/>
+          </a:ln>
+        </p:spPr>
+      </p:sp>
+      <p:sp>
+        <p:nvSpPr>
+          <p:cNvPr id="41" name="Shape 39"/>
+          <p:cNvSpPr/>
+          <p:nvPr/>
+        </p:nvSpPr>
+        <p:spPr>
+          <a:xfrm>
+            <a:off x="10012680" y="3246120"/>
+            <a:ext cx="365760" cy="0"/>
+          </a:xfrm>
+          <a:prstGeom prst="line">
+            <a:avLst/>
+          </a:prstGeom>
+          <a:noFill/>
+          <a:ln w="15875">
+            <a:solidFill>
+              <a:srgbClr val="5C6E7C"/>
+            </a:solidFill>
+            <a:prstDash val="solid"/>
+            <a:headEnd type="triangle"/>
+          </a:ln>
+        </p:spPr>
+      </p:sp>
+      <p:sp>
+        <p:nvSpPr>
+          <p:cNvPr id="42" name="Text 40"/>
+          <p:cNvSpPr/>
+          <p:nvPr/>
+        </p:nvSpPr>
+        <p:spPr>
+          <a:xfrm>
+            <a:off x="9966960" y="3447288"/>
+            <a:ext cx="1097280" cy="274320"/>
+          </a:xfrm>
+          <a:prstGeom prst="rect">
+            <a:avLst/>
+          </a:prstGeom>
+          <a:noFill/>
+          <a:ln/>
+        </p:spPr>
+        <p:txBody>
+          <a:bodyPr wrap="square" lIns="0" tIns="0" rIns="0" bIns="0" rtlCol="0" anchor="ctr"/>
+          <a:lstStyle/>
+          <a:p>
+            <a:pPr algn="ctr" indent="0" marL="0">
+              <a:buNone/>
+            </a:pPr>
+            <a:r>
+              <a:rPr lang="en-US" sz="1100" dirty="0">
+                <a:solidFill>
+                  <a:srgbClr val="5C6E7C"/>
+                </a:solidFill>
+                <a:latin typeface="Courier New" pitchFamily="34" charset="0"/>
+                <a:ea typeface="Courier New" pitchFamily="34" charset="-122"/>
+                <a:cs typeface="Courier New" pitchFamily="34" charset="-120"/>
+              </a:rPr>
               <a:t>07-15</a:t>
             </a:r>
             <a:endParaRPr lang="en-US" sz="1100" dirty="0"/>
@@ -21904,7 +22002,7 @@
       </p:sp>
       <p:sp>
         <p:nvSpPr>
-          <p:cNvPr id="39" name="Shape 37"/>
+          <p:cNvPr id="43" name="Shape 41"/>
           <p:cNvSpPr/>
           <p:nvPr/>
         </p:nvSpPr>
@@ -21927,7 +22025,7 @@
       </p:sp>
       <p:sp>
         <p:nvSpPr>
-          <p:cNvPr id="40" name="Text 38"/>
+          <p:cNvPr id="44" name="Text 42"/>
           <p:cNvSpPr/>
           <p:nvPr/>
         </p:nvSpPr>
@@ -21966,7 +22064,7 @@
       </p:sp>
       <p:sp>
         <p:nvSpPr>
-          <p:cNvPr id="41" name="Shape 39"/>
+          <p:cNvPr id="45" name="Shape 43"/>
           <p:cNvSpPr/>
           <p:nvPr/>
         </p:nvSpPr>
@@ -21989,7 +22087,7 @@
       </p:sp>
       <p:sp>
         <p:nvSpPr>
-          <p:cNvPr id="42" name="Text 40"/>
+          <p:cNvPr id="46" name="Text 44"/>
           <p:cNvSpPr/>
           <p:nvPr/>
         </p:nvSpPr>
@@ -22051,7 +22149,7 @@
       </p:sp>
       <p:sp>
         <p:nvSpPr>
-          <p:cNvPr id="43" name="Shape 41"/>
+          <p:cNvPr id="47" name="Shape 45"/>
           <p:cNvSpPr/>
           <p:nvPr/>
         </p:nvSpPr>
@@ -22075,7 +22173,7 @@
       </p:sp>
       <p:sp>
         <p:nvSpPr>
-          <p:cNvPr id="44" name="Text 42"/>
+          <p:cNvPr id="48" name="Text 46"/>
           <p:cNvSpPr/>
           <p:nvPr/>
         </p:nvSpPr>
@@ -22114,7 +22212,7 @@
       </p:sp>
       <p:sp>
         <p:nvSpPr>
-          <p:cNvPr id="45" name="Shape 43"/>
+          <p:cNvPr id="49" name="Shape 47"/>
           <p:cNvSpPr/>
           <p:nvPr/>
         </p:nvSpPr>
@@ -22134,7 +22232,7 @@
       </p:sp>
       <p:sp>
         <p:nvSpPr>
-          <p:cNvPr id="46" name="Text 44"/>
+          <p:cNvPr id="50" name="Text 48"/>
           <p:cNvSpPr/>
           <p:nvPr/>
         </p:nvSpPr>
@@ -22173,7 +22271,7 @@
       </p:sp>
       <p:sp>
         <p:nvSpPr>
-          <p:cNvPr id="47" name="Text 45"/>
+          <p:cNvPr id="51" name="Text 49"/>
           <p:cNvSpPr/>
           <p:nvPr/>
         </p:nvSpPr>
@@ -22212,7 +22310,7 @@
       </p:sp>
       <p:sp>
         <p:nvSpPr>
-          <p:cNvPr id="48" name="Shape 46"/>
+          <p:cNvPr id="52" name="Shape 50"/>
           <p:cNvSpPr/>
           <p:nvPr/>
         </p:nvSpPr>
@@ -22236,7 +22334,7 @@
       </p:sp>
       <p:sp>
         <p:nvSpPr>
-          <p:cNvPr id="49" name="Shape 47"/>
+          <p:cNvPr id="53" name="Shape 51"/>
           <p:cNvSpPr/>
           <p:nvPr/>
         </p:nvSpPr>
@@ -22261,7 +22359,7 @@
       </p:sp>
       <p:sp>
         <p:nvSpPr>
-          <p:cNvPr id="50" name="Text 48"/>
+          <p:cNvPr id="54" name="Text 52"/>
           <p:cNvSpPr/>
           <p:nvPr/>
         </p:nvSpPr>
@@ -22300,7 +22398,7 @@
       </p:sp>
       <p:sp>
         <p:nvSpPr>
-          <p:cNvPr id="51" name="Text 49"/>
+          <p:cNvPr id="55" name="Text 53"/>
           <p:cNvSpPr/>
           <p:nvPr/>
         </p:nvSpPr>
@@ -22339,7 +22437,7 @@
       </p:sp>
       <p:sp>
         <p:nvSpPr>
-          <p:cNvPr id="52" name="Shape 50"/>
+          <p:cNvPr id="56" name="Shape 54"/>
           <p:cNvSpPr/>
           <p:nvPr/>
         </p:nvSpPr>
@@ -22359,7 +22457,7 @@
       </p:sp>
       <p:sp>
         <p:nvSpPr>
-          <p:cNvPr id="53" name="Text 51"/>
+          <p:cNvPr id="57" name="Text 55"/>
           <p:cNvSpPr/>
           <p:nvPr/>
         </p:nvSpPr>
@@ -22398,7 +22496,7 @@
       </p:sp>
       <p:sp>
         <p:nvSpPr>
-          <p:cNvPr id="54" name="Shape 52"/>
+          <p:cNvPr id="58" name="Shape 56"/>
           <p:cNvSpPr/>
           <p:nvPr/>
         </p:nvSpPr>
@@ -22418,7 +22516,7 @@
       </p:sp>
       <p:sp>
         <p:nvSpPr>
-          <p:cNvPr id="55" name="Text 53"/>
+          <p:cNvPr id="59" name="Text 57"/>
           <p:cNvSpPr/>
           <p:nvPr/>
         </p:nvSpPr>
@@ -22457,7 +22555,7 @@
       </p:sp>
       <p:sp>
         <p:nvSpPr>
-          <p:cNvPr id="56" name="Shape 54"/>
+          <p:cNvPr id="60" name="Shape 58"/>
           <p:cNvSpPr/>
           <p:nvPr/>
         </p:nvSpPr>
@@ -22477,7 +22575,7 @@
       </p:sp>
       <p:sp>
         <p:nvSpPr>
-          <p:cNvPr id="57" name="Text 55"/>
+          <p:cNvPr id="61" name="Text 59"/>
           <p:cNvSpPr/>
           <p:nvPr/>
         </p:nvSpPr>
@@ -22516,7 +22614,7 @@
       </p:sp>
       <p:sp>
         <p:nvSpPr>
-          <p:cNvPr id="58" name="Shape 56"/>
+          <p:cNvPr id="62" name="Shape 60"/>
           <p:cNvSpPr/>
           <p:nvPr/>
         </p:nvSpPr>
@@ -22541,7 +22639,7 @@
       </p:sp>
       <p:sp>
         <p:nvSpPr>
-          <p:cNvPr id="59" name="Text 57"/>
+          <p:cNvPr id="63" name="Text 61"/>
           <p:cNvSpPr/>
           <p:nvPr/>
         </p:nvSpPr>
@@ -22580,7 +22678,7 @@
       </p:sp>
       <p:sp>
         <p:nvSpPr>
-          <p:cNvPr id="60" name="Shape 58"/>
+          <p:cNvPr id="64" name="Shape 62"/>
           <p:cNvSpPr/>
           <p:nvPr/>
         </p:nvSpPr>
@@ -22607,7 +22705,7 @@
       </p:sp>
       <p:sp>
         <p:nvSpPr>
-          <p:cNvPr id="61" name="Text 59"/>
+          <p:cNvPr id="65" name="Text 63"/>
           <p:cNvSpPr/>
           <p:nvPr/>
         </p:nvSpPr>
@@ -22646,7 +22744,7 @@
       </p:sp>
       <p:sp>
         <p:nvSpPr>
-          <p:cNvPr id="62" name="Text 60"/>
+          <p:cNvPr id="66" name="Text 64"/>
           <p:cNvSpPr/>
           <p:nvPr/>
         </p:nvSpPr>
@@ -22797,7 +22895,7 @@
       </p:sp>
       <p:sp>
         <p:nvSpPr>
-          <p:cNvPr id="63" name="Text 61"/>
+          <p:cNvPr id="67" name="Text 65"/>
           <p:cNvSpPr/>
           <p:nvPr/>
         </p:nvSpPr>
@@ -22934,7 +23032,7 @@
       </p:sp>
       <p:sp>
         <p:nvSpPr>
-          <p:cNvPr id="64" name="Shape 62"/>
+          <p:cNvPr id="68" name="Shape 66"/>
           <p:cNvSpPr/>
           <p:nvPr/>
         </p:nvSpPr>
@@ -22961,7 +23059,7 @@
       </p:sp>
       <p:sp>
         <p:nvSpPr>
-          <p:cNvPr id="65" name="Text 63"/>
+          <p:cNvPr id="69" name="Text 67"/>
           <p:cNvSpPr/>
           <p:nvPr/>
         </p:nvSpPr>
@@ -23037,7 +23135,7 @@
       </p:sp>
       <p:sp>
         <p:nvSpPr>
-          <p:cNvPr id="66" name="Text 64"/>
+          <p:cNvPr id="70" name="Text 68"/>
           <p:cNvSpPr/>
           <p:nvPr/>
         </p:nvSpPr>
@@ -23076,7 +23174,7 @@
       </p:sp>
       <p:sp>
         <p:nvSpPr>
-          <p:cNvPr id="67" name="Text 65"/>
+          <p:cNvPr id="71" name="Text 69"/>
           <p:cNvSpPr/>
           <p:nvPr/>
         </p:nvSpPr>

</xml_diff>

<commit_message>
shorten DI so 07-14 becomes due/archivable on slide 18
Move the due cutoff (now - DI) right of 07-14 and mark 07-14 as an
archived/re-archived-this-run circle; leave only the current period (now)
as not-yet-due. DI arrow length reduced to match.

Co-Authored-By: Claude Opus 4.6 <noreply@anthropic.com>
</commit_message>
<xml_diff>
--- a/docs/slides/dsupdt_guide.pptx
+++ b/docs/slides/dsupdt_guide.pptx
@@ -21791,6 +21791,114 @@
           <a:solidFill>
             <a:srgbClr val="FFFFFF"/>
           </a:solidFill>
+          <a:ln w="25400">
+            <a:solidFill>
+              <a:srgbClr val="E8963A"/>
+            </a:solidFill>
+            <a:prstDash val="dash"/>
+          </a:ln>
+        </p:spPr>
+      </p:sp>
+      <p:sp>
+        <p:nvSpPr>
+          <p:cNvPr id="36" name="Shape 34"/>
+          <p:cNvSpPr/>
+          <p:nvPr/>
+        </p:nvSpPr>
+        <p:spPr>
+          <a:xfrm>
+            <a:off x="8202168" y="3127248"/>
+            <a:ext cx="237744" cy="237744"/>
+          </a:xfrm>
+          <a:prstGeom prst="ellipse">
+            <a:avLst/>
+          </a:prstGeom>
+          <a:solidFill>
+            <a:srgbClr val="E8963A"/>
+          </a:solidFill>
+          <a:ln/>
+        </p:spPr>
+      </p:sp>
+      <p:sp>
+        <p:nvSpPr>
+          <p:cNvPr id="37" name="Shape 35"/>
+          <p:cNvSpPr/>
+          <p:nvPr/>
+        </p:nvSpPr>
+        <p:spPr>
+          <a:xfrm>
+            <a:off x="8458200" y="3246120"/>
+            <a:ext cx="365760" cy="0"/>
+          </a:xfrm>
+          <a:prstGeom prst="line">
+            <a:avLst/>
+          </a:prstGeom>
+          <a:noFill/>
+          <a:ln w="15875">
+            <a:solidFill>
+              <a:srgbClr val="E8963A"/>
+            </a:solidFill>
+            <a:prstDash val="solid"/>
+            <a:headEnd type="triangle"/>
+          </a:ln>
+        </p:spPr>
+      </p:sp>
+      <p:sp>
+        <p:nvSpPr>
+          <p:cNvPr id="38" name="Text 36"/>
+          <p:cNvSpPr/>
+          <p:nvPr/>
+        </p:nvSpPr>
+        <p:spPr>
+          <a:xfrm>
+            <a:off x="8412480" y="3447288"/>
+            <a:ext cx="1097280" cy="274320"/>
+          </a:xfrm>
+          <a:prstGeom prst="rect">
+            <a:avLst/>
+          </a:prstGeom>
+          <a:noFill/>
+          <a:ln/>
+        </p:spPr>
+        <p:txBody>
+          <a:bodyPr wrap="square" lIns="0" tIns="0" rIns="0" bIns="0" rtlCol="0" anchor="ctr"/>
+          <a:lstStyle/>
+          <a:p>
+            <a:pPr algn="ctr" indent="0" marL="0">
+              <a:buNone/>
+            </a:pPr>
+            <a:r>
+              <a:rPr lang="en-US" sz="1100" dirty="0">
+                <a:solidFill>
+                  <a:srgbClr val="5C6E7C"/>
+                </a:solidFill>
+                <a:latin typeface="Courier New" pitchFamily="34" charset="0"/>
+                <a:ea typeface="Courier New" pitchFamily="34" charset="-122"/>
+                <a:cs typeface="Courier New" pitchFamily="34" charset="-120"/>
+              </a:rPr>
+              <a:t>07-14</a:t>
+            </a:r>
+            <a:endParaRPr lang="en-US" sz="1100" dirty="0"/>
+          </a:p>
+        </p:txBody>
+      </p:sp>
+      <p:sp>
+        <p:nvSpPr>
+          <p:cNvPr id="39" name="Shape 37"/>
+          <p:cNvSpPr/>
+          <p:nvPr/>
+        </p:nvSpPr>
+        <p:spPr>
+          <a:xfrm>
+            <a:off x="10396728" y="3127248"/>
+            <a:ext cx="237744" cy="237744"/>
+          </a:xfrm>
+          <a:prstGeom prst="ellipse">
+            <a:avLst/>
+          </a:prstGeom>
+          <a:solidFill>
+            <a:srgbClr val="FFFFFF"/>
+          </a:solidFill>
           <a:ln w="19050">
             <a:solidFill>
               <a:srgbClr val="5C6E7C"/>
@@ -21801,13 +21909,13 @@
       </p:sp>
       <p:sp>
         <p:nvSpPr>
-          <p:cNvPr id="36" name="Shape 34"/>
-          <p:cNvSpPr/>
-          <p:nvPr/>
-        </p:nvSpPr>
-        <p:spPr>
-          <a:xfrm>
-            <a:off x="8202168" y="3127248"/>
+          <p:cNvPr id="40" name="Shape 38"/>
+          <p:cNvSpPr/>
+          <p:nvPr/>
+        </p:nvSpPr>
+        <p:spPr>
+          <a:xfrm>
+            <a:off x="9756648" y="3127248"/>
             <a:ext cx="237744" cy="237744"/>
           </a:xfrm>
           <a:prstGeom prst="ellipse">
@@ -21826,13 +21934,13 @@
       </p:sp>
       <p:sp>
         <p:nvSpPr>
-          <p:cNvPr id="37" name="Shape 35"/>
-          <p:cNvSpPr/>
-          <p:nvPr/>
-        </p:nvSpPr>
-        <p:spPr>
-          <a:xfrm>
-            <a:off x="8458200" y="3246120"/>
+          <p:cNvPr id="41" name="Shape 39"/>
+          <p:cNvSpPr/>
+          <p:nvPr/>
+        </p:nvSpPr>
+        <p:spPr>
+          <a:xfrm>
+            <a:off x="10012680" y="3246120"/>
             <a:ext cx="365760" cy="0"/>
           </a:xfrm>
           <a:prstGeom prst="line">
@@ -21850,119 +21958,6 @@
       </p:sp>
       <p:sp>
         <p:nvSpPr>
-          <p:cNvPr id="38" name="Text 36"/>
-          <p:cNvSpPr/>
-          <p:nvPr/>
-        </p:nvSpPr>
-        <p:spPr>
-          <a:xfrm>
-            <a:off x="8412480" y="3447288"/>
-            <a:ext cx="1097280" cy="274320"/>
-          </a:xfrm>
-          <a:prstGeom prst="rect">
-            <a:avLst/>
-          </a:prstGeom>
-          <a:noFill/>
-          <a:ln/>
-        </p:spPr>
-        <p:txBody>
-          <a:bodyPr wrap="square" lIns="0" tIns="0" rIns="0" bIns="0" rtlCol="0" anchor="ctr"/>
-          <a:lstStyle/>
-          <a:p>
-            <a:pPr algn="ctr" indent="0" marL="0">
-              <a:buNone/>
-            </a:pPr>
-            <a:r>
-              <a:rPr lang="en-US" sz="1100" dirty="0">
-                <a:solidFill>
-                  <a:srgbClr val="5C6E7C"/>
-                </a:solidFill>
-                <a:latin typeface="Courier New" pitchFamily="34" charset="0"/>
-                <a:ea typeface="Courier New" pitchFamily="34" charset="-122"/>
-                <a:cs typeface="Courier New" pitchFamily="34" charset="-120"/>
-              </a:rPr>
-              <a:t>07-14</a:t>
-            </a:r>
-            <a:endParaRPr lang="en-US" sz="1100" dirty="0"/>
-          </a:p>
-        </p:txBody>
-      </p:sp>
-      <p:sp>
-        <p:nvSpPr>
-          <p:cNvPr id="39" name="Shape 37"/>
-          <p:cNvSpPr/>
-          <p:nvPr/>
-        </p:nvSpPr>
-        <p:spPr>
-          <a:xfrm>
-            <a:off x="10396728" y="3127248"/>
-            <a:ext cx="237744" cy="237744"/>
-          </a:xfrm>
-          <a:prstGeom prst="ellipse">
-            <a:avLst/>
-          </a:prstGeom>
-          <a:solidFill>
-            <a:srgbClr val="FFFFFF"/>
-          </a:solidFill>
-          <a:ln w="19050">
-            <a:solidFill>
-              <a:srgbClr val="5C6E7C"/>
-            </a:solidFill>
-            <a:prstDash val="dash"/>
-          </a:ln>
-        </p:spPr>
-      </p:sp>
-      <p:sp>
-        <p:nvSpPr>
-          <p:cNvPr id="40" name="Shape 38"/>
-          <p:cNvSpPr/>
-          <p:nvPr/>
-        </p:nvSpPr>
-        <p:spPr>
-          <a:xfrm>
-            <a:off x="9756648" y="3127248"/>
-            <a:ext cx="237744" cy="237744"/>
-          </a:xfrm>
-          <a:prstGeom prst="ellipse">
-            <a:avLst/>
-          </a:prstGeom>
-          <a:solidFill>
-            <a:srgbClr val="FFFFFF"/>
-          </a:solidFill>
-          <a:ln w="25400">
-            <a:solidFill>
-              <a:srgbClr val="5C6E7C"/>
-            </a:solidFill>
-            <a:prstDash val="solid"/>
-          </a:ln>
-        </p:spPr>
-      </p:sp>
-      <p:sp>
-        <p:nvSpPr>
-          <p:cNvPr id="41" name="Shape 39"/>
-          <p:cNvSpPr/>
-          <p:nvPr/>
-        </p:nvSpPr>
-        <p:spPr>
-          <a:xfrm>
-            <a:off x="10012680" y="3246120"/>
-            <a:ext cx="365760" cy="0"/>
-          </a:xfrm>
-          <a:prstGeom prst="line">
-            <a:avLst/>
-          </a:prstGeom>
-          <a:noFill/>
-          <a:ln w="15875">
-            <a:solidFill>
-              <a:srgbClr val="5C6E7C"/>
-            </a:solidFill>
-            <a:prstDash val="solid"/>
-            <a:headEnd type="triangle"/>
-          </a:ln>
-        </p:spPr>
-      </p:sp>
-      <p:sp>
-        <p:nvSpPr>
           <p:cNvPr id="42" name="Text 40"/>
           <p:cNvSpPr/>
           <p:nvPr/>
@@ -22070,7 +22065,7 @@
         </p:nvSpPr>
         <p:spPr>
           <a:xfrm>
-            <a:off x="8339328" y="2286000"/>
+            <a:off x="9738360" y="2286000"/>
             <a:ext cx="0" cy="1508760"/>
           </a:xfrm>
           <a:prstGeom prst="line">
@@ -22093,7 +22088,7 @@
         </p:nvSpPr>
         <p:spPr>
           <a:xfrm>
-            <a:off x="7196328" y="1847088"/>
+            <a:off x="8595360" y="1847088"/>
             <a:ext cx="2286000" cy="420624"/>
           </a:xfrm>
           <a:prstGeom prst="rect">
@@ -22156,7 +22151,7 @@
         <p:spPr>
           <a:xfrm>
             <a:off x="4297680" y="3813048"/>
-            <a:ext cx="2176272" cy="0"/>
+            <a:ext cx="777240" cy="0"/>
           </a:xfrm>
           <a:prstGeom prst="line">
             <a:avLst/>

</xml_diff>

<commit_message>
anchor DI/next-due to local time end period on slide 18
Start the DI arrow at the local (TZ-shifted) End Date circle and measure the
due cutoff from local now, so next-due = local period end + DI consistently.

Co-Authored-By: Claude Opus 4.6 <noreply@anthropic.com>
</commit_message>
<xml_diff>
--- a/docs/slides/dsupdt_guide.pptx
+++ b/docs/slides/dsupdt_guide.pptx
@@ -22065,7 +22065,7 @@
         </p:nvSpPr>
         <p:spPr>
           <a:xfrm>
-            <a:off x="9738360" y="2286000"/>
+            <a:off x="9098280" y="2286000"/>
             <a:ext cx="0" cy="1508760"/>
           </a:xfrm>
           <a:prstGeom prst="line">
@@ -22088,7 +22088,7 @@
         </p:nvSpPr>
         <p:spPr>
           <a:xfrm>
-            <a:off x="8595360" y="1847088"/>
+            <a:off x="7955280" y="1847088"/>
             <a:ext cx="2286000" cy="420624"/>
           </a:xfrm>
           <a:prstGeom prst="rect">
@@ -22150,7 +22150,7 @@
         </p:nvSpPr>
         <p:spPr>
           <a:xfrm>
-            <a:off x="4297680" y="3813048"/>
+            <a:off x="3657600" y="3813048"/>
             <a:ext cx="777240" cy="0"/>
           </a:xfrm>
           <a:prstGeom prst="line">
@@ -22174,8 +22174,8 @@
         </p:nvSpPr>
         <p:spPr>
           <a:xfrm>
-            <a:off x="4160520" y="3904488"/>
-            <a:ext cx="3566160" cy="274320"/>
+            <a:off x="3520440" y="3904488"/>
+            <a:ext cx="4023360" cy="274320"/>
           </a:xfrm>
           <a:prstGeom prst="rect">
             <a:avLst/>
@@ -22199,7 +22199,7 @@
                 <a:ea typeface="Calibri" pitchFamily="34" charset="-122"/>
                 <a:cs typeface="Calibri" pitchFamily="34" charset="-120"/>
               </a:rPr>
-              <a:t>DI — next-due = period end + DI</a:t>
+              <a:t>DI — next-due = local period end + DI</a:t>
             </a:r>
             <a:endParaRPr lang="en-US" sz="1100" dirty="0"/>
           </a:p>

</xml_diff>

<commit_message>
place now at local time so cutoff and DI lengths match on slide 18
Move the now reference line (and CT marker) to the local now position so the
now-to-cutoff gap equals the DI arrow length; reposition the now label to
avoid the due-cutoff label.

Co-Authored-By: Claude Opus 4.6 <noreply@anthropic.com>
</commit_message>
<xml_diff>
--- a/docs/slides/dsupdt_guide.pptx
+++ b/docs/slides/dsupdt_guide.pptx
@@ -22003,7 +22003,7 @@
         </p:nvSpPr>
         <p:spPr>
           <a:xfrm>
-            <a:off x="10515600" y="2286000"/>
+            <a:off x="9875520" y="2286000"/>
             <a:ext cx="0" cy="1508760"/>
           </a:xfrm>
           <a:prstGeom prst="line">
@@ -22026,8 +22026,8 @@
         </p:nvSpPr>
         <p:spPr>
           <a:xfrm>
-            <a:off x="9966960" y="1993392"/>
-            <a:ext cx="1097280" cy="274320"/>
+            <a:off x="9985248" y="1993392"/>
+            <a:ext cx="914400" cy="274320"/>
           </a:xfrm>
           <a:prstGeom prst="rect">
             <a:avLst/>
@@ -22039,7 +22039,7 @@
           <a:bodyPr wrap="square" lIns="0" tIns="0" rIns="0" bIns="0" rtlCol="0" anchor="ctr"/>
           <a:lstStyle/>
           <a:p>
-            <a:pPr algn="ctr" indent="0" marL="0">
+            <a:pPr algn="l" indent="0" marL="0">
               <a:buNone/>
             </a:pPr>
             <a:r>
@@ -22213,7 +22213,7 @@
         </p:nvSpPr>
         <p:spPr>
           <a:xfrm>
-            <a:off x="10424160" y="3950208"/>
+            <a:off x="9784080" y="3950208"/>
             <a:ext cx="182880" cy="182880"/>
           </a:xfrm>
           <a:prstGeom prst="rect">
@@ -22233,7 +22233,7 @@
         </p:nvSpPr>
         <p:spPr>
           <a:xfrm>
-            <a:off x="8458200" y="3922776"/>
+            <a:off x="7818120" y="3922776"/>
             <a:ext cx="1828800" cy="237744"/>
           </a:xfrm>
           <a:prstGeom prst="rect">
@@ -22272,7 +22272,7 @@
         </p:nvSpPr>
         <p:spPr>
           <a:xfrm>
-            <a:off x="8458200" y="4142232"/>
+            <a:off x="7818120" y="4142232"/>
             <a:ext cx="1828800" cy="201168"/>
           </a:xfrm>
           <a:prstGeom prst="rect">
@@ -22311,8 +22311,8 @@
         </p:nvSpPr>
         <p:spPr>
           <a:xfrm>
-            <a:off x="10643616" y="4041648"/>
-            <a:ext cx="1133856" cy="0"/>
+            <a:off x="10003536" y="4041648"/>
+            <a:ext cx="1773936" cy="0"/>
           </a:xfrm>
           <a:prstGeom prst="line">
             <a:avLst/>
@@ -22360,7 +22360,7 @@
         </p:nvSpPr>
         <p:spPr>
           <a:xfrm>
-            <a:off x="10607040" y="3749040"/>
+            <a:off x="9966960" y="3749040"/>
             <a:ext cx="1463040" cy="219456"/>
           </a:xfrm>
           <a:prstGeom prst="rect">

</xml_diff>

<commit_message>
end VI look-back window at local now on slide 18
Shift the VI band into the local frame (moved tzsh definition earlier) so the
look-back window ends at local now instead of extending past it to the GMT tick.

Co-Authored-By: Claude Opus 4.6 <noreply@anthropic.com>
</commit_message>
<xml_diff>
--- a/docs/slides/dsupdt_guide.pptx
+++ b/docs/slides/dsupdt_guide.pptx
@@ -20944,7 +20944,7 @@
         </p:nvSpPr>
         <p:spPr>
           <a:xfrm>
-            <a:off x="4133088" y="2331720"/>
+            <a:off x="3493008" y="2331720"/>
             <a:ext cx="6547104" cy="1417320"/>
           </a:xfrm>
           <a:prstGeom prst="roundRect">
@@ -20971,7 +20971,7 @@
         </p:nvSpPr>
         <p:spPr>
           <a:xfrm>
-            <a:off x="4270248" y="2395728"/>
+            <a:off x="3630168" y="2395728"/>
             <a:ext cx="6272784" cy="292608"/>
           </a:xfrm>
           <a:prstGeom prst="rect">

</xml_diff>

<commit_message>
size the next-CT arrow to exactly one FQ on slide 18
Set next CT = CT + dx so the +FQ arrow spans one frequency, matching the FQ
bracket, instead of a fixed x position.

Co-Authored-By: Claude Opus 4.6 <noreply@anthropic.com>
</commit_message>
<xml_diff>
--- a/docs/slides/dsupdt_guide.pptx
+++ b/docs/slides/dsupdt_guide.pptx
@@ -22312,7 +22312,7 @@
         <p:spPr>
           <a:xfrm>
             <a:off x="10003536" y="4041648"/>
-            <a:ext cx="1773936" cy="0"/>
+            <a:ext cx="1316736" cy="0"/>
           </a:xfrm>
           <a:prstGeom prst="line">
             <a:avLst/>
@@ -22335,7 +22335,7 @@
         </p:nvSpPr>
         <p:spPr>
           <a:xfrm>
-            <a:off x="11804904" y="3959352"/>
+            <a:off x="11347704" y="3959352"/>
             <a:ext cx="164592" cy="164592"/>
           </a:xfrm>
           <a:prstGeom prst="rect">
@@ -22399,7 +22399,7 @@
         </p:nvSpPr>
         <p:spPr>
           <a:xfrm>
-            <a:off x="11201400" y="4133088"/>
+            <a:off x="10744200" y="4133088"/>
             <a:ext cx="1371600" cy="219456"/>
           </a:xfrm>
           <a:prstGeom prst="rect">

</xml_diff>

<commit_message>
distinguish the three frequency meanings across the deck
Clarify that dcupdt -FQ is the update frequency, dlupdt -FQ is the local
data-file frequency, and drupdt -TI is the remote-file frequency (only when
many remotes map to one local file), in the record tables and overview cards.

Co-Authored-By: Claude Opus 4.6 <noreply@anthropic.com>
</commit_message>
<xml_diff>
--- a/docs/slides/dsupdt_guide.pptx
+++ b/docs/slides/dsupdt_guide.pptx
@@ -4987,7 +4987,7 @@
                           <a:ea typeface="Calibri" pitchFamily="34" charset="-122"/>
                           <a:cs typeface="Calibri" pitchFamily="34" charset="-120"/>
                         </a:rPr>
-                        <a:t>data cadence, e.g. 1M, 1W, 6H</a:t>
+                        <a:t>local data-file frequency, e.g. 1M, 6H</a:t>
                       </a:r>
                       <a:endParaRPr lang="en-US" sz="1150" dirty="0">
                         <a:latin typeface="Calibri" charset="0"/>
@@ -9388,7 +9388,7 @@
                           <a:ea typeface="Calibri" pitchFamily="34" charset="-122"/>
                           <a:cs typeface="Calibri" pitchFamily="34" charset="-120"/>
                         </a:rPr>
-                        <a:t>one name per sub-period, e.g. 6H, 5D</a:t>
+                        <a:t>remote-file frequency — only when many remotes → one local, e.g. 6H, 5D</a:t>
                       </a:r>
                       <a:endParaRPr lang="en-US" sz="1250" dirty="0">
                         <a:latin typeface="Calibri" charset="0"/>
@@ -34393,7 +34393,7 @@
                 <a:ea typeface="Calibri" pitchFamily="34" charset="-122"/>
                 <a:cs typeface="Calibri" pitchFamily="34" charset="-120"/>
               </a:rPr>
-              <a:t>Frequency, offset, retry, valid interval</a:t>
+              <a:t>Update frequency, offset, retry, valid interval</a:t>
             </a:r>
             <a:endParaRPr lang="en-US" sz="1350" dirty="0"/>
           </a:p>
@@ -35004,7 +35004,7 @@
                 <a:ea typeface="Calibri" pitchFamily="34" charset="-122"/>
                 <a:cs typeface="Calibri" pitchFamily="34" charset="-120"/>
               </a:rPr>
-              <a:t>Time interval for sub-periods</a:t>
+              <a:t>Remote-file frequency (many → one)</a:t>
             </a:r>
             <a:endParaRPr lang="en-US" sz="1350" dirty="0"/>
           </a:p>
@@ -39606,7 +39606,7 @@
                 <a:ea typeface="Calibri" pitchFamily="34" charset="-122"/>
                 <a:cs typeface="Calibri" pitchFamily="34" charset="-120"/>
               </a:rPr>
-              <a:t>frequency, next-due, actions, e-mail &amp; error controls</a:t>
+              <a:t>update frequency, next-due, actions, e-mail &amp; error controls</a:t>
             </a:r>
             <a:endParaRPr lang="en-US" sz="1200" dirty="0"/>
           </a:p>
@@ -41151,7 +41151,7 @@
                           <a:ea typeface="Calibri" pitchFamily="34" charset="-122"/>
                           <a:cs typeface="Calibri" pitchFamily="34" charset="-120"/>
                         </a:rPr>
-                        <a:t>how often, e.g. 1W, 1M, 6H, 1M/3</a:t>
+                        <a:t>update frequency — how often updates run, e.g. 1W, 1M, 1M/3</a:t>
                       </a:r>
                       <a:endParaRPr lang="en-US" sz="1250" dirty="0">
                         <a:latin typeface="Calibri" charset="0"/>

</xml_diff>

<commit_message>
make repo/PyPI/Read the Docs links real clickable hyperlinks
</commit_message>
<xml_diff>
--- a/docs/slides/dsupdt_guide.pptx
+++ b/docs/slides/dsupdt_guide.pptx
@@ -35314,7 +35314,72 @@
                 <a:ea typeface="Calibri" pitchFamily="34" charset="-122"/>
                 <a:cs typeface="Calibri" pitchFamily="34" charset="-120"/>
               </a:rPr>
-              <a:t>   •   full guide: dsupdt.usg   •   docs: gdex-docs-dsupdt.readthedocs.io   •   repo: github.com/NCAR/rda-python-dsupdt</a:t>
+              <a:t>   •   full guide: dsupdt.usg   •   docs: </a:t>
+            </a:r>
+            <a:pPr indent="0" marL="0">
+              <a:lnSpc>
+                <a:spcPct val="110000"/>
+              </a:lnSpc>
+              <a:buNone/>
+            </a:pPr>
+            <a:r>
+              <a:rPr lang="en-US" sz="1300" u="sng" dirty="0">
+                <a:solidFill>
+                  <a:srgbClr val="8FB0C9"/>
+                </a:solidFill>
+                <a:latin typeface="Calibri" pitchFamily="34" charset="0"/>
+                <a:ea typeface="Calibri" pitchFamily="34" charset="-122"/>
+                <a:cs typeface="Calibri" pitchFamily="34" charset="-120"/>
+                <a:hlinkClick r:id="rId1" invalidUrl="" action="" tgtFrame="" tooltip="" history="1" highlightClick="0" endSnd="0">
+                  <a:extLst>
+                    <a:ext uri="{A12FA001-AC4F-418D-AE19-62706E023703}">
+                      <ahyp:hlinkClr xmlns:ahyp="http://schemas.microsoft.com/office/drawing/2018/hyperlinkcolor" val="tx"/>
+                    </a:ext>
+                  </a:extLst>
+                </a:hlinkClick>
+              </a:rPr>
+              <a:t>gdex-docs-dsupdt.readthedocs.io</a:t>
+            </a:r>
+            <a:pPr indent="0" marL="0">
+              <a:lnSpc>
+                <a:spcPct val="110000"/>
+              </a:lnSpc>
+              <a:buNone/>
+            </a:pPr>
+            <a:r>
+              <a:rPr lang="en-US" sz="1300" dirty="0">
+                <a:solidFill>
+                  <a:srgbClr val="8FB0C9"/>
+                </a:solidFill>
+                <a:latin typeface="Calibri" pitchFamily="34" charset="0"/>
+                <a:ea typeface="Calibri" pitchFamily="34" charset="-122"/>
+                <a:cs typeface="Calibri" pitchFamily="34" charset="-120"/>
+              </a:rPr>
+              <a:t>   •   repo: </a:t>
+            </a:r>
+            <a:pPr indent="0" marL="0">
+              <a:lnSpc>
+                <a:spcPct val="110000"/>
+              </a:lnSpc>
+              <a:buNone/>
+            </a:pPr>
+            <a:r>
+              <a:rPr lang="en-US" sz="1300" u="sng" dirty="0">
+                <a:solidFill>
+                  <a:srgbClr val="8FB0C9"/>
+                </a:solidFill>
+                <a:latin typeface="Calibri" pitchFamily="34" charset="0"/>
+                <a:ea typeface="Calibri" pitchFamily="34" charset="-122"/>
+                <a:cs typeface="Calibri" pitchFamily="34" charset="-120"/>
+                <a:hlinkClick r:id="rId2" invalidUrl="" action="" tgtFrame="" tooltip="" history="1" highlightClick="0" endSnd="0">
+                  <a:extLst>
+                    <a:ext uri="{A12FA001-AC4F-418D-AE19-62706E023703}">
+                      <ahyp:hlinkClr xmlns:ahyp="http://schemas.microsoft.com/office/drawing/2018/hyperlinkcolor" val="tx"/>
+                    </a:ext>
+                  </a:extLst>
+                </a:hlinkClick>
+              </a:rPr>
+              <a:t>github.com/NCAR/rda-python-dsupdt</a:t>
             </a:r>
             <a:endParaRPr lang="en-US" sz="1300" dirty="0"/>
           </a:p>
@@ -35635,13 +35700,20 @@
               <a:buNone/>
             </a:pPr>
             <a:r>
-              <a:rPr lang="en-US" sz="1300" dirty="0">
+              <a:rPr lang="en-US" sz="1300" u="sng" dirty="0">
                 <a:solidFill>
                   <a:srgbClr val="8FB0C9"/>
                 </a:solidFill>
                 <a:latin typeface="Calibri" pitchFamily="34" charset="0"/>
                 <a:ea typeface="Calibri" pitchFamily="34" charset="-122"/>
                 <a:cs typeface="Calibri" pitchFamily="34" charset="-120"/>
+                <a:hlinkClick r:id="rId1" invalidUrl="" action="" tgtFrame="" tooltip="" history="1" highlightClick="0" endSnd="0">
+                  <a:extLst>
+                    <a:ext uri="{A12FA001-AC4F-418D-AE19-62706E023703}">
+                      <ahyp:hlinkClr xmlns:ahyp="http://schemas.microsoft.com/office/drawing/2018/hyperlinkcolor" val="tx"/>
+                    </a:ext>
+                  </a:extLst>
+                </a:hlinkClick>
               </a:rPr>
               <a:t>github.com/NCAR/rda-python-dsupdt</a:t>
             </a:r>
@@ -36093,13 +36165,20 @@
               <a:buNone/>
             </a:pPr>
             <a:r>
-              <a:rPr lang="en-US" sz="1050" b="1" dirty="0">
+              <a:rPr lang="en-US" sz="1050" b="1" u="sng" dirty="0">
                 <a:solidFill>
                   <a:srgbClr val="065A82"/>
                 </a:solidFill>
                 <a:latin typeface="Courier New" pitchFamily="34" charset="0"/>
                 <a:ea typeface="Courier New" pitchFamily="34" charset="-122"/>
                 <a:cs typeface="Courier New" pitchFamily="34" charset="-120"/>
+                <a:hlinkClick r:id="rId1" invalidUrl="" action="" tgtFrame="" tooltip="" history="1" highlightClick="0" endSnd="0">
+                  <a:extLst>
+                    <a:ext uri="{A12FA001-AC4F-418D-AE19-62706E023703}">
+                      <ahyp:hlinkClr xmlns:ahyp="http://schemas.microsoft.com/office/drawing/2018/hyperlinkcolor" val="tx"/>
+                    </a:ext>
+                  </a:extLst>
+                </a:hlinkClick>
               </a:rPr>
               <a:t>github.com/NCAR/rda-python-dsupdt</a:t>
             </a:r>
@@ -36424,13 +36503,20 @@
               <a:buNone/>
             </a:pPr>
             <a:r>
-              <a:rPr lang="en-US" sz="1050" b="1" dirty="0">
+              <a:rPr lang="en-US" sz="1050" b="1" u="sng" dirty="0">
                 <a:solidFill>
                   <a:srgbClr val="065A82"/>
                 </a:solidFill>
                 <a:latin typeface="Courier New" pitchFamily="34" charset="0"/>
                 <a:ea typeface="Courier New" pitchFamily="34" charset="-122"/>
                 <a:cs typeface="Courier New" pitchFamily="34" charset="-120"/>
+                <a:hlinkClick r:id="rId2" invalidUrl="" action="" tgtFrame="" tooltip="" history="1" highlightClick="0" endSnd="0">
+                  <a:extLst>
+                    <a:ext uri="{A12FA001-AC4F-418D-AE19-62706E023703}">
+                      <ahyp:hlinkClr xmlns:ahyp="http://schemas.microsoft.com/office/drawing/2018/hyperlinkcolor" val="tx"/>
+                    </a:ext>
+                  </a:extLst>
+                </a:hlinkClick>
               </a:rPr>
               <a:t>pypi.org/project/rda-python-dsupdt</a:t>
             </a:r>
@@ -36694,13 +36780,20 @@
               <a:buNone/>
             </a:pPr>
             <a:r>
-              <a:rPr lang="en-US" sz="1050" b="1" dirty="0">
+              <a:rPr lang="en-US" sz="1050" b="1" u="sng" dirty="0">
                 <a:solidFill>
                   <a:srgbClr val="065A82"/>
                 </a:solidFill>
                 <a:latin typeface="Courier New" pitchFamily="34" charset="0"/>
                 <a:ea typeface="Courier New" pitchFamily="34" charset="-122"/>
                 <a:cs typeface="Courier New" pitchFamily="34" charset="-120"/>
+                <a:hlinkClick r:id="rId3" invalidUrl="" action="" tgtFrame="" tooltip="" history="1" highlightClick="0" endSnd="0">
+                  <a:extLst>
+                    <a:ext uri="{A12FA001-AC4F-418D-AE19-62706E023703}">
+                      <ahyp:hlinkClr xmlns:ahyp="http://schemas.microsoft.com/office/drawing/2018/hyperlinkcolor" val="tx"/>
+                    </a:ext>
+                  </a:extLst>
+                </a:hlinkClick>
               </a:rPr>
               <a:t>gdex-docs-dsupdt.readthedocs.io</a:t>
             </a:r>

</xml_diff>

<commit_message>
deck: add GDEX lockup (bottom NSF|NCAR cropped), $GDEXHOME rename, -WD date-pattern note
- feature cropped GDEX lockup logo at uniform size on title/recap/questions slides
- rename $DSSHOME -> $GDEXHOME on env slide and in dsupdt.usg
- document -WD date-pattern requirement for hourly files reused across days, with example
</commit_message>
<xml_diff>
--- a/docs/slides/dsupdt_guide.pptx
+++ b/docs/slides/dsupdt_guide.pptx
@@ -3124,134 +3124,33 @@
           </a:prstGeom>
         </p:spPr>
       </p:pic>
-      <p:sp>
-        <p:nvSpPr>
-          <p:cNvPr id="3" name="Shape 0"/>
-          <p:cNvSpPr/>
-          <p:nvPr/>
-        </p:nvSpPr>
-        <p:spPr>
-          <a:xfrm>
-            <a:off x="7772400" y="-365760"/>
-            <a:ext cx="3108960" cy="3108960"/>
-          </a:xfrm>
-          <a:prstGeom prst="ellipse">
-            <a:avLst/>
-          </a:prstGeom>
-          <a:ln w="12700">
-            <a:solidFill>
-              <a:srgbClr val="2C4E7D"/>
-            </a:solidFill>
-            <a:prstDash val="solid"/>
-          </a:ln>
-        </p:spPr>
-      </p:sp>
-      <p:sp>
-        <p:nvSpPr>
-          <p:cNvPr id="4" name="Shape 1"/>
-          <p:cNvSpPr/>
-          <p:nvPr/>
-        </p:nvSpPr>
-        <p:spPr>
-          <a:xfrm>
-            <a:off x="8183880" y="45720"/>
-            <a:ext cx="2286000" cy="2286000"/>
-          </a:xfrm>
-          <a:prstGeom prst="ellipse">
-            <a:avLst/>
-          </a:prstGeom>
-          <a:ln w="12700">
-            <a:solidFill>
-              <a:srgbClr val="2C4E7D"/>
-            </a:solidFill>
-            <a:prstDash val="solid"/>
-          </a:ln>
-        </p:spPr>
-      </p:sp>
-      <p:sp>
-        <p:nvSpPr>
-          <p:cNvPr id="5" name="Shape 2"/>
-          <p:cNvSpPr/>
-          <p:nvPr/>
-        </p:nvSpPr>
-        <p:spPr>
-          <a:xfrm>
-            <a:off x="8595360" y="457200"/>
-            <a:ext cx="1463040" cy="1463040"/>
-          </a:xfrm>
-          <a:prstGeom prst="ellipse">
-            <a:avLst/>
-          </a:prstGeom>
-          <a:ln w="25400">
-            <a:solidFill>
-              <a:srgbClr val="42C0FF"/>
-            </a:solidFill>
-            <a:prstDash val="solid"/>
-          </a:ln>
-        </p:spPr>
-      </p:sp>
-      <p:sp>
-        <p:nvSpPr>
-          <p:cNvPr id="6" name="Shape 3"/>
-          <p:cNvSpPr/>
-          <p:nvPr/>
-        </p:nvSpPr>
-        <p:spPr>
-          <a:xfrm>
-            <a:off x="8732520" y="822960"/>
-            <a:ext cx="822960" cy="822960"/>
-          </a:xfrm>
-          <a:prstGeom prst="ellipse">
-            <a:avLst/>
-          </a:prstGeom>
-          <a:solidFill>
-            <a:srgbClr val="42C0FF"/>
-          </a:solidFill>
-          <a:ln/>
-        </p:spPr>
-      </p:sp>
-      <p:sp>
-        <p:nvSpPr>
-          <p:cNvPr id="7" name="Text 4"/>
-          <p:cNvSpPr/>
-          <p:nvPr/>
-        </p:nvSpPr>
-        <p:spPr>
-          <a:xfrm>
-            <a:off x="8732520" y="822960"/>
-            <a:ext cx="822960" cy="822960"/>
-          </a:xfrm>
-          <a:prstGeom prst="rect">
-            <a:avLst/>
-          </a:prstGeom>
-          <a:noFill/>
-          <a:ln/>
-        </p:spPr>
-        <p:txBody>
-          <a:bodyPr wrap="square" lIns="0" tIns="0" rIns="0" bIns="0" rtlCol="0" anchor="ctr"/>
-          <a:lstStyle/>
-          <a:p>
-            <a:pPr algn="ctr" indent="0" marL="0">
-              <a:buNone/>
-            </a:pPr>
-            <a:r>
-              <a:rPr lang="en-US" sz="3000" b="1" dirty="0">
-                <a:solidFill>
-                  <a:srgbClr val="011837"/>
-                </a:solidFill>
-                <a:latin typeface="Poppins" pitchFamily="34" charset="0"/>
-                <a:ea typeface="Poppins" pitchFamily="34" charset="-122"/>
-                <a:cs typeface="Poppins" pitchFamily="34" charset="-120"/>
-              </a:rPr>
-              <a:t>↻</a:t>
-            </a:r>
-            <a:endParaRPr lang="en-US" sz="3000" dirty="0"/>
-          </a:p>
-        </p:txBody>
-      </p:sp>
-      <p:sp>
-        <p:nvSpPr>
-          <p:cNvPr id="8" name="Text 5"/>
+      <p:pic>
+        <p:nvPicPr>
+          <p:cNvPr id="3" name="Image 1" descr="gdex_lockup_white.png">    </p:cNvPr>
+          <p:cNvPicPr>
+            <a:picLocks noChangeAspect="1"/>
+          </p:cNvPicPr>
+          <p:nvPr/>
+        </p:nvPicPr>
+        <p:blipFill>
+          <a:blip r:embed="rId2"/>
+          <a:stretch>
+            <a:fillRect/>
+          </a:stretch>
+        </p:blipFill>
+        <p:spPr>
+          <a:xfrm>
+            <a:off x="9905695" y="640080"/>
+            <a:ext cx="1737360" cy="877824"/>
+          </a:xfrm>
+          <a:prstGeom prst="rect">
+            <a:avLst/>
+          </a:prstGeom>
+        </p:spPr>
+      </p:pic>
+      <p:sp>
+        <p:nvSpPr>
+          <p:cNvPr id="4" name="Text 0"/>
           <p:cNvSpPr/>
           <p:nvPr/>
         </p:nvSpPr>
@@ -3290,7 +3189,7 @@
       </p:sp>
       <p:sp>
         <p:nvSpPr>
-          <p:cNvPr id="9" name="Text 6"/>
+          <p:cNvPr id="5" name="Text 1"/>
           <p:cNvSpPr/>
           <p:nvPr/>
         </p:nvSpPr>
@@ -3329,7 +3228,7 @@
       </p:sp>
       <p:sp>
         <p:nvSpPr>
-          <p:cNvPr id="10" name="Text 7"/>
+          <p:cNvPr id="6" name="Text 2"/>
           <p:cNvSpPr/>
           <p:nvPr/>
         </p:nvSpPr>
@@ -3368,7 +3267,7 @@
       </p:sp>
       <p:sp>
         <p:nvSpPr>
-          <p:cNvPr id="11" name="Shape 8"/>
+          <p:cNvPr id="7" name="Shape 3"/>
           <p:cNvSpPr/>
           <p:nvPr/>
         </p:nvSpPr>
@@ -3395,7 +3294,7 @@
       </p:sp>
       <p:sp>
         <p:nvSpPr>
-          <p:cNvPr id="12" name="Text 9"/>
+          <p:cNvPr id="8" name="Text 4"/>
           <p:cNvSpPr/>
           <p:nvPr/>
         </p:nvSpPr>
@@ -3434,7 +3333,7 @@
       </p:sp>
       <p:sp>
         <p:nvSpPr>
-          <p:cNvPr id="13" name="Shape 10"/>
+          <p:cNvPr id="9" name="Shape 5"/>
           <p:cNvSpPr/>
           <p:nvPr/>
         </p:nvSpPr>
@@ -3461,7 +3360,7 @@
       </p:sp>
       <p:sp>
         <p:nvSpPr>
-          <p:cNvPr id="14" name="Text 11"/>
+          <p:cNvPr id="10" name="Text 6"/>
           <p:cNvSpPr/>
           <p:nvPr/>
         </p:nvSpPr>
@@ -3500,7 +3399,7 @@
       </p:sp>
       <p:sp>
         <p:nvSpPr>
-          <p:cNvPr id="15" name="Shape 12"/>
+          <p:cNvPr id="11" name="Shape 7"/>
           <p:cNvSpPr/>
           <p:nvPr/>
         </p:nvSpPr>
@@ -3527,7 +3426,7 @@
       </p:sp>
       <p:sp>
         <p:nvSpPr>
-          <p:cNvPr id="16" name="Text 13"/>
+          <p:cNvPr id="12" name="Text 8"/>
           <p:cNvSpPr/>
           <p:nvPr/>
         </p:nvSpPr>
@@ -3566,7 +3465,7 @@
       </p:sp>
       <p:sp>
         <p:nvSpPr>
-          <p:cNvPr id="17" name="Text 14"/>
+          <p:cNvPr id="13" name="Text 9"/>
           <p:cNvSpPr/>
           <p:nvPr/>
         </p:nvSpPr>
@@ -3619,7 +3518,7 @@
       </p:sp>
       <p:sp>
         <p:nvSpPr>
-          <p:cNvPr id="18" name="Text 15"/>
+          <p:cNvPr id="14" name="Text 10"/>
           <p:cNvSpPr/>
           <p:nvPr/>
         </p:nvSpPr>
@@ -33064,7 +32963,7 @@
                 <a:ea typeface="Poppins" pitchFamily="34" charset="-122"/>
                 <a:cs typeface="Poppins" pitchFamily="34" charset="-120"/>
               </a:rPr>
-              <a:t>Root for working dirs. If set to /lustre/gdex/work, then $UPDTWKP/zji/icoads resolves under it; if unset, -WD is used as given.</a:t>
+              <a:t>Root for working dirs (unset → -WD used as-is). Hourly files sharing a name across days need a date pattern in -WD to keep each workdir/server-file pair unique, e.g. -WD $UPDTWKP/zji/ds084.1/&lt;YYYYMMDD&gt;.</a:t>
             </a:r>
             <a:endParaRPr lang="en-US" sz="1150" dirty="0"/>
           </a:p>
@@ -33760,7 +33659,7 @@
                 <a:ea typeface="Poppins" pitchFamily="34" charset="-122"/>
                 <a:cs typeface="Poppins" pitchFamily="34" charset="-120"/>
               </a:rPr>
-              <a:t>Debug logging via -DB level [path] [file]; default log path $DSSHOME/dssdb/log, file pgdss.dbg.</a:t>
+              <a:t>Debug logging via -DB level [path] [file]; default log path $GDEXHOME/dssdb/log, file pgdss.dbg.</a:t>
             </a:r>
             <a:endParaRPr lang="en-US" sz="1150" dirty="0"/>
           </a:p>
@@ -35108,9 +35007,33 @@
           </a:prstGeom>
         </p:spPr>
       </p:pic>
-      <p:sp>
-        <p:nvSpPr>
-          <p:cNvPr id="3" name="Shape 0"/>
+      <p:pic>
+        <p:nvPicPr>
+          <p:cNvPr id="3" name="Image 1" descr="gdex_lockup_white.png">    </p:cNvPr>
+          <p:cNvPicPr>
+            <a:picLocks noChangeAspect="1"/>
+          </p:cNvPicPr>
+          <p:nvPr/>
+        </p:nvPicPr>
+        <p:blipFill>
+          <a:blip r:embed="rId2"/>
+          <a:stretch>
+            <a:fillRect/>
+          </a:stretch>
+        </p:blipFill>
+        <p:spPr>
+          <a:xfrm>
+            <a:off x="10088575" y="896112"/>
+            <a:ext cx="1737360" cy="877824"/>
+          </a:xfrm>
+          <a:prstGeom prst="rect">
+            <a:avLst/>
+          </a:prstGeom>
+        </p:spPr>
+      </p:pic>
+      <p:sp>
+        <p:nvSpPr>
+          <p:cNvPr id="4" name="Shape 0"/>
           <p:cNvSpPr/>
           <p:nvPr/>
         </p:nvSpPr>
@@ -35132,7 +35055,7 @@
       </p:sp>
       <p:sp>
         <p:nvSpPr>
-          <p:cNvPr id="4" name="Shape 1"/>
+          <p:cNvPr id="5" name="Shape 1"/>
           <p:cNvSpPr/>
           <p:nvPr/>
         </p:nvSpPr>
@@ -35154,7 +35077,7 @@
       </p:sp>
       <p:sp>
         <p:nvSpPr>
-          <p:cNvPr id="5" name="Shape 2"/>
+          <p:cNvPr id="6" name="Shape 2"/>
           <p:cNvSpPr/>
           <p:nvPr/>
         </p:nvSpPr>
@@ -35176,7 +35099,7 @@
       </p:sp>
       <p:sp>
         <p:nvSpPr>
-          <p:cNvPr id="6" name="Text 3"/>
+          <p:cNvPr id="7" name="Text 3"/>
           <p:cNvSpPr/>
           <p:nvPr/>
         </p:nvSpPr>
@@ -35215,7 +35138,7 @@
       </p:sp>
       <p:sp>
         <p:nvSpPr>
-          <p:cNvPr id="7" name="Text 4"/>
+          <p:cNvPr id="8" name="Text 4"/>
           <p:cNvSpPr/>
           <p:nvPr/>
         </p:nvSpPr>
@@ -35254,7 +35177,7 @@
       </p:sp>
       <p:sp>
         <p:nvSpPr>
-          <p:cNvPr id="8" name="Shape 5"/>
+          <p:cNvPr id="9" name="Shape 5"/>
           <p:cNvSpPr/>
           <p:nvPr/>
         </p:nvSpPr>
@@ -35274,7 +35197,7 @@
       </p:sp>
       <p:sp>
         <p:nvSpPr>
-          <p:cNvPr id="9" name="Text 6"/>
+          <p:cNvPr id="10" name="Text 6"/>
           <p:cNvSpPr/>
           <p:nvPr/>
         </p:nvSpPr>
@@ -35313,7 +35236,7 @@
       </p:sp>
       <p:sp>
         <p:nvSpPr>
-          <p:cNvPr id="10" name="Text 7"/>
+          <p:cNvPr id="11" name="Text 7"/>
           <p:cNvSpPr/>
           <p:nvPr/>
         </p:nvSpPr>
@@ -35366,7 +35289,7 @@
       </p:sp>
       <p:sp>
         <p:nvSpPr>
-          <p:cNvPr id="11" name="Shape 8"/>
+          <p:cNvPr id="12" name="Shape 8"/>
           <p:cNvSpPr/>
           <p:nvPr/>
         </p:nvSpPr>
@@ -35386,7 +35309,7 @@
       </p:sp>
       <p:sp>
         <p:nvSpPr>
-          <p:cNvPr id="12" name="Text 9"/>
+          <p:cNvPr id="13" name="Text 9"/>
           <p:cNvSpPr/>
           <p:nvPr/>
         </p:nvSpPr>
@@ -35425,7 +35348,7 @@
       </p:sp>
       <p:sp>
         <p:nvSpPr>
-          <p:cNvPr id="13" name="Text 10"/>
+          <p:cNvPr id="14" name="Text 10"/>
           <p:cNvSpPr/>
           <p:nvPr/>
         </p:nvSpPr>
@@ -35478,7 +35401,7 @@
       </p:sp>
       <p:sp>
         <p:nvSpPr>
-          <p:cNvPr id="14" name="Shape 11"/>
+          <p:cNvPr id="15" name="Shape 11"/>
           <p:cNvSpPr/>
           <p:nvPr/>
         </p:nvSpPr>
@@ -35498,7 +35421,7 @@
       </p:sp>
       <p:sp>
         <p:nvSpPr>
-          <p:cNvPr id="15" name="Text 12"/>
+          <p:cNvPr id="16" name="Text 12"/>
           <p:cNvSpPr/>
           <p:nvPr/>
         </p:nvSpPr>
@@ -35537,7 +35460,7 @@
       </p:sp>
       <p:sp>
         <p:nvSpPr>
-          <p:cNvPr id="16" name="Text 13"/>
+          <p:cNvPr id="17" name="Text 13"/>
           <p:cNvSpPr/>
           <p:nvPr/>
         </p:nvSpPr>
@@ -35590,7 +35513,7 @@
       </p:sp>
       <p:sp>
         <p:nvSpPr>
-          <p:cNvPr id="17" name="Shape 14"/>
+          <p:cNvPr id="18" name="Shape 14"/>
           <p:cNvSpPr/>
           <p:nvPr/>
         </p:nvSpPr>
@@ -35610,7 +35533,7 @@
       </p:sp>
       <p:sp>
         <p:nvSpPr>
-          <p:cNvPr id="18" name="Text 15"/>
+          <p:cNvPr id="19" name="Text 15"/>
           <p:cNvSpPr/>
           <p:nvPr/>
         </p:nvSpPr>
@@ -35649,7 +35572,7 @@
       </p:sp>
       <p:sp>
         <p:nvSpPr>
-          <p:cNvPr id="19" name="Text 16"/>
+          <p:cNvPr id="20" name="Text 16"/>
           <p:cNvSpPr/>
           <p:nvPr/>
         </p:nvSpPr>
@@ -35702,7 +35625,7 @@
       </p:sp>
       <p:sp>
         <p:nvSpPr>
-          <p:cNvPr id="20" name="Shape 17"/>
+          <p:cNvPr id="21" name="Shape 17"/>
           <p:cNvSpPr/>
           <p:nvPr/>
         </p:nvSpPr>
@@ -35729,7 +35652,7 @@
       </p:sp>
       <p:sp>
         <p:nvSpPr>
-          <p:cNvPr id="21" name="Text 18"/>
+          <p:cNvPr id="22" name="Text 18"/>
           <p:cNvSpPr/>
           <p:nvPr/>
         </p:nvSpPr>
@@ -35813,7 +35736,7 @@
                 <a:latin typeface="Poppins" pitchFamily="34" charset="0"/>
                 <a:ea typeface="Poppins" pitchFamily="34" charset="-122"/>
                 <a:cs typeface="Poppins" pitchFamily="34" charset="-120"/>
-                <a:hlinkClick r:id="rId2" invalidUrl="" action="" tgtFrame="" tooltip="" history="1" highlightClick="0" endSnd="0">
+                <a:hlinkClick r:id="rId3" invalidUrl="" action="" tgtFrame="" tooltip="" history="1" highlightClick="0" endSnd="0">
                   <a:extLst>
                     <a:ext uri="{A12FA001-AC4F-418D-AE19-62706E023703}">
                       <ahyp:hlinkClr xmlns:ahyp="http://schemas.microsoft.com/office/drawing/2018/hyperlinkcolor" val="tx"/>
@@ -35854,7 +35777,7 @@
                 <a:latin typeface="Poppins" pitchFamily="34" charset="0"/>
                 <a:ea typeface="Poppins" pitchFamily="34" charset="-122"/>
                 <a:cs typeface="Poppins" pitchFamily="34" charset="-120"/>
-                <a:hlinkClick r:id="rId3" invalidUrl="" action="" tgtFrame="" tooltip="" history="1" highlightClick="0" endSnd="0">
+                <a:hlinkClick r:id="rId4" invalidUrl="" action="" tgtFrame="" tooltip="" history="1" highlightClick="0" endSnd="0">
                   <a:extLst>
                     <a:ext uri="{A12FA001-AC4F-418D-AE19-62706E023703}">
                       <ahyp:hlinkClr xmlns:ahyp="http://schemas.microsoft.com/office/drawing/2018/hyperlinkcolor" val="tx"/>
@@ -35924,9 +35847,33 @@
           </a:prstGeom>
         </p:spPr>
       </p:pic>
-      <p:sp>
-        <p:nvSpPr>
-          <p:cNvPr id="3" name="Shape 0"/>
+      <p:pic>
+        <p:nvPicPr>
+          <p:cNvPr id="3" name="Image 1" descr="gdex_lockup_white.png">    </p:cNvPr>
+          <p:cNvPicPr>
+            <a:picLocks noChangeAspect="1"/>
+          </p:cNvPicPr>
+          <p:nvPr/>
+        </p:nvPicPr>
+        <p:blipFill>
+          <a:blip r:embed="rId2"/>
+          <a:stretch>
+            <a:fillRect/>
+          </a:stretch>
+        </p:blipFill>
+        <p:spPr>
+          <a:xfrm>
+            <a:off x="10088575" y="896112"/>
+            <a:ext cx="1737360" cy="877824"/>
+          </a:xfrm>
+          <a:prstGeom prst="rect">
+            <a:avLst/>
+          </a:prstGeom>
+        </p:spPr>
+      </p:pic>
+      <p:sp>
+        <p:nvSpPr>
+          <p:cNvPr id="4" name="Shape 0"/>
           <p:cNvSpPr/>
           <p:nvPr/>
         </p:nvSpPr>
@@ -35948,7 +35895,7 @@
       </p:sp>
       <p:sp>
         <p:nvSpPr>
-          <p:cNvPr id="4" name="Shape 1"/>
+          <p:cNvPr id="5" name="Shape 1"/>
           <p:cNvSpPr/>
           <p:nvPr/>
         </p:nvSpPr>
@@ -35970,7 +35917,7 @@
       </p:sp>
       <p:sp>
         <p:nvSpPr>
-          <p:cNvPr id="5" name="Shape 2"/>
+          <p:cNvPr id="6" name="Shape 2"/>
           <p:cNvSpPr/>
           <p:nvPr/>
         </p:nvSpPr>
@@ -35992,7 +35939,7 @@
       </p:sp>
       <p:sp>
         <p:nvSpPr>
-          <p:cNvPr id="6" name="Shape 3"/>
+          <p:cNvPr id="7" name="Shape 3"/>
           <p:cNvSpPr/>
           <p:nvPr/>
         </p:nvSpPr>
@@ -36012,7 +35959,7 @@
       </p:sp>
       <p:sp>
         <p:nvSpPr>
-          <p:cNvPr id="7" name="Text 4"/>
+          <p:cNvPr id="8" name="Text 4"/>
           <p:cNvSpPr/>
           <p:nvPr/>
         </p:nvSpPr>
@@ -36051,7 +35998,7 @@
       </p:sp>
       <p:sp>
         <p:nvSpPr>
-          <p:cNvPr id="8" name="Text 5"/>
+          <p:cNvPr id="9" name="Text 5"/>
           <p:cNvSpPr/>
           <p:nvPr/>
         </p:nvSpPr>
@@ -36090,7 +36037,7 @@
       </p:sp>
       <p:sp>
         <p:nvSpPr>
-          <p:cNvPr id="9" name="Text 6"/>
+          <p:cNvPr id="10" name="Text 6"/>
           <p:cNvSpPr/>
           <p:nvPr/>
         </p:nvSpPr>
@@ -36129,7 +36076,7 @@
       </p:sp>
       <p:sp>
         <p:nvSpPr>
-          <p:cNvPr id="10" name="Shape 7"/>
+          <p:cNvPr id="11" name="Shape 7"/>
           <p:cNvSpPr/>
           <p:nvPr/>
         </p:nvSpPr>
@@ -36156,7 +36103,7 @@
       </p:sp>
       <p:sp>
         <p:nvSpPr>
-          <p:cNvPr id="11" name="Text 8"/>
+          <p:cNvPr id="12" name="Text 8"/>
           <p:cNvSpPr/>
           <p:nvPr/>
         </p:nvSpPr>
@@ -36214,7 +36161,7 @@
                 <a:latin typeface="Poppins" pitchFamily="34" charset="0"/>
                 <a:ea typeface="Poppins" pitchFamily="34" charset="-122"/>
                 <a:cs typeface="Poppins" pitchFamily="34" charset="-120"/>
-                <a:hlinkClick r:id="rId2" invalidUrl="" action="" tgtFrame="" tooltip="" history="1" highlightClick="0" endSnd="0">
+                <a:hlinkClick r:id="rId3" invalidUrl="" action="" tgtFrame="" tooltip="" history="1" highlightClick="0" endSnd="0">
                   <a:extLst>
                     <a:ext uri="{A12FA001-AC4F-418D-AE19-62706E023703}">
                       <ahyp:hlinkClr xmlns:ahyp="http://schemas.microsoft.com/office/drawing/2018/hyperlinkcolor" val="tx"/>

</xml_diff>

<commit_message>
deck: update email-report example slide for repeated-error and >4-file compaction
Replace the stale hand-written ellipsis DETAIL example with the real
compacted archive-summary line (new/changed/used tally + gatherxml
failure count), and add a "N similar errors" example to the ERROR
MESSAGE section, matching the compaction actually implemented in
dsupdt.py.
</commit_message>
<xml_diff>
--- a/docs/slides/dsupdt_guide.pptx
+++ b/docs/slides/dsupdt_guide.pptx
@@ -30221,7 +30221,7 @@
                 <a:ea typeface="Courier New" pitchFamily="34" charset="-122"/>
                 <a:cs typeface="Courier New" pitchFamily="34" charset="-120"/>
               </a:rPr>
-              <a:t>Subject: 4 local files archived for</a:t>
+              <a:t>Subject: 6 local files archived for</a:t>
             </a:r>
             <a:endParaRPr lang="en-US" sz="960" dirty="0"/>
           </a:p>
@@ -30301,7 +30301,7 @@
                 <a:ea typeface="Courier New" pitchFamily="34" charset="-122"/>
                 <a:cs typeface="Courier New" pitchFamily="34" charset="-120"/>
               </a:rPr>
-              <a:t>Failed Metadata Summaring: d609000</a:t>
+              <a:t>2 similar errors:</a:t>
             </a:r>
             <a:endParaRPr lang="en-US" sz="960" dirty="0"/>
           </a:p>
@@ -30321,7 +30321,7 @@
                 <a:ea typeface="Courier New" pitchFamily="34" charset="-122"/>
                 <a:cs typeface="Courier New" pitchFamily="34" charset="-120"/>
               </a:rPr>
-              <a:t>  scm: connection timed out to metadata DB</a:t>
+              <a:t>  - Failed Metadata Gathering: …t18z…grib2</a:t>
             </a:r>
             <a:endParaRPr lang="en-US" sz="960" dirty="0"/>
           </a:p>
@@ -30341,7 +30341,7 @@
                 <a:ea typeface="Courier New" pitchFamily="34" charset="-122"/>
                 <a:cs typeface="Courier New" pitchFamily="34" charset="-120"/>
               </a:rPr>
-              <a:t> </a:t>
+              <a:t>  - Failed Metadata Gathering: …t00z…grib2</a:t>
             </a:r>
             <a:endParaRPr lang="en-US" sz="960" dirty="0"/>
           </a:p>
@@ -30353,15 +30353,15 @@
               <a:buNone/>
             </a:pPr>
             <a:r>
-              <a:rPr lang="en-US" sz="960" b="1" dirty="0">
-                <a:solidFill>
-                  <a:srgbClr val="42C0FF"/>
+              <a:rPr lang="en-US" sz="960" dirty="0">
+                <a:solidFill>
+                  <a:srgbClr val="9AB6D6"/>
                 </a:solidFill>
                 <a:latin typeface="Courier New" pitchFamily="34" charset="0"/>
                 <a:ea typeface="Courier New" pitchFamily="34" charset="-122"/>
                 <a:cs typeface="Courier New" pitchFamily="34" charset="-120"/>
               </a:rPr>
-              <a:t>SUMMARY:</a:t>
+              <a:t>  gatherxml: connection timed out to metadata DB</a:t>
             </a:r>
             <a:endParaRPr lang="en-US" sz="960" dirty="0"/>
           </a:p>
@@ -30375,13 +30375,13 @@
             <a:r>
               <a:rPr lang="en-US" sz="960" dirty="0">
                 <a:solidFill>
-                  <a:srgbClr val="E6EEF8"/>
+                  <a:srgbClr val="9AB6D6"/>
                 </a:solidFill>
                 <a:latin typeface="Courier New" pitchFamily="34" charset="0"/>
                 <a:ea typeface="Courier New" pitchFamily="34" charset="-122"/>
                 <a:cs typeface="Courier New" pitchFamily="34" charset="-120"/>
               </a:rPr>
-              <a:t>d609000: 4 of 16 local files ARCHIVED(AW) for</a:t>
+              <a:t> </a:t>
             </a:r>
             <a:endParaRPr lang="en-US" sz="960" dirty="0"/>
           </a:p>
@@ -30393,15 +30393,15 @@
               <a:buNone/>
             </a:pPr>
             <a:r>
-              <a:rPr lang="en-US" sz="960" dirty="0">
-                <a:solidFill>
-                  <a:srgbClr val="9AB6D6"/>
+              <a:rPr lang="en-US" sz="960" b="1" dirty="0">
+                <a:solidFill>
+                  <a:srgbClr val="42C0FF"/>
                 </a:solidFill>
                 <a:latin typeface="Courier New" pitchFamily="34" charset="0"/>
                 <a:ea typeface="Courier New" pitchFamily="34" charset="-122"/>
                 <a:cs typeface="Courier New" pitchFamily="34" charset="-120"/>
               </a:rPr>
-              <a:t>  [2026-07-16:12(UTC) .. 2026-07-17:06(UTC)]</a:t>
+              <a:t>SUMMARY:</a:t>
             </a:r>
             <a:endParaRPr lang="en-US" sz="960" dirty="0"/>
           </a:p>
@@ -30415,13 +30415,13 @@
             <a:r>
               <a:rPr lang="en-US" sz="960" dirty="0">
                 <a:solidFill>
-                  <a:srgbClr val="9AB6D6"/>
+                  <a:srgbClr val="E6EEF8"/>
                 </a:solidFill>
                 <a:latin typeface="Courier New" pitchFamily="34" charset="0"/>
                 <a:ea typeface="Courier New" pitchFamily="34" charset="-122"/>
                 <a:cs typeface="Courier New" pitchFamily="34" charset="-120"/>
               </a:rPr>
-              <a:t> </a:t>
+              <a:t>d609000: 6 of 18 local files ARCHIVED(AW) for</a:t>
             </a:r>
             <a:endParaRPr lang="en-US" sz="960" dirty="0"/>
           </a:p>
@@ -30433,15 +30433,15 @@
               <a:buNone/>
             </a:pPr>
             <a:r>
-              <a:rPr lang="en-US" sz="960" b="1" dirty="0">
-                <a:solidFill>
-                  <a:srgbClr val="42C0FF"/>
+              <a:rPr lang="en-US" sz="960" dirty="0">
+                <a:solidFill>
+                  <a:srgbClr val="9AB6D6"/>
                 </a:solidFill>
                 <a:latin typeface="Courier New" pitchFamily="34" charset="0"/>
                 <a:ea typeface="Courier New" pitchFamily="34" charset="-122"/>
                 <a:cs typeface="Courier New" pitchFamily="34" charset="-120"/>
               </a:rPr>
-              <a:t>DETAIL INFORMATION:</a:t>
+              <a:t>  [2026-07-16:12(UTC) .. 2026-07-17:06(UTC)]</a:t>
             </a:r>
             <a:endParaRPr lang="en-US" sz="960" dirty="0"/>
           </a:p>
@@ -30461,7 +30461,7 @@
                 <a:ea typeface="Courier New" pitchFamily="34" charset="-122"/>
                 <a:cs typeface="Courier New" pitchFamily="34" charset="-120"/>
               </a:rPr>
-              <a:t>d609000-L480: 12 update periods UNCHANGED</a:t>
+              <a:t> </a:t>
             </a:r>
             <a:endParaRPr lang="en-US" sz="960" dirty="0"/>
           </a:p>
@@ -30473,15 +30473,15 @@
               <a:buNone/>
             </a:pPr>
             <a:r>
-              <a:rPr lang="en-US" sz="960" dirty="0">
-                <a:solidFill>
-                  <a:srgbClr val="9AB6D6"/>
+              <a:rPr lang="en-US" sz="960" b="1" dirty="0">
+                <a:solidFill>
+                  <a:srgbClr val="42C0FF"/>
                 </a:solidFill>
                 <a:latin typeface="Courier New" pitchFamily="34" charset="0"/>
                 <a:ea typeface="Courier New" pitchFamily="34" charset="-122"/>
                 <a:cs typeface="Courier New" pitchFamily="34" charset="-120"/>
               </a:rPr>
-              <a:t>  [..07-13:12(UTC) .. 07-16:06(UTC)] already archived</a:t>
+              <a:t>DETAIL INFORMATION:</a:t>
             </a:r>
             <a:endParaRPr lang="en-US" sz="960" dirty="0"/>
           </a:p>
@@ -30501,7 +30501,7 @@
                 <a:ea typeface="Courier New" pitchFamily="34" charset="-122"/>
                 <a:cs typeface="Courier New" pitchFamily="34" charset="-120"/>
               </a:rPr>
-              <a:t> </a:t>
+              <a:t>d609000-L480: 12 update periods UNCHANGED</a:t>
             </a:r>
             <a:endParaRPr lang="en-US" sz="960" dirty="0"/>
           </a:p>
@@ -30513,15 +30513,15 @@
               <a:buNone/>
             </a:pPr>
             <a:r>
-              <a:rPr lang="en-US" sz="960" b="1" dirty="0">
-                <a:solidFill>
-                  <a:srgbClr val="FAA119"/>
+              <a:rPr lang="en-US" sz="960" dirty="0">
+                <a:solidFill>
+                  <a:srgbClr val="9AB6D6"/>
                 </a:solidFill>
                 <a:latin typeface="Courier New" pitchFamily="34" charset="0"/>
                 <a:ea typeface="Courier New" pitchFamily="34" charset="-122"/>
                 <a:cs typeface="Courier New" pitchFamily="34" charset="-120"/>
               </a:rPr>
-              <a:t>d609000-R329-20260716.nam.t12z…grib2: got new file</a:t>
+              <a:t>  [..07-13:12(UTC) .. 07-16:06(UTC)] already archived</a:t>
             </a:r>
             <a:endParaRPr lang="en-US" sz="960" dirty="0"/>
           </a:p>
@@ -30535,13 +30535,13 @@
             <a:r>
               <a:rPr lang="en-US" sz="960" dirty="0">
                 <a:solidFill>
-                  <a:srgbClr val="7FD1A6"/>
+                  <a:srgbClr val="9AB6D6"/>
                 </a:solidFill>
                 <a:latin typeface="Courier New" pitchFamily="34" charset="0"/>
                 <a:ea typeface="Courier New" pitchFamily="34" charset="-122"/>
                 <a:cs typeface="Courier New" pitchFamily="34" charset="-120"/>
               </a:rPr>
-              <a:t>d609000-L480-20260716.nam.t12z…grib2:</a:t>
+              <a:t> </a:t>
             </a:r>
             <a:endParaRPr lang="en-US" sz="960" dirty="0"/>
           </a:p>
@@ -30553,7 +30553,7 @@
               <a:buNone/>
             </a:pPr>
             <a:r>
-              <a:rPr lang="en-US" sz="960" dirty="0">
+              <a:rPr lang="en-US" sz="960" b="1" dirty="0">
                 <a:solidFill>
                   <a:srgbClr val="7FD1A6"/>
                 </a:solidFill>
@@ -30561,7 +30561,7 @@
                 <a:ea typeface="Courier New" pitchFamily="34" charset="-122"/>
                 <a:cs typeface="Courier New" pitchFamily="34" charset="-120"/>
               </a:rPr>
-              <a:t>   ARCHIVED(AW) for …07-16:12(UTC) - Metadata Gathered</a:t>
+              <a:t>d609000-L480: 6 files ARCHIVED(AW) for</a:t>
             </a:r>
             <a:endParaRPr lang="en-US" sz="960" dirty="0"/>
           </a:p>
@@ -30575,13 +30575,13 @@
             <a:r>
               <a:rPr lang="en-US" sz="960" dirty="0">
                 <a:solidFill>
-                  <a:srgbClr val="9AB6D6"/>
+                  <a:srgbClr val="7FD1A6"/>
                 </a:solidFill>
                 <a:latin typeface="Courier New" pitchFamily="34" charset="0"/>
                 <a:ea typeface="Courier New" pitchFamily="34" charset="-122"/>
                 <a:cs typeface="Courier New" pitchFamily="34" charset="-120"/>
               </a:rPr>
-              <a:t>   … t18z, t00z, t06z (3 more archived) …</a:t>
+              <a:t>  07-16:12(UTC) - 4 new, 2 changed</a:t>
             </a:r>
             <a:endParaRPr lang="en-US" sz="960" dirty="0"/>
           </a:p>
@@ -30595,13 +30595,13 @@
             <a:r>
               <a:rPr lang="en-US" sz="960" dirty="0">
                 <a:solidFill>
-                  <a:srgbClr val="9AB6D6"/>
+                  <a:srgbClr val="7FD1A6"/>
                 </a:solidFill>
                 <a:latin typeface="Courier New" pitchFamily="34" charset="0"/>
                 <a:ea typeface="Courier New" pitchFamily="34" charset="-122"/>
                 <a:cs typeface="Courier New" pitchFamily="34" charset="-120"/>
               </a:rPr>
-              <a:t> </a:t>
+              <a:t>  - 2 Failed Metadata Gathering</a:t>
             </a:r>
             <a:endParaRPr lang="en-US" sz="960" dirty="0"/>
           </a:p>
@@ -30615,13 +30615,13 @@
             <a:r>
               <a:rPr lang="en-US" sz="960" dirty="0">
                 <a:solidFill>
-                  <a:srgbClr val="FF8A80"/>
+                  <a:srgbClr val="9AB6D6"/>
                 </a:solidFill>
                 <a:latin typeface="Courier New" pitchFamily="34" charset="0"/>
                 <a:ea typeface="Courier New" pitchFamily="34" charset="-122"/>
                 <a:cs typeface="Courier New" pitchFamily="34" charset="-120"/>
               </a:rPr>
-              <a:t>d609000: Failed Metadata Summaring</a:t>
+              <a:t> </a:t>
             </a:r>
             <a:endParaRPr lang="en-US" sz="960" dirty="0"/>
           </a:p>
@@ -30641,7 +30641,7 @@
                 <a:ea typeface="Courier New" pitchFamily="34" charset="-122"/>
                 <a:cs typeface="Courier New" pitchFamily="34" charset="-120"/>
               </a:rPr>
-              <a:t>d609000-C57: Next Control Time 2026-07-18 03:00:00</a:t>
+              <a:t>d609000-C57: Next Control Time 2026-07-17 03:00:00</a:t>
             </a:r>
             <a:endParaRPr lang="en-US" sz="960" dirty="0"/>
           </a:p>
@@ -30896,7 +30896,7 @@
                 <a:ea typeface="Poppins" pitchFamily="34" charset="-122"/>
                 <a:cs typeface="Poppins" pitchFamily="34" charset="-120"/>
               </a:rPr>
-              <a:t>raw failures, prefixed with the failing target; shown in every mode.</a:t>
+              <a:t>identical repeated failures merge into one “N similar errors” block.</a:t>
             </a:r>
             <a:endParaRPr lang="en-US" sz="1050" dirty="0"/>
           </a:p>
@@ -31203,7 +31203,7 @@
                 <a:ea typeface="Poppins" pitchFamily="34" charset="-122"/>
                 <a:cs typeface="Poppins" pitchFamily="34" charset="-120"/>
               </a:rPr>
-              <a:t>R-line  </a:t>
+              <a:t>&gt;4 files  </a:t>
             </a:r>
             <a:pPr indent="0" marL="0">
               <a:lnSpc>
@@ -31220,7 +31220,7 @@
                 <a:ea typeface="Poppins" pitchFamily="34" charset="-122"/>
                 <a:cs typeface="Poppins" pitchFamily="34" charset="-120"/>
               </a:rPr>
-              <a:t>d609000-R&lt;n&gt;-&lt;remote file&gt;: per-remote-record source status.</a:t>
+              <a:t>more than 4 archived files in one period roll into one summary line with a new/changed/used tally.</a:t>
             </a:r>
             <a:endParaRPr lang="en-US" sz="1050" dirty="0"/>
           </a:p>

</xml_diff>